<commit_message>
docs: restructure one-page reference scheme into layered narrative
Co-authored-by: Lizzy67 <Lizzy67@users.noreply.github.com>
</commit_message>
<xml_diff>
--- a/docs/tool_param_ref_onepage.pptx
+++ b/docs/tool_param_ref_onepage.pptx
@@ -3139,8 +3139,8 @@
         </p:nvSpPr>
         <p:spPr>
           <a:xfrm>
-            <a:off x="320040" y="164592"/>
-            <a:ext cx="6949440" cy="292608"/>
+            <a:off x="320040" y="137160"/>
+            <a:ext cx="6400800" cy="310896"/>
           </a:xfrm>
           <a:prstGeom prst="rect">
             <a:avLst/>
@@ -3173,8 +3173,8 @@
         </p:nvSpPr>
         <p:spPr>
           <a:xfrm>
-            <a:off x="320040" y="475488"/>
-            <a:ext cx="7498079" cy="219456"/>
+            <a:off x="6858000" y="201168"/>
+            <a:ext cx="4983480" cy="274320"/>
           </a:xfrm>
           <a:prstGeom prst="rect">
             <a:avLst/>
@@ -3188,61 +3188,27 @@
           <a:lstStyle/>
           <a:p>
             <a:r>
-              <a:rPr sz="880" b="0">
+              <a:rPr sz="840" b="0">
                 <a:solidFill>
                   <a:srgbClr val="60706A"/>
                 </a:solidFill>
                 <a:latin typeface="Microsoft YaHei"/>
               </a:rPr>
-              <a:t>模型表达“引用谁” · Runtime负责“取真值、做转换、再调用” · 工具零改动</a:t>
-            </a:r>
-          </a:p>
-        </p:txBody>
-      </p:sp>
-      <p:sp>
-        <p:nvSpPr>
-          <p:cNvPr id="5" name="TextBox 4"/>
-          <p:cNvSpPr txBox="1"/>
-          <p:nvPr/>
-        </p:nvSpPr>
-        <p:spPr>
-          <a:xfrm>
-            <a:off x="7726679" y="228600"/>
-            <a:ext cx="4114800" cy="310896"/>
-          </a:xfrm>
-          <a:prstGeom prst="rect">
-            <a:avLst/>
-          </a:prstGeom>
-          <a:noFill/>
-        </p:spPr>
-        <p:txBody>
-          <a:bodyPr wrap="square" lIns="0" rIns="0" tIns="0" bIns="0">
-            <a:spAutoFit/>
-          </a:bodyPr>
-          <a:lstStyle/>
-          <a:p>
-            <a:r>
-              <a:rPr sz="819" b="0">
-                <a:solidFill>
-                  <a:srgbClr val="60706A"/>
-                </a:solidFill>
-                <a:latin typeface="Microsoft YaHei"/>
-              </a:rPr>
-              <a:t>结果引用  ${resultId.path}    语义引用  ${namespace.entity.attribute}</a:t>
-            </a:r>
-          </a:p>
-        </p:txBody>
-      </p:sp>
-      <p:sp>
-        <p:nvSpPr>
-          <p:cNvPr id="6" name="Rectangle 5"/>
+              <a:t>结果引用 ${resultId.path}    语义引用 ${namespace.entity.attribute}</a:t>
+            </a:r>
+          </a:p>
+        </p:txBody>
+      </p:sp>
+      <p:sp>
+        <p:nvSpPr>
+          <p:cNvPr id="5" name="Rectangle 4"/>
           <p:cNvSpPr/>
           <p:nvPr/>
         </p:nvSpPr>
         <p:spPr>
           <a:xfrm>
-            <a:off x="320040" y="749808"/>
-            <a:ext cx="11548872" cy="36576"/>
+            <a:off x="320040" y="512064"/>
+            <a:ext cx="11548872" cy="32004"/>
           </a:xfrm>
           <a:prstGeom prst="rect">
             <a:avLst/>
@@ -3250,7 +3216,7 @@
           <a:solidFill>
             <a:srgbClr val="0F766E"/>
           </a:solidFill>
-          <a:ln>
+          <a:ln w="6350">
             <a:noFill/>
           </a:ln>
         </p:spPr>
@@ -3278,24 +3244,24 @@
       </p:sp>
       <p:sp>
         <p:nvSpPr>
-          <p:cNvPr id="7" name="Rounded Rectangle 6"/>
+          <p:cNvPr id="6" name="Rounded Rectangle 5"/>
           <p:cNvSpPr/>
           <p:nvPr/>
         </p:nvSpPr>
         <p:spPr>
           <a:xfrm>
-            <a:off x="320040" y="896112"/>
-            <a:ext cx="3429000" cy="987552"/>
+            <a:off x="320040" y="640080"/>
+            <a:ext cx="5623560" cy="1024128"/>
           </a:xfrm>
           <a:prstGeom prst="roundRect">
             <a:avLst/>
           </a:prstGeom>
           <a:solidFill>
-            <a:srgbClr val="ECF8F4"/>
+            <a:srgbClr val="FFF0F3"/>
           </a:solidFill>
           <a:ln w="12700">
             <a:solidFill>
-              <a:srgbClr val="CFDBD5"/>
+              <a:srgbClr val="E7C4CC"/>
             </a:solidFill>
           </a:ln>
         </p:spPr>
@@ -3323,14 +3289,14 @@
       </p:sp>
       <p:sp>
         <p:nvSpPr>
-          <p:cNvPr id="8" name="TextBox 7"/>
+          <p:cNvPr id="7" name="TextBox 6"/>
           <p:cNvSpPr txBox="1"/>
           <p:nvPr/>
         </p:nvSpPr>
         <p:spPr>
           <a:xfrm>
-            <a:off x="429768" y="969264"/>
-            <a:ext cx="3209544" cy="841248"/>
+            <a:off x="429768" y="694944"/>
+            <a:ext cx="5440680" cy="201168"/>
           </a:xfrm>
           <a:prstGeom prst="rect">
             <a:avLst/>
@@ -3338,19 +3304,19 @@
           <a:noFill/>
         </p:spPr>
         <p:txBody>
-          <a:bodyPr wrap="square" lIns="45720" rIns="45720">
+          <a:bodyPr wrap="square" lIns="0" rIns="0" tIns="0" bIns="0">
             <a:spAutoFit/>
           </a:bodyPr>
           <a:lstStyle/>
           <a:p>
             <a:r>
-              <a:rPr sz="1100" b="1">
-                <a:solidFill>
-                  <a:srgbClr val="115E59"/>
-                </a:solidFill>
-                <a:latin typeface="Microsoft YaHei"/>
-              </a:rPr>
-              <a:t>为什么需要</a:t>
+              <a:rPr sz="1050" b="1">
+                <a:solidFill>
+                  <a:srgbClr val="8B3144"/>
+                </a:solidFill>
+                <a:latin typeface="Microsoft YaHei"/>
+              </a:rPr>
+              <a:t>问题：模型直接生成业务真值不可靠</a:t>
             </a:r>
           </a:p>
           <a:p>
@@ -3360,13 +3326,13 @@
               </a:spcAft>
             </a:pPr>
             <a:r>
-              <a:rPr sz="850" b="0">
+              <a:rPr sz="819" b="0">
                 <a:solidFill>
                   <a:srgbClr val="15231F"/>
                 </a:solidFill>
                 <a:latin typeface="Microsoft YaHei"/>
               </a:rPr>
-              <a:t>• 长URI/列表照抄：Token高、易截断改写</a:t>
+              <a:t>• 抄不准：长URI/列表照抄易截断改写，Token高</a:t>
             </a:r>
           </a:p>
           <a:p>
@@ -3376,13 +3342,13 @@
               </a:spcAft>
             </a:pPr>
             <a:r>
-              <a:rPr sz="850" b="0">
+              <a:rPr sz="819" b="0">
                 <a:solidFill>
                   <a:srgbClr val="15231F"/>
                 </a:solidFill>
                 <a:latin typeface="Microsoft YaHei"/>
               </a:rPr>
-              <a:t>• 包名等弱语义标识：模型易凭记忆编造</a:t>
+              <a:t>• 会编造：包名等弱语义标识凭记忆幻觉</a:t>
             </a:r>
           </a:p>
           <a:p>
@@ -3392,13 +3358,47 @@
               </a:spcAft>
             </a:pPr>
             <a:r>
-              <a:rPr sz="850" b="0">
+              <a:rPr sz="819" b="0">
                 <a:solidFill>
                   <a:srgbClr val="15231F"/>
                 </a:solidFill>
                 <a:latin typeface="Microsoft YaHei"/>
               </a:rPr>
-              <a:t>• 上下游Schema不同：模型改长JSON不稳定</a:t>
+              <a:t>• 改不动：上下游Schema不同，改长JSON不稳、改工具成本高</a:t>
+            </a:r>
+          </a:p>
+        </p:txBody>
+      </p:sp>
+      <p:sp>
+        <p:nvSpPr>
+          <p:cNvPr id="8" name="TextBox 7"/>
+          <p:cNvSpPr txBox="1"/>
+          <p:nvPr/>
+        </p:nvSpPr>
+        <p:spPr>
+          <a:xfrm>
+            <a:off x="5961888" y="987552"/>
+            <a:ext cx="310896" cy="329184"/>
+          </a:xfrm>
+          <a:prstGeom prst="rect">
+            <a:avLst/>
+          </a:prstGeom>
+          <a:noFill/>
+        </p:spPr>
+        <p:txBody>
+          <a:bodyPr wrap="square" lIns="0" rIns="0" tIns="0" bIns="0">
+            <a:spAutoFit/>
+          </a:bodyPr>
+          <a:lstStyle/>
+          <a:p>
+            <a:r>
+              <a:rPr sz="1800" b="1">
+                <a:solidFill>
+                  <a:srgbClr val="0F766E"/>
+                </a:solidFill>
+                <a:latin typeface="Microsoft YaHei"/>
+              </a:rPr>
+              <a:t>→</a:t>
             </a:r>
           </a:p>
         </p:txBody>
@@ -3411,18 +3411,18 @@
         </p:nvSpPr>
         <p:spPr>
           <a:xfrm>
-            <a:off x="3858768" y="896112"/>
-            <a:ext cx="4572000" cy="987552"/>
+            <a:off x="6291072" y="640080"/>
+            <a:ext cx="5577840" cy="1024128"/>
           </a:xfrm>
           <a:prstGeom prst="roundRect">
             <a:avLst/>
           </a:prstGeom>
           <a:solidFill>
-            <a:srgbClr val="EDF4FC"/>
+            <a:srgbClr val="ECF8F4"/>
           </a:solidFill>
           <a:ln w="12700">
             <a:solidFill>
-              <a:srgbClr val="CFDBD5"/>
+              <a:srgbClr val="BCDED4"/>
             </a:solidFill>
           </a:ln>
         </p:spPr>
@@ -3456,8 +3456,8 @@
         </p:nvSpPr>
         <p:spPr>
           <a:xfrm>
-            <a:off x="3968496" y="969264"/>
-            <a:ext cx="4352544" cy="841248"/>
+            <a:off x="6400800" y="694944"/>
+            <a:ext cx="5394960" cy="201168"/>
           </a:xfrm>
           <a:prstGeom prst="rect">
             <a:avLst/>
@@ -3465,19 +3465,19 @@
           <a:noFill/>
         </p:spPr>
         <p:txBody>
-          <a:bodyPr wrap="square" lIns="45720" rIns="45720">
+          <a:bodyPr wrap="square" lIns="0" rIns="0" tIns="0" bIns="0">
             <a:spAutoFit/>
           </a:bodyPr>
           <a:lstStyle/>
           <a:p>
             <a:r>
-              <a:rPr sz="1100" b="1">
+              <a:rPr sz="1050" b="1">
                 <a:solidFill>
                   <a:srgbClr val="115E59"/>
                 </a:solidFill>
                 <a:latin typeface="Microsoft YaHei"/>
               </a:rPr>
-              <a:t>核心原则</a:t>
+              <a:t>核心思路：职责分离</a:t>
             </a:r>
           </a:p>
           <a:p>
@@ -3487,13 +3487,13 @@
               </a:spcAft>
             </a:pPr>
             <a:r>
-              <a:rPr sz="850" b="0">
+              <a:rPr sz="880" b="1">
                 <a:solidFill>
                   <a:srgbClr val="15231F"/>
                 </a:solidFill>
                 <a:latin typeface="Microsoft YaHei"/>
               </a:rPr>
-              <a:t>• 模型只输出引用意图，业务真值来自工作记忆/语义词典</a:t>
+              <a:t>模型只表达“引用谁”，Runtime负责“取真值、做适配、保合法”</a:t>
             </a:r>
           </a:p>
           <a:p>
@@ -3503,13 +3503,13 @@
               </a:spcAft>
             </a:pPr>
             <a:r>
-              <a:rPr sz="850" b="0">
+              <a:rPr sz="819" b="0">
                 <a:solidFill>
                   <a:srgbClr val="15231F"/>
                 </a:solidFill>
                 <a:latin typeface="Microsoft YaHei"/>
               </a:rPr>
-              <a:t>• 统一Pre-call流水线：求值 → 转换 → 校验 → 调工具</a:t>
+              <a:t>• 真值只来自可信数据源（工作记忆 / 语义词典）</a:t>
             </a:r>
           </a:p>
           <a:p>
@@ -3519,13 +3519,13 @@
               </a:spcAft>
             </a:pPr>
             <a:r>
-              <a:rPr sz="850" b="0">
+              <a:rPr sz="819" b="0">
                 <a:solidFill>
                   <a:srgbClr val="15231F"/>
                 </a:solidFill>
                 <a:latin typeface="Microsoft YaHei"/>
               </a:rPr>
-              <a:t>• 存量工具继续接收原有真实参数，对引用协议无感</a:t>
+              <a:t>• 全部处理收敛在工具执行前统一入口，工具零改动</a:t>
             </a:r>
           </a:p>
         </p:txBody>
@@ -3538,18 +3538,18 @@
         </p:nvSpPr>
         <p:spPr>
           <a:xfrm>
-            <a:off x="8540496" y="896112"/>
-            <a:ext cx="3328416" cy="987552"/>
+            <a:off x="320040" y="1773936"/>
+            <a:ext cx="11548872" cy="1481328"/>
           </a:xfrm>
           <a:prstGeom prst="roundRect">
             <a:avLst/>
           </a:prstGeom>
           <a:solidFill>
-            <a:srgbClr val="FFF7E4"/>
+            <a:srgbClr val="F5FBF8"/>
           </a:solidFill>
-          <a:ln w="12700">
+          <a:ln w="15240">
             <a:solidFill>
-              <a:srgbClr val="CFDBD5"/>
+              <a:srgbClr val="0F766E"/>
             </a:solidFill>
           </a:ln>
         </p:spPr>
@@ -3583,90 +3583,8 @@
         </p:nvSpPr>
         <p:spPr>
           <a:xfrm>
-            <a:off x="8650224" y="969264"/>
-            <a:ext cx="3108960" cy="841248"/>
-          </a:xfrm>
-          <a:prstGeom prst="rect">
-            <a:avLst/>
-          </a:prstGeom>
-          <a:noFill/>
-        </p:spPr>
-        <p:txBody>
-          <a:bodyPr wrap="square" lIns="45720" rIns="45720">
-            <a:spAutoFit/>
-          </a:bodyPr>
-          <a:lstStyle/>
-          <a:p>
-            <a:r>
-              <a:rPr sz="1100" b="1">
-                <a:solidFill>
-                  <a:srgbClr val="115E59"/>
-                </a:solidFill>
-                <a:latin typeface="Microsoft YaHei"/>
-              </a:rPr>
-              <a:t>可靠性底线</a:t>
-            </a:r>
-          </a:p>
-          <a:p>
-            <a:pPr>
-              <a:spcAft>
-                <a:spcPts val="100"/>
-              </a:spcAft>
-            </a:pPr>
-            <a:r>
-              <a:rPr sz="830" b="0">
-                <a:solidFill>
-                  <a:srgbClr val="15231F"/>
-                </a:solidFill>
-                <a:latin typeface="Microsoft YaHei"/>
-              </a:rPr>
-              <a:t>• 解析/映射/转换/Schema失败即短路</a:t>
-            </a:r>
-          </a:p>
-          <a:p>
-            <a:pPr>
-              <a:spcAft>
-                <a:spcPts val="100"/>
-              </a:spcAft>
-            </a:pPr>
-            <a:r>
-              <a:rPr sz="830" b="0">
-                <a:solidFill>
-                  <a:srgbClr val="15231F"/>
-                </a:solidFill>
-                <a:latin typeface="Microsoft YaHei"/>
-              </a:rPr>
-              <a:t>• 禁止引用字面量或半成品透传工具</a:t>
-            </a:r>
-          </a:p>
-          <a:p>
-            <a:pPr>
-              <a:spcAft>
-                <a:spcPts val="100"/>
-              </a:spcAft>
-            </a:pPr>
-            <a:r>
-              <a:rPr sz="830" b="0">
-                <a:solidFill>
-                  <a:srgbClr val="15231F"/>
-                </a:solidFill>
-                <a:latin typeface="Microsoft YaHei"/>
-              </a:rPr>
-              <a:t>• 权限与作用域由Runtime校验</a:t>
-            </a:r>
-          </a:p>
-        </p:txBody>
-      </p:sp>
-      <p:sp>
-        <p:nvSpPr>
-          <p:cNvPr id="13" name="TextBox 12"/>
-          <p:cNvSpPr txBox="1"/>
-          <p:nvPr/>
-        </p:nvSpPr>
-        <p:spPr>
-          <a:xfrm>
-            <a:off x="365760" y="1993392"/>
-            <a:ext cx="1828800" cy="201168"/>
+            <a:off x="429768" y="1828800"/>
+            <a:ext cx="4572000" cy="201168"/>
           </a:xfrm>
           <a:prstGeom prst="rect">
             <a:avLst/>
@@ -3686,31 +3604,31 @@
                 </a:solidFill>
                 <a:latin typeface="Microsoft YaHei"/>
               </a:rPr>
-              <a:t>完整主链路</a:t>
-            </a:r>
-          </a:p>
-        </p:txBody>
-      </p:sp>
-      <p:sp>
-        <p:nvSpPr>
-          <p:cNvPr id="14" name="Rounded Rectangle 13"/>
+              <a:t>主链路：Reference → Resolve → Invoke</a:t>
+            </a:r>
+          </a:p>
+        </p:txBody>
+      </p:sp>
+      <p:sp>
+        <p:nvSpPr>
+          <p:cNvPr id="13" name="Rounded Rectangle 12"/>
           <p:cNvSpPr/>
           <p:nvPr/>
         </p:nvSpPr>
         <p:spPr>
           <a:xfrm>
-            <a:off x="320040" y="2221992"/>
-            <a:ext cx="1581912" cy="694944"/>
+            <a:off x="429768" y="2084831"/>
+            <a:ext cx="3200400" cy="1097280"/>
           </a:xfrm>
           <a:prstGeom prst="roundRect">
             <a:avLst/>
           </a:prstGeom>
           <a:solidFill>
-            <a:srgbClr val="FFFFFF"/>
+            <a:srgbClr val="EDF4FC"/>
           </a:solidFill>
           <a:ln w="12700">
             <a:solidFill>
-              <a:srgbClr val="CFDBD5"/>
+              <a:srgbClr val="EDF4FC"/>
             </a:solidFill>
           </a:ln>
         </p:spPr>
@@ -3738,14 +3656,14 @@
       </p:sp>
       <p:sp>
         <p:nvSpPr>
-          <p:cNvPr id="15" name="TextBox 14"/>
+          <p:cNvPr id="14" name="TextBox 13"/>
           <p:cNvSpPr txBox="1"/>
           <p:nvPr/>
         </p:nvSpPr>
         <p:spPr>
           <a:xfrm>
-            <a:off x="384048" y="2295144"/>
-            <a:ext cx="1453895" cy="201168"/>
+            <a:off x="429768" y="2112263"/>
+            <a:ext cx="3200400" cy="182880"/>
           </a:xfrm>
           <a:prstGeom prst="rect">
             <a:avLst/>
@@ -3758,106 +3676,39 @@
           </a:bodyPr>
           <a:lstStyle/>
           <a:p>
-            <a:r>
-              <a:rPr sz="860" b="1">
-                <a:solidFill>
-                  <a:srgbClr val="115E59"/>
-                </a:solidFill>
-                <a:latin typeface="Microsoft YaHei"/>
-              </a:rPr>
-              <a:t>① 工具返回</a:t>
-            </a:r>
-          </a:p>
-        </p:txBody>
-      </p:sp>
-      <p:sp>
-        <p:nvSpPr>
-          <p:cNvPr id="16" name="TextBox 15"/>
-          <p:cNvSpPr txBox="1"/>
-          <p:nvPr/>
-        </p:nvSpPr>
-        <p:spPr>
-          <a:xfrm>
-            <a:off x="384048" y="2523744"/>
-            <a:ext cx="1453895" cy="310896"/>
-          </a:xfrm>
-          <a:prstGeom prst="rect">
-            <a:avLst/>
-          </a:prstGeom>
-          <a:noFill/>
-        </p:spPr>
-        <p:txBody>
-          <a:bodyPr wrap="square" lIns="0" rIns="0" tIns="0" bIns="0">
-            <a:spAutoFit/>
-          </a:bodyPr>
-          <a:lstStyle/>
-          <a:p>
-            <a:r>
-              <a:rPr sz="770" b="0">
-                <a:solidFill>
-                  <a:srgbClr val="60706A"/>
-                </a:solidFill>
-                <a:latin typeface="Microsoft YaHei"/>
-              </a:rPr>
-              <a:t>工具A产出URI、ID、列表</a:t>
-            </a:r>
-          </a:p>
-        </p:txBody>
-      </p:sp>
-      <p:sp>
-        <p:nvSpPr>
-          <p:cNvPr id="17" name="TextBox 16"/>
-          <p:cNvSpPr txBox="1"/>
-          <p:nvPr/>
-        </p:nvSpPr>
-        <p:spPr>
-          <a:xfrm>
-            <a:off x="1892808" y="2441448"/>
-            <a:ext cx="164592" cy="228600"/>
-          </a:xfrm>
-          <a:prstGeom prst="rect">
-            <a:avLst/>
-          </a:prstGeom>
-          <a:noFill/>
-        </p:spPr>
-        <p:txBody>
-          <a:bodyPr wrap="square" lIns="0" rIns="0" tIns="0" bIns="0">
-            <a:spAutoFit/>
-          </a:bodyPr>
-          <a:lstStyle/>
-          <a:p>
-            <a:r>
-              <a:rPr sz="1300" b="1">
-                <a:solidFill>
-                  <a:srgbClr val="0F766E"/>
-                </a:solidFill>
-                <a:latin typeface="Microsoft YaHei"/>
-              </a:rPr>
-              <a:t>→</a:t>
-            </a:r>
-          </a:p>
-        </p:txBody>
-      </p:sp>
-      <p:sp>
-        <p:nvSpPr>
-          <p:cNvPr id="18" name="Rounded Rectangle 17"/>
+            <a:pPr algn="ctr"/>
+            <a:r>
+              <a:rPr sz="840" b="1">
+                <a:solidFill>
+                  <a:srgbClr val="1D4F91"/>
+                </a:solidFill>
+                <a:latin typeface="Microsoft YaHei"/>
+              </a:rPr>
+              <a:t>Ⅰ 引用表达（模型侧）</a:t>
+            </a:r>
+          </a:p>
+        </p:txBody>
+      </p:sp>
+      <p:sp>
+        <p:nvSpPr>
+          <p:cNvPr id="15" name="Rounded Rectangle 14"/>
           <p:cNvSpPr/>
           <p:nvPr/>
         </p:nvSpPr>
         <p:spPr>
           <a:xfrm>
-            <a:off x="1975104" y="2221992"/>
-            <a:ext cx="1581912" cy="694944"/>
+            <a:off x="3721608" y="2084831"/>
+            <a:ext cx="3200400" cy="1097280"/>
           </a:xfrm>
           <a:prstGeom prst="roundRect">
             <a:avLst/>
           </a:prstGeom>
           <a:solidFill>
-            <a:srgbClr val="FFFFFF"/>
+            <a:srgbClr val="FFF7E4"/>
           </a:solidFill>
           <a:ln w="12700">
             <a:solidFill>
-              <a:srgbClr val="CFDBD5"/>
+              <a:srgbClr val="FFF7E4"/>
             </a:solidFill>
           </a:ln>
         </p:spPr>
@@ -3885,14 +3736,14 @@
       </p:sp>
       <p:sp>
         <p:nvSpPr>
-          <p:cNvPr id="19" name="TextBox 18"/>
+          <p:cNvPr id="16" name="TextBox 15"/>
           <p:cNvSpPr txBox="1"/>
           <p:nvPr/>
         </p:nvSpPr>
         <p:spPr>
           <a:xfrm>
-            <a:off x="2039112" y="2295144"/>
-            <a:ext cx="1453895" cy="201168"/>
+            <a:off x="3721608" y="2112263"/>
+            <a:ext cx="3200400" cy="182880"/>
           </a:xfrm>
           <a:prstGeom prst="rect">
             <a:avLst/>
@@ -3905,106 +3756,39 @@
           </a:bodyPr>
           <a:lstStyle/>
           <a:p>
-            <a:r>
-              <a:rPr sz="860" b="1">
-                <a:solidFill>
-                  <a:srgbClr val="115E59"/>
-                </a:solidFill>
-                <a:latin typeface="Microsoft YaHei"/>
-              </a:rPr>
-              <a:t>② 默认入库</a:t>
-            </a:r>
-          </a:p>
-        </p:txBody>
-      </p:sp>
-      <p:sp>
-        <p:nvSpPr>
-          <p:cNvPr id="20" name="TextBox 19"/>
-          <p:cNvSpPr txBox="1"/>
-          <p:nvPr/>
-        </p:nvSpPr>
-        <p:spPr>
-          <a:xfrm>
-            <a:off x="2039112" y="2523744"/>
-            <a:ext cx="1453895" cy="310896"/>
-          </a:xfrm>
-          <a:prstGeom prst="rect">
-            <a:avLst/>
-          </a:prstGeom>
-          <a:noFill/>
-        </p:spPr>
-        <p:txBody>
-          <a:bodyPr wrap="square" lIns="0" rIns="0" tIns="0" bIns="0">
-            <a:spAutoFit/>
-          </a:bodyPr>
-          <a:lstStyle/>
-          <a:p>
-            <a:r>
-              <a:rPr sz="770" b="0">
-                <a:solidFill>
-                  <a:srgbClr val="60706A"/>
-                </a:solidFill>
-                <a:latin typeface="Microsoft YaHei"/>
-              </a:rPr>
-              <a:t>写Workmemory并生成resultId</a:t>
-            </a:r>
-          </a:p>
-        </p:txBody>
-      </p:sp>
-      <p:sp>
-        <p:nvSpPr>
-          <p:cNvPr id="21" name="TextBox 20"/>
-          <p:cNvSpPr txBox="1"/>
-          <p:nvPr/>
-        </p:nvSpPr>
-        <p:spPr>
-          <a:xfrm>
-            <a:off x="3547872" y="2441448"/>
-            <a:ext cx="164592" cy="228600"/>
-          </a:xfrm>
-          <a:prstGeom prst="rect">
-            <a:avLst/>
-          </a:prstGeom>
-          <a:noFill/>
-        </p:spPr>
-        <p:txBody>
-          <a:bodyPr wrap="square" lIns="0" rIns="0" tIns="0" bIns="0">
-            <a:spAutoFit/>
-          </a:bodyPr>
-          <a:lstStyle/>
-          <a:p>
-            <a:r>
-              <a:rPr sz="1300" b="1">
-                <a:solidFill>
-                  <a:srgbClr val="0F766E"/>
-                </a:solidFill>
-                <a:latin typeface="Microsoft YaHei"/>
-              </a:rPr>
-              <a:t>→</a:t>
-            </a:r>
-          </a:p>
-        </p:txBody>
-      </p:sp>
-      <p:sp>
-        <p:nvSpPr>
-          <p:cNvPr id="22" name="Rounded Rectangle 21"/>
+            <a:pPr algn="ctr"/>
+            <a:r>
+              <a:rPr sz="840" b="1">
+                <a:solidFill>
+                  <a:srgbClr val="8A5A00"/>
+                </a:solidFill>
+                <a:latin typeface="Microsoft YaHei"/>
+              </a:rPr>
+              <a:t>Ⅱ 求值与适配（Runtime侧）</a:t>
+            </a:r>
+          </a:p>
+        </p:txBody>
+      </p:sp>
+      <p:sp>
+        <p:nvSpPr>
+          <p:cNvPr id="17" name="Rounded Rectangle 16"/>
           <p:cNvSpPr/>
           <p:nvPr/>
         </p:nvSpPr>
         <p:spPr>
           <a:xfrm>
-            <a:off x="3630168" y="2221992"/>
-            <a:ext cx="1581912" cy="694944"/>
+            <a:off x="7013448" y="2084831"/>
+            <a:ext cx="4754880" cy="1097280"/>
           </a:xfrm>
           <a:prstGeom prst="roundRect">
             <a:avLst/>
           </a:prstGeom>
           <a:solidFill>
-            <a:srgbClr val="FFFFFF"/>
+            <a:srgbClr val="ECF8F4"/>
           </a:solidFill>
           <a:ln w="12700">
             <a:solidFill>
-              <a:srgbClr val="CFDBD5"/>
+              <a:srgbClr val="ECF8F4"/>
             </a:solidFill>
           </a:ln>
         </p:spPr>
@@ -4032,14 +3816,14 @@
       </p:sp>
       <p:sp>
         <p:nvSpPr>
-          <p:cNvPr id="23" name="TextBox 22"/>
+          <p:cNvPr id="18" name="TextBox 17"/>
           <p:cNvSpPr txBox="1"/>
           <p:nvPr/>
         </p:nvSpPr>
         <p:spPr>
           <a:xfrm>
-            <a:off x="3694176" y="2295144"/>
-            <a:ext cx="1453895" cy="201168"/>
+            <a:off x="7013448" y="2112263"/>
+            <a:ext cx="4754880" cy="182880"/>
           </a:xfrm>
           <a:prstGeom prst="rect">
             <a:avLst/>
@@ -4052,96 +3836,29 @@
           </a:bodyPr>
           <a:lstStyle/>
           <a:p>
-            <a:r>
-              <a:rPr sz="860" b="1">
+            <a:pPr algn="ctr"/>
+            <a:r>
+              <a:rPr sz="840" b="1">
                 <a:solidFill>
                   <a:srgbClr val="115E59"/>
                 </a:solidFill>
                 <a:latin typeface="Microsoft YaHei"/>
               </a:rPr>
-              <a:t>③ 送模</a:t>
-            </a:r>
-          </a:p>
-        </p:txBody>
-      </p:sp>
-      <p:sp>
-        <p:nvSpPr>
-          <p:cNvPr id="24" name="TextBox 23"/>
-          <p:cNvSpPr txBox="1"/>
-          <p:nvPr/>
-        </p:nvSpPr>
-        <p:spPr>
-          <a:xfrm>
-            <a:off x="3694176" y="2523744"/>
-            <a:ext cx="1453895" cy="310896"/>
-          </a:xfrm>
-          <a:prstGeom prst="rect">
-            <a:avLst/>
-          </a:prstGeom>
-          <a:noFill/>
-        </p:spPr>
-        <p:txBody>
-          <a:bodyPr wrap="square" lIns="0" rIns="0" tIns="0" bIns="0">
-            <a:spAutoFit/>
-          </a:bodyPr>
-          <a:lstStyle/>
-          <a:p>
-            <a:r>
-              <a:rPr sz="770" b="0">
-                <a:solidFill>
-                  <a:srgbClr val="60706A"/>
-                </a:solidFill>
-                <a:latin typeface="Microsoft YaHei"/>
-              </a:rPr>
-              <a:t>按需mask或内容+引用</a:t>
-            </a:r>
-          </a:p>
-        </p:txBody>
-      </p:sp>
-      <p:sp>
-        <p:nvSpPr>
-          <p:cNvPr id="25" name="TextBox 24"/>
-          <p:cNvSpPr txBox="1"/>
-          <p:nvPr/>
-        </p:nvSpPr>
-        <p:spPr>
-          <a:xfrm>
-            <a:off x="5202936" y="2441448"/>
-            <a:ext cx="164592" cy="228600"/>
-          </a:xfrm>
-          <a:prstGeom prst="rect">
-            <a:avLst/>
-          </a:prstGeom>
-          <a:noFill/>
-        </p:spPr>
-        <p:txBody>
-          <a:bodyPr wrap="square" lIns="0" rIns="0" tIns="0" bIns="0">
-            <a:spAutoFit/>
-          </a:bodyPr>
-          <a:lstStyle/>
-          <a:p>
-            <a:r>
-              <a:rPr sz="1300" b="1">
-                <a:solidFill>
-                  <a:srgbClr val="0F766E"/>
-                </a:solidFill>
-                <a:latin typeface="Microsoft YaHei"/>
-              </a:rPr>
-              <a:t>→</a:t>
-            </a:r>
-          </a:p>
-        </p:txBody>
-      </p:sp>
-      <p:sp>
-        <p:nvSpPr>
-          <p:cNvPr id="26" name="Rounded Rectangle 25"/>
+              <a:t>Ⅲ 校验与执行（工具侧）</a:t>
+            </a:r>
+          </a:p>
+        </p:txBody>
+      </p:sp>
+      <p:sp>
+        <p:nvSpPr>
+          <p:cNvPr id="19" name="Rounded Rectangle 18"/>
           <p:cNvSpPr/>
           <p:nvPr/>
         </p:nvSpPr>
         <p:spPr>
           <a:xfrm>
-            <a:off x="5285231" y="2221992"/>
-            <a:ext cx="1581912" cy="694944"/>
+            <a:off x="493776" y="2331720"/>
+            <a:ext cx="1481328" cy="768096"/>
           </a:xfrm>
           <a:prstGeom prst="roundRect">
             <a:avLst/>
@@ -4179,14 +3896,14 @@
       </p:sp>
       <p:sp>
         <p:nvSpPr>
-          <p:cNvPr id="27" name="TextBox 26"/>
+          <p:cNvPr id="20" name="TextBox 19"/>
           <p:cNvSpPr txBox="1"/>
           <p:nvPr/>
         </p:nvSpPr>
         <p:spPr>
           <a:xfrm>
-            <a:off x="5349240" y="2295144"/>
-            <a:ext cx="1453895" cy="201168"/>
+            <a:off x="548640" y="2377439"/>
+            <a:ext cx="1371600" cy="182880"/>
           </a:xfrm>
           <a:prstGeom prst="rect">
             <a:avLst/>
@@ -4200,27 +3917,27 @@
           <a:lstStyle/>
           <a:p>
             <a:r>
-              <a:rPr sz="860" b="1">
+              <a:rPr sz="819" b="1">
                 <a:solidFill>
                   <a:srgbClr val="115E59"/>
                 </a:solidFill>
                 <a:latin typeface="Microsoft YaHei"/>
               </a:rPr>
-              <a:t>④ 模型填引用</a:t>
-            </a:r>
-          </a:p>
-        </p:txBody>
-      </p:sp>
-      <p:sp>
-        <p:nvSpPr>
-          <p:cNvPr id="28" name="TextBox 27"/>
+              <a:t>① 结果入库</a:t>
+            </a:r>
+          </a:p>
+        </p:txBody>
+      </p:sp>
+      <p:sp>
+        <p:nvSpPr>
+          <p:cNvPr id="21" name="TextBox 20"/>
           <p:cNvSpPr txBox="1"/>
           <p:nvPr/>
         </p:nvSpPr>
         <p:spPr>
           <a:xfrm>
-            <a:off x="5349240" y="2523744"/>
-            <a:ext cx="1453895" cy="310896"/>
+            <a:off x="548640" y="2578608"/>
+            <a:ext cx="1371600" cy="493776"/>
           </a:xfrm>
           <a:prstGeom prst="rect">
             <a:avLst/>
@@ -4234,27 +3951,27 @@
           <a:lstStyle/>
           <a:p>
             <a:r>
-              <a:rPr sz="770" b="0">
+              <a:rPr sz="740" b="0">
                 <a:solidFill>
                   <a:srgbClr val="60706A"/>
                 </a:solidFill>
                 <a:latin typeface="Microsoft YaHei"/>
               </a:rPr>
-              <a:t>下游参数不复述真值</a:t>
-            </a:r>
-          </a:p>
-        </p:txBody>
-      </p:sp>
-      <p:sp>
-        <p:nvSpPr>
-          <p:cNvPr id="29" name="TextBox 28"/>
+              <a:t>工具A返回，写工作记忆并生成resultId</a:t>
+            </a:r>
+          </a:p>
+        </p:txBody>
+      </p:sp>
+      <p:sp>
+        <p:nvSpPr>
+          <p:cNvPr id="22" name="TextBox 21"/>
           <p:cNvSpPr txBox="1"/>
           <p:nvPr/>
         </p:nvSpPr>
         <p:spPr>
           <a:xfrm>
-            <a:off x="6858000" y="2441448"/>
-            <a:ext cx="164592" cy="228600"/>
+            <a:off x="1956816" y="2596896"/>
+            <a:ext cx="182880" cy="237744"/>
           </a:xfrm>
           <a:prstGeom prst="rect">
             <a:avLst/>
@@ -4268,7 +3985,7 @@
           <a:lstStyle/>
           <a:p>
             <a:r>
-              <a:rPr sz="1300" b="1">
+              <a:rPr sz="1200" b="1">
                 <a:solidFill>
                   <a:srgbClr val="0F766E"/>
                 </a:solidFill>
@@ -4281,14 +3998,14 @@
       </p:sp>
       <p:sp>
         <p:nvSpPr>
-          <p:cNvPr id="30" name="Rounded Rectangle 29"/>
+          <p:cNvPr id="23" name="Rounded Rectangle 22"/>
           <p:cNvSpPr/>
           <p:nvPr/>
         </p:nvSpPr>
         <p:spPr>
           <a:xfrm>
-            <a:off x="6940296" y="2221992"/>
-            <a:ext cx="1581912" cy="694944"/>
+            <a:off x="2066543" y="2331720"/>
+            <a:ext cx="1481328" cy="768096"/>
           </a:xfrm>
           <a:prstGeom prst="roundRect">
             <a:avLst/>
@@ -4326,14 +4043,14 @@
       </p:sp>
       <p:sp>
         <p:nvSpPr>
-          <p:cNvPr id="31" name="TextBox 30"/>
+          <p:cNvPr id="24" name="TextBox 23"/>
           <p:cNvSpPr txBox="1"/>
           <p:nvPr/>
         </p:nvSpPr>
         <p:spPr>
           <a:xfrm>
-            <a:off x="7004304" y="2295144"/>
-            <a:ext cx="1453895" cy="201168"/>
+            <a:off x="2121408" y="2377439"/>
+            <a:ext cx="1371600" cy="182880"/>
           </a:xfrm>
           <a:prstGeom prst="rect">
             <a:avLst/>
@@ -4347,27 +4064,27 @@
           <a:lstStyle/>
           <a:p>
             <a:r>
-              <a:rPr sz="860" b="1">
+              <a:rPr sz="819" b="1">
                 <a:solidFill>
                   <a:srgbClr val="115E59"/>
                 </a:solidFill>
                 <a:latin typeface="Microsoft YaHei"/>
               </a:rPr>
-              <a:t>⑤ 引用求值</a:t>
-            </a:r>
-          </a:p>
-        </p:txBody>
-      </p:sp>
-      <p:sp>
-        <p:nvSpPr>
-          <p:cNvPr id="32" name="TextBox 31"/>
+              <a:t>② 送模呈现</a:t>
+            </a:r>
+          </a:p>
+        </p:txBody>
+      </p:sp>
+      <p:sp>
+        <p:nvSpPr>
+          <p:cNvPr id="25" name="TextBox 24"/>
           <p:cNvSpPr txBox="1"/>
           <p:nvPr/>
         </p:nvSpPr>
         <p:spPr>
           <a:xfrm>
-            <a:off x="7004304" y="2523744"/>
-            <a:ext cx="1453895" cy="310896"/>
+            <a:off x="2121408" y="2578608"/>
+            <a:ext cx="1371600" cy="493776"/>
           </a:xfrm>
           <a:prstGeom prst="rect">
             <a:avLst/>
@@ -4381,27 +4098,27 @@
           <a:lstStyle/>
           <a:p>
             <a:r>
-              <a:rPr sz="770" b="0">
+              <a:rPr sz="740" b="0">
                 <a:solidFill>
                   <a:srgbClr val="60706A"/>
                 </a:solidFill>
                 <a:latin typeface="Microsoft YaHei"/>
               </a:rPr>
-              <a:t>查记忆或语义词典回填</a:t>
-            </a:r>
-          </a:p>
-        </p:txBody>
-      </p:sp>
-      <p:sp>
-        <p:nvSpPr>
-          <p:cNvPr id="33" name="TextBox 32"/>
+              <a:t>指针字段mask；要推理的留内容+引用</a:t>
+            </a:r>
+          </a:p>
+        </p:txBody>
+      </p:sp>
+      <p:sp>
+        <p:nvSpPr>
+          <p:cNvPr id="26" name="TextBox 25"/>
           <p:cNvSpPr txBox="1"/>
           <p:nvPr/>
         </p:nvSpPr>
         <p:spPr>
           <a:xfrm>
-            <a:off x="8513064" y="2441448"/>
-            <a:ext cx="164592" cy="228600"/>
+            <a:off x="3529584" y="2596896"/>
+            <a:ext cx="182880" cy="237744"/>
           </a:xfrm>
           <a:prstGeom prst="rect">
             <a:avLst/>
@@ -4415,7 +4132,7 @@
           <a:lstStyle/>
           <a:p>
             <a:r>
-              <a:rPr sz="1300" b="1">
+              <a:rPr sz="1200" b="1">
                 <a:solidFill>
                   <a:srgbClr val="0F766E"/>
                 </a:solidFill>
@@ -4428,14 +4145,14 @@
       </p:sp>
       <p:sp>
         <p:nvSpPr>
-          <p:cNvPr id="34" name="Rounded Rectangle 33"/>
+          <p:cNvPr id="27" name="Rounded Rectangle 26"/>
           <p:cNvSpPr/>
           <p:nvPr/>
         </p:nvSpPr>
         <p:spPr>
           <a:xfrm>
-            <a:off x="8595360" y="2221992"/>
-            <a:ext cx="1581912" cy="694944"/>
+            <a:off x="3785616" y="2331720"/>
+            <a:ext cx="1481328" cy="768096"/>
           </a:xfrm>
           <a:prstGeom prst="roundRect">
             <a:avLst/>
@@ -4473,14 +4190,14 @@
       </p:sp>
       <p:sp>
         <p:nvSpPr>
-          <p:cNvPr id="35" name="TextBox 34"/>
+          <p:cNvPr id="28" name="TextBox 27"/>
           <p:cNvSpPr txBox="1"/>
           <p:nvPr/>
         </p:nvSpPr>
         <p:spPr>
           <a:xfrm>
-            <a:off x="8659368" y="2295144"/>
-            <a:ext cx="1453895" cy="201168"/>
+            <a:off x="3840480" y="2377439"/>
+            <a:ext cx="1371600" cy="182880"/>
           </a:xfrm>
           <a:prstGeom prst="rect">
             <a:avLst/>
@@ -4494,27 +4211,27 @@
           <a:lstStyle/>
           <a:p>
             <a:r>
-              <a:rPr sz="860" b="1">
+              <a:rPr sz="819" b="1">
                 <a:solidFill>
                   <a:srgbClr val="115E59"/>
                 </a:solidFill>
                 <a:latin typeface="Microsoft YaHei"/>
               </a:rPr>
-              <a:t>⑥ 转换/校验</a:t>
-            </a:r>
-          </a:p>
-        </p:txBody>
-      </p:sp>
-      <p:sp>
-        <p:nvSpPr>
-          <p:cNvPr id="36" name="TextBox 35"/>
+              <a:t>③ 模型填引用</a:t>
+            </a:r>
+          </a:p>
+        </p:txBody>
+      </p:sp>
+      <p:sp>
+        <p:nvSpPr>
+          <p:cNvPr id="29" name="TextBox 28"/>
           <p:cNvSpPr txBox="1"/>
           <p:nvPr/>
         </p:nvSpPr>
         <p:spPr>
           <a:xfrm>
-            <a:off x="8659368" y="2523744"/>
-            <a:ext cx="1453895" cy="310896"/>
+            <a:off x="3840480" y="2578608"/>
+            <a:ext cx="1371600" cy="493776"/>
           </a:xfrm>
           <a:prstGeom prst="rect">
             <a:avLst/>
@@ -4528,27 +4245,27 @@
           <a:lstStyle/>
           <a:p>
             <a:r>
-              <a:rPr sz="770" b="0">
+              <a:rPr sz="740" b="0">
                 <a:solidFill>
                   <a:srgbClr val="60706A"/>
                 </a:solidFill>
                 <a:latin typeface="Microsoft YaHei"/>
               </a:rPr>
-              <a:t>Policy适配结构并校验</a:t>
-            </a:r>
-          </a:p>
-        </p:txBody>
-      </p:sp>
-      <p:sp>
-        <p:nvSpPr>
-          <p:cNvPr id="37" name="TextBox 36"/>
+              <a:t>下游入参写${…}，不复述真值</a:t>
+            </a:r>
+          </a:p>
+        </p:txBody>
+      </p:sp>
+      <p:sp>
+        <p:nvSpPr>
+          <p:cNvPr id="30" name="TextBox 29"/>
           <p:cNvSpPr txBox="1"/>
           <p:nvPr/>
         </p:nvSpPr>
         <p:spPr>
           <a:xfrm>
-            <a:off x="10168128" y="2441448"/>
-            <a:ext cx="164592" cy="228600"/>
+            <a:off x="5248656" y="2596896"/>
+            <a:ext cx="182880" cy="237744"/>
           </a:xfrm>
           <a:prstGeom prst="rect">
             <a:avLst/>
@@ -4562,7 +4279,7 @@
           <a:lstStyle/>
           <a:p>
             <a:r>
-              <a:rPr sz="1300" b="1">
+              <a:rPr sz="1200" b="1">
                 <a:solidFill>
                   <a:srgbClr val="0F766E"/>
                 </a:solidFill>
@@ -4575,14 +4292,14 @@
       </p:sp>
       <p:sp>
         <p:nvSpPr>
-          <p:cNvPr id="38" name="Rounded Rectangle 37"/>
+          <p:cNvPr id="31" name="Rounded Rectangle 30"/>
           <p:cNvSpPr/>
           <p:nvPr/>
         </p:nvSpPr>
         <p:spPr>
           <a:xfrm>
-            <a:off x="10250424" y="2221992"/>
-            <a:ext cx="1581912" cy="694944"/>
+            <a:off x="5358384" y="2331720"/>
+            <a:ext cx="1481328" cy="768096"/>
           </a:xfrm>
           <a:prstGeom prst="roundRect">
             <a:avLst/>
@@ -4620,14 +4337,14 @@
       </p:sp>
       <p:sp>
         <p:nvSpPr>
-          <p:cNvPr id="39" name="TextBox 38"/>
+          <p:cNvPr id="32" name="TextBox 31"/>
           <p:cNvSpPr txBox="1"/>
           <p:nvPr/>
         </p:nvSpPr>
         <p:spPr>
           <a:xfrm>
-            <a:off x="10314432" y="2295144"/>
-            <a:ext cx="1453895" cy="201168"/>
+            <a:off x="5413248" y="2377439"/>
+            <a:ext cx="1371600" cy="182880"/>
           </a:xfrm>
           <a:prstGeom prst="rect">
             <a:avLst/>
@@ -4641,27 +4358,27 @@
           <a:lstStyle/>
           <a:p>
             <a:r>
-              <a:rPr sz="860" b="1">
+              <a:rPr sz="819" b="1">
                 <a:solidFill>
                   <a:srgbClr val="115E59"/>
                 </a:solidFill>
                 <a:latin typeface="Microsoft YaHei"/>
               </a:rPr>
-              <a:t>⑦ 执行闭环</a:t>
-            </a:r>
-          </a:p>
-        </p:txBody>
-      </p:sp>
-      <p:sp>
-        <p:nvSpPr>
-          <p:cNvPr id="40" name="TextBox 39"/>
+              <a:t>④ 引用求值</a:t>
+            </a:r>
+          </a:p>
+        </p:txBody>
+      </p:sp>
+      <p:sp>
+        <p:nvSpPr>
+          <p:cNvPr id="33" name="TextBox 32"/>
           <p:cNvSpPr txBox="1"/>
           <p:nvPr/>
         </p:nvSpPr>
         <p:spPr>
           <a:xfrm>
-            <a:off x="10314432" y="2523744"/>
-            <a:ext cx="1453895" cy="310896"/>
+            <a:off x="5413248" y="2578608"/>
+            <a:ext cx="1371600" cy="493776"/>
           </a:xfrm>
           <a:prstGeom prst="rect">
             <a:avLst/>
@@ -4675,33 +4392,67 @@
           <a:lstStyle/>
           <a:p>
             <a:r>
-              <a:rPr sz="770" b="0">
+              <a:rPr sz="740" b="0">
                 <a:solidFill>
                   <a:srgbClr val="60706A"/>
                 </a:solidFill>
                 <a:latin typeface="Microsoft YaHei"/>
               </a:rPr>
-              <a:t>真值调工具B；结果再入库</a:t>
-            </a:r>
-          </a:p>
-        </p:txBody>
-      </p:sp>
-      <p:sp>
-        <p:nvSpPr>
-          <p:cNvPr id="41" name="Rounded Rectangle 40"/>
+              <a:t>查记忆/词典，回填真值</a:t>
+            </a:r>
+          </a:p>
+        </p:txBody>
+      </p:sp>
+      <p:sp>
+        <p:nvSpPr>
+          <p:cNvPr id="34" name="TextBox 33"/>
+          <p:cNvSpPr txBox="1"/>
+          <p:nvPr/>
+        </p:nvSpPr>
+        <p:spPr>
+          <a:xfrm>
+            <a:off x="6821424" y="2596896"/>
+            <a:ext cx="182880" cy="237744"/>
+          </a:xfrm>
+          <a:prstGeom prst="rect">
+            <a:avLst/>
+          </a:prstGeom>
+          <a:noFill/>
+        </p:spPr>
+        <p:txBody>
+          <a:bodyPr wrap="square" lIns="0" rIns="0" tIns="0" bIns="0">
+            <a:spAutoFit/>
+          </a:bodyPr>
+          <a:lstStyle/>
+          <a:p>
+            <a:r>
+              <a:rPr sz="1200" b="1">
+                <a:solidFill>
+                  <a:srgbClr val="0F766E"/>
+                </a:solidFill>
+                <a:latin typeface="Microsoft YaHei"/>
+              </a:rPr>
+              <a:t>→</a:t>
+            </a:r>
+          </a:p>
+        </p:txBody>
+      </p:sp>
+      <p:sp>
+        <p:nvSpPr>
+          <p:cNvPr id="35" name="Rounded Rectangle 34"/>
           <p:cNvSpPr/>
           <p:nvPr/>
         </p:nvSpPr>
         <p:spPr>
           <a:xfrm>
-            <a:off x="320040" y="3054096"/>
-            <a:ext cx="3657600" cy="1298448"/>
+            <a:off x="7077456" y="2331720"/>
+            <a:ext cx="1481328" cy="768096"/>
           </a:xfrm>
           <a:prstGeom prst="roundRect">
             <a:avLst/>
           </a:prstGeom>
           <a:solidFill>
-            <a:srgbClr val="EDF4FC"/>
+            <a:srgbClr val="FFFFFF"/>
           </a:solidFill>
           <a:ln w="12700">
             <a:solidFill>
@@ -4733,14 +4484,14 @@
       </p:sp>
       <p:sp>
         <p:nvSpPr>
-          <p:cNvPr id="42" name="TextBox 41"/>
+          <p:cNvPr id="36" name="TextBox 35"/>
           <p:cNvSpPr txBox="1"/>
           <p:nvPr/>
         </p:nvSpPr>
         <p:spPr>
           <a:xfrm>
-            <a:off x="429768" y="3127248"/>
-            <a:ext cx="3438144" cy="1152144"/>
+            <a:off x="7132320" y="2377439"/>
+            <a:ext cx="1371600" cy="182880"/>
           </a:xfrm>
           <a:prstGeom prst="rect">
             <a:avLst/>
@@ -4748,103 +4499,107 @@
           <a:noFill/>
         </p:spPr>
         <p:txBody>
-          <a:bodyPr wrap="square" lIns="45720" rIns="45720">
+          <a:bodyPr wrap="square" lIns="0" rIns="0" tIns="0" bIns="0">
             <a:spAutoFit/>
           </a:bodyPr>
           <a:lstStyle/>
           <a:p>
             <a:r>
-              <a:rPr sz="1100" b="1">
+              <a:rPr sz="819" b="1">
                 <a:solidFill>
                   <a:srgbClr val="115E59"/>
                 </a:solidFill>
                 <a:latin typeface="Microsoft YaHei"/>
               </a:rPr>
-              <a:t>两类引用 · 同一管道</a:t>
-            </a:r>
-          </a:p>
-          <a:p>
-            <a:pPr>
-              <a:spcAft>
-                <a:spcPts val="100"/>
-              </a:spcAft>
-            </a:pPr>
-            <a:r>
-              <a:rPr sz="869" b="1">
-                <a:solidFill>
-                  <a:srgbClr val="115E59"/>
-                </a:solidFill>
-                <a:latin typeface="Microsoft YaHei"/>
-              </a:rPr>
-              <a:t>A  工具结果引用</a:t>
-            </a:r>
-          </a:p>
-          <a:p>
-            <a:pPr>
-              <a:spcAft>
-                <a:spcPts val="100"/>
-              </a:spcAft>
-            </a:pPr>
-            <a:r>
-              <a:rPr sz="800" b="0">
-                <a:solidFill>
-                  <a:srgbClr val="15231F"/>
-                </a:solidFill>
-                <a:latin typeface="Microsoft YaHei"/>
-              </a:rPr>
-              <a:t>${a1b2c3d4.fileUri}  →  Workmemory</a:t>
-            </a:r>
-          </a:p>
-          <a:p>
-            <a:pPr>
-              <a:spcAft>
-                <a:spcPts val="100"/>
-              </a:spcAft>
-            </a:pPr>
-            <a:r>
-              <a:rPr sz="869" b="1">
-                <a:solidFill>
-                  <a:srgbClr val="115E59"/>
-                </a:solidFill>
-                <a:latin typeface="Microsoft YaHei"/>
-              </a:rPr>
-              <a:t>B  语义实体引用</a:t>
-            </a:r>
-          </a:p>
-          <a:p>
-            <a:pPr>
-              <a:spcAft>
-                <a:spcPts val="100"/>
-              </a:spcAft>
-            </a:pPr>
-            <a:r>
-              <a:rPr sz="800" b="0">
-                <a:solidFill>
-                  <a:srgbClr val="15231F"/>
-                </a:solidFill>
-                <a:latin typeface="Microsoft YaHei"/>
-              </a:rPr>
-              <a:t>${app.抖音.bundleName}  →  别名归一 + 属性映射</a:t>
-            </a:r>
-          </a:p>
-        </p:txBody>
-      </p:sp>
-      <p:sp>
-        <p:nvSpPr>
-          <p:cNvPr id="43" name="Rounded Rectangle 42"/>
+              <a:t>⑤ 结构适配</a:t>
+            </a:r>
+          </a:p>
+        </p:txBody>
+      </p:sp>
+      <p:sp>
+        <p:nvSpPr>
+          <p:cNvPr id="37" name="TextBox 36"/>
+          <p:cNvSpPr txBox="1"/>
+          <p:nvPr/>
+        </p:nvSpPr>
+        <p:spPr>
+          <a:xfrm>
+            <a:off x="7132320" y="2578608"/>
+            <a:ext cx="1371600" cy="493776"/>
+          </a:xfrm>
+          <a:prstGeom prst="rect">
+            <a:avLst/>
+          </a:prstGeom>
+          <a:noFill/>
+        </p:spPr>
+        <p:txBody>
+          <a:bodyPr wrap="square" lIns="0" rIns="0" tIns="0" bIns="0">
+            <a:spAutoFit/>
+          </a:bodyPr>
+          <a:lstStyle/>
+          <a:p>
+            <a:r>
+              <a:rPr sz="740" b="0">
+                <a:solidFill>
+                  <a:srgbClr val="60706A"/>
+                </a:solidFill>
+                <a:latin typeface="Microsoft YaHei"/>
+              </a:rPr>
+              <a:t>按参数Policy转换（可选）</a:t>
+            </a:r>
+          </a:p>
+        </p:txBody>
+      </p:sp>
+      <p:sp>
+        <p:nvSpPr>
+          <p:cNvPr id="38" name="TextBox 37"/>
+          <p:cNvSpPr txBox="1"/>
+          <p:nvPr/>
+        </p:nvSpPr>
+        <p:spPr>
+          <a:xfrm>
+            <a:off x="8540496" y="2596896"/>
+            <a:ext cx="182880" cy="237744"/>
+          </a:xfrm>
+          <a:prstGeom prst="rect">
+            <a:avLst/>
+          </a:prstGeom>
+          <a:noFill/>
+        </p:spPr>
+        <p:txBody>
+          <a:bodyPr wrap="square" lIns="0" rIns="0" tIns="0" bIns="0">
+            <a:spAutoFit/>
+          </a:bodyPr>
+          <a:lstStyle/>
+          <a:p>
+            <a:r>
+              <a:rPr sz="1200" b="1">
+                <a:solidFill>
+                  <a:srgbClr val="0F766E"/>
+                </a:solidFill>
+                <a:latin typeface="Microsoft YaHei"/>
+              </a:rPr>
+              <a:t>→</a:t>
+            </a:r>
+          </a:p>
+        </p:txBody>
+      </p:sp>
+      <p:sp>
+        <p:nvSpPr>
+          <p:cNvPr id="39" name="Rounded Rectangle 38"/>
           <p:cNvSpPr/>
           <p:nvPr/>
         </p:nvSpPr>
         <p:spPr>
           <a:xfrm>
-            <a:off x="4087368" y="3054096"/>
-            <a:ext cx="3657600" cy="1298448"/>
+            <a:off x="8631936" y="2331720"/>
+            <a:ext cx="1481328" cy="768096"/>
           </a:xfrm>
           <a:prstGeom prst="roundRect">
             <a:avLst/>
           </a:prstGeom>
           <a:solidFill>
-            <a:srgbClr val="FFF7E4"/>
+            <a:srgbClr val="FFFFFF"/>
           </a:solidFill>
           <a:ln w="12700">
             <a:solidFill>
@@ -4876,14 +4631,14 @@
       </p:sp>
       <p:sp>
         <p:nvSpPr>
-          <p:cNvPr id="44" name="TextBox 43"/>
+          <p:cNvPr id="40" name="TextBox 39"/>
           <p:cNvSpPr txBox="1"/>
           <p:nvPr/>
         </p:nvSpPr>
         <p:spPr>
           <a:xfrm>
-            <a:off x="4197096" y="3127248"/>
-            <a:ext cx="3438144" cy="1152144"/>
+            <a:off x="8686800" y="2377439"/>
+            <a:ext cx="1371600" cy="182880"/>
           </a:xfrm>
           <a:prstGeom prst="rect">
             <a:avLst/>
@@ -4891,87 +4646,107 @@
           <a:noFill/>
         </p:spPr>
         <p:txBody>
-          <a:bodyPr wrap="square" lIns="45720" rIns="45720">
+          <a:bodyPr wrap="square" lIns="0" rIns="0" tIns="0" bIns="0">
             <a:spAutoFit/>
           </a:bodyPr>
           <a:lstStyle/>
           <a:p>
             <a:r>
-              <a:rPr sz="1100" b="1">
+              <a:rPr sz="819" b="1">
                 <a:solidFill>
                   <a:srgbClr val="115E59"/>
                 </a:solidFill>
                 <a:latin typeface="Microsoft YaHei"/>
               </a:rPr>
-              <a:t>两种可见性</a:t>
-            </a:r>
-          </a:p>
-          <a:p>
-            <a:pPr>
-              <a:spcAft>
-                <a:spcPts val="100"/>
-              </a:spcAft>
-            </a:pPr>
-            <a:r>
-              <a:rPr sz="840" b="0">
-                <a:solidFill>
-                  <a:srgbClr val="15231F"/>
-                </a:solidFill>
-                <a:latin typeface="Microsoft YaHei"/>
-              </a:rPr>
-              <a:t>• 模型不用看值：送模前mask为引用，所见即所填</a:t>
-            </a:r>
-          </a:p>
-          <a:p>
-            <a:pPr>
-              <a:spcAft>
-                <a:spcPts val="100"/>
-              </a:spcAft>
-            </a:pPr>
-            <a:r>
-              <a:rPr sz="840" b="0">
-                <a:solidFill>
-                  <a:srgbClr val="15231F"/>
-                </a:solidFill>
-                <a:latin typeface="Microsoft YaHei"/>
-              </a:rPr>
-              <a:t>• 模型需要看值：内容/摘要供推理，入参仍写引用</a:t>
-            </a:r>
-          </a:p>
-          <a:p>
-            <a:pPr>
-              <a:spcAft>
-                <a:spcPts val="100"/>
-              </a:spcAft>
-            </a:pPr>
-            <a:r>
-              <a:rPr sz="800" b="1">
-                <a:solidFill>
-                  <a:srgbClr val="115E59"/>
-                </a:solidFill>
-                <a:latin typeface="Microsoft YaHei"/>
-              </a:rPr>
-              <a:t>约束层级：Runtime硬校验 ＞ Schema/Skill ＞ Prompt</a:t>
-            </a:r>
-          </a:p>
-        </p:txBody>
-      </p:sp>
-      <p:sp>
-        <p:nvSpPr>
-          <p:cNvPr id="45" name="Rounded Rectangle 44"/>
+              <a:t>⑥ 校验/短路</a:t>
+            </a:r>
+          </a:p>
+        </p:txBody>
+      </p:sp>
+      <p:sp>
+        <p:nvSpPr>
+          <p:cNvPr id="41" name="TextBox 40"/>
+          <p:cNvSpPr txBox="1"/>
+          <p:nvPr/>
+        </p:nvSpPr>
+        <p:spPr>
+          <a:xfrm>
+            <a:off x="8686800" y="2578608"/>
+            <a:ext cx="1371600" cy="493776"/>
+          </a:xfrm>
+          <a:prstGeom prst="rect">
+            <a:avLst/>
+          </a:prstGeom>
+          <a:noFill/>
+        </p:spPr>
+        <p:txBody>
+          <a:bodyPr wrap="square" lIns="0" rIns="0" tIns="0" bIns="0">
+            <a:spAutoFit/>
+          </a:bodyPr>
+          <a:lstStyle/>
+          <a:p>
+            <a:r>
+              <a:rPr sz="740" b="0">
+                <a:solidFill>
+                  <a:srgbClr val="60706A"/>
+                </a:solidFill>
+                <a:latin typeface="Microsoft YaHei"/>
+              </a:rPr>
+              <a:t>Schema与权限校验；失败不透传</a:t>
+            </a:r>
+          </a:p>
+        </p:txBody>
+      </p:sp>
+      <p:sp>
+        <p:nvSpPr>
+          <p:cNvPr id="42" name="TextBox 41"/>
+          <p:cNvSpPr txBox="1"/>
+          <p:nvPr/>
+        </p:nvSpPr>
+        <p:spPr>
+          <a:xfrm>
+            <a:off x="10094976" y="2596896"/>
+            <a:ext cx="182880" cy="237744"/>
+          </a:xfrm>
+          <a:prstGeom prst="rect">
+            <a:avLst/>
+          </a:prstGeom>
+          <a:noFill/>
+        </p:spPr>
+        <p:txBody>
+          <a:bodyPr wrap="square" lIns="0" rIns="0" tIns="0" bIns="0">
+            <a:spAutoFit/>
+          </a:bodyPr>
+          <a:lstStyle/>
+          <a:p>
+            <a:r>
+              <a:rPr sz="1200" b="1">
+                <a:solidFill>
+                  <a:srgbClr val="0F766E"/>
+                </a:solidFill>
+                <a:latin typeface="Microsoft YaHei"/>
+              </a:rPr>
+              <a:t>→</a:t>
+            </a:r>
+          </a:p>
+        </p:txBody>
+      </p:sp>
+      <p:sp>
+        <p:nvSpPr>
+          <p:cNvPr id="43" name="Rounded Rectangle 42"/>
           <p:cNvSpPr/>
           <p:nvPr/>
         </p:nvSpPr>
         <p:spPr>
           <a:xfrm>
-            <a:off x="7854696" y="3054096"/>
-            <a:ext cx="4014215" cy="1298448"/>
+            <a:off x="10186416" y="2331720"/>
+            <a:ext cx="1481328" cy="768096"/>
           </a:xfrm>
           <a:prstGeom prst="roundRect">
             <a:avLst/>
           </a:prstGeom>
           <a:solidFill>
-            <a:srgbClr val="ECF8F4"/>
+            <a:srgbClr val="FFFFFF"/>
           </a:solidFill>
           <a:ln w="12700">
             <a:solidFill>
@@ -5003,14 +4778,14 @@
       </p:sp>
       <p:sp>
         <p:nvSpPr>
-          <p:cNvPr id="46" name="TextBox 45"/>
+          <p:cNvPr id="44" name="TextBox 43"/>
           <p:cNvSpPr txBox="1"/>
           <p:nvPr/>
         </p:nvSpPr>
         <p:spPr>
           <a:xfrm>
-            <a:off x="7964423" y="3127248"/>
-            <a:ext cx="3794759" cy="1152144"/>
+            <a:off x="10241280" y="2377439"/>
+            <a:ext cx="1371600" cy="182880"/>
           </a:xfrm>
           <a:prstGeom prst="rect">
             <a:avLst/>
@@ -5018,107 +4793,77 @@
           <a:noFill/>
         </p:spPr>
         <p:txBody>
-          <a:bodyPr wrap="square" lIns="45720" rIns="45720">
+          <a:bodyPr wrap="square" lIns="0" rIns="0" tIns="0" bIns="0">
             <a:spAutoFit/>
           </a:bodyPr>
           <a:lstStyle/>
           <a:p>
             <a:r>
-              <a:rPr sz="1100" b="1">
+              <a:rPr sz="819" b="1">
                 <a:solidFill>
                   <a:srgbClr val="115E59"/>
                 </a:solidFill>
                 <a:latin typeface="Microsoft YaHei"/>
               </a:rPr>
-              <a:t>引用后可做结构适配</a:t>
-            </a:r>
-          </a:p>
-          <a:p>
-            <a:pPr>
-              <a:spcAft>
-                <a:spcPts val="100"/>
-              </a:spcAft>
-            </a:pPr>
-            <a:r>
-              <a:rPr sz="800" b="0">
-                <a:solidFill>
-                  <a:srgbClr val="15231F"/>
-                </a:solidFill>
-                <a:latin typeface="Microsoft YaHei"/>
-              </a:rPr>
-              <a:t>模型：images=${rid.merged_id_list}</a:t>
-            </a:r>
-          </a:p>
-          <a:p>
-            <a:pPr>
-              <a:spcAft>
-                <a:spcPts val="100"/>
-              </a:spcAft>
-            </a:pPr>
-            <a:r>
-              <a:rPr sz="800" b="0">
-                <a:solidFill>
-                  <a:srgbClr val="15231F"/>
-                </a:solidFill>
-                <a:latin typeface="Microsoft YaHei"/>
-              </a:rPr>
-              <a:t>Resolve：[563, 728]</a:t>
-            </a:r>
-          </a:p>
-          <a:p>
-            <a:pPr>
-              <a:spcAft>
-                <a:spcPts val="100"/>
-              </a:spcAft>
-            </a:pPr>
-            <a:r>
-              <a:rPr sz="760" b="0">
-                <a:solidFill>
-                  <a:srgbClr val="15231F"/>
-                </a:solidFill>
-                <a:latin typeface="Microsoft YaHei"/>
-              </a:rPr>
-              <a:t>Transform：[{"file_id":"563"},{"file_id":"728"}]</a:t>
-            </a:r>
-          </a:p>
-          <a:p>
-            <a:pPr>
-              <a:spcAft>
-                <a:spcPts val="100"/>
-              </a:spcAft>
-            </a:pPr>
-            <a:r>
-              <a:rPr sz="780" b="1">
-                <a:solidFill>
-                  <a:srgbClr val="115E59"/>
-                </a:solidFill>
-                <a:latin typeface="Microsoft YaHei"/>
-              </a:rPr>
-              <a:t>先求值，再按目标参数Policy转换；模型/工具均不改结构</a:t>
-            </a:r>
-          </a:p>
-        </p:txBody>
-      </p:sp>
-      <p:sp>
-        <p:nvSpPr>
-          <p:cNvPr id="47" name="Rounded Rectangle 46"/>
+              <a:t>⑦ 执行闭环</a:t>
+            </a:r>
+          </a:p>
+        </p:txBody>
+      </p:sp>
+      <p:sp>
+        <p:nvSpPr>
+          <p:cNvPr id="45" name="TextBox 44"/>
+          <p:cNvSpPr txBox="1"/>
+          <p:nvPr/>
+        </p:nvSpPr>
+        <p:spPr>
+          <a:xfrm>
+            <a:off x="10241280" y="2578608"/>
+            <a:ext cx="1371600" cy="493776"/>
+          </a:xfrm>
+          <a:prstGeom prst="rect">
+            <a:avLst/>
+          </a:prstGeom>
+          <a:noFill/>
+        </p:spPr>
+        <p:txBody>
+          <a:bodyPr wrap="square" lIns="0" rIns="0" tIns="0" bIns="0">
+            <a:spAutoFit/>
+          </a:bodyPr>
+          <a:lstStyle/>
+          <a:p>
+            <a:r>
+              <a:rPr sz="740" b="0">
+                <a:solidFill>
+                  <a:srgbClr val="60706A"/>
+                </a:solidFill>
+                <a:latin typeface="Microsoft YaHei"/>
+              </a:rPr>
+              <a:t>真值调工具B；结果再入库</a:t>
+            </a:r>
+          </a:p>
+        </p:txBody>
+      </p:sp>
+      <p:sp>
+        <p:nvSpPr>
+          <p:cNvPr id="46" name="Rounded Rectangle 45"/>
           <p:cNvSpPr/>
           <p:nvPr/>
         </p:nvSpPr>
         <p:spPr>
           <a:xfrm>
-            <a:off x="320040" y="4471416"/>
-            <a:ext cx="4572000" cy="1234440"/>
+            <a:off x="320040" y="3364992"/>
+            <a:ext cx="3246120" cy="2011680"/>
           </a:xfrm>
           <a:prstGeom prst="roundRect">
             <a:avLst/>
           </a:prstGeom>
           <a:solidFill>
-            <a:srgbClr val="FFFFFF"/>
+            <a:srgbClr val="EDF4FC"/>
           </a:solidFill>
           <a:ln w="12700">
             <a:solidFill>
-              <a:srgbClr val="CFDBD5"/>
+              <a:srgbClr val="BED4EC"/>
             </a:solidFill>
           </a:ln>
         </p:spPr>
@@ -5146,14 +4891,14 @@
       </p:sp>
       <p:sp>
         <p:nvSpPr>
-          <p:cNvPr id="48" name="TextBox 47"/>
+          <p:cNvPr id="47" name="TextBox 46"/>
           <p:cNvSpPr txBox="1"/>
           <p:nvPr/>
         </p:nvSpPr>
         <p:spPr>
           <a:xfrm>
-            <a:off x="429768" y="4544568"/>
-            <a:ext cx="4352544" cy="1088136"/>
+            <a:off x="429768" y="3419856"/>
+            <a:ext cx="3063240" cy="201168"/>
           </a:xfrm>
           <a:prstGeom prst="rect">
             <a:avLst/>
@@ -5161,19 +4906,35 @@
           <a:noFill/>
         </p:spPr>
         <p:txBody>
-          <a:bodyPr wrap="square" lIns="45720" rIns="45720">
+          <a:bodyPr wrap="square" lIns="0" rIns="0" tIns="0" bIns="0">
             <a:spAutoFit/>
           </a:bodyPr>
           <a:lstStyle/>
           <a:p>
             <a:r>
-              <a:rPr sz="1100" b="1">
-                <a:solidFill>
-                  <a:srgbClr val="115E59"/>
-                </a:solidFill>
-                <a:latin typeface="Microsoft YaHei"/>
-              </a:rPr>
-              <a:t>关键实现约定</a:t>
+              <a:rPr sz="1000" b="1">
+                <a:solidFill>
+                  <a:srgbClr val="1D4F91"/>
+                </a:solidFill>
+                <a:latin typeface="Microsoft YaHei"/>
+              </a:rPr>
+              <a:t>支柱Ⅰ：引用怎么写</a:t>
+            </a:r>
+          </a:p>
+          <a:p>
+            <a:pPr>
+              <a:spcAft>
+                <a:spcPts val="0"/>
+              </a:spcAft>
+            </a:pPr>
+            <a:r>
+              <a:rPr sz="840" b="1">
+                <a:solidFill>
+                  <a:srgbClr val="15231F"/>
+                </a:solidFill>
+                <a:latin typeface="Microsoft YaHei"/>
+              </a:rPr>
+              <a:t>两类引用，同一管道</a:t>
             </a:r>
           </a:p>
           <a:p>
@@ -5183,13 +4944,13 @@
               </a:spcAft>
             </a:pPr>
             <a:r>
-              <a:rPr sz="819" b="0">
+              <a:rPr sz="780" b="0">
                 <a:solidFill>
                   <a:srgbClr val="15231F"/>
                 </a:solidFill>
                 <a:latin typeface="Microsoft YaHei"/>
               </a:rPr>
-              <a:t>• 结果默认写入Workmemory；查询可兼容全量结果集 → 工具适配视图</a:t>
+              <a:t>• 结果引用 ${a1b2c3d4.fileUri} → 工作记忆</a:t>
             </a:r>
           </a:p>
           <a:p>
@@ -5199,13 +4960,29 @@
               </a:spcAft>
             </a:pPr>
             <a:r>
-              <a:rPr sz="819" b="0">
+              <a:rPr sz="780" b="0">
                 <a:solidFill>
                   <a:srgbClr val="15231F"/>
                 </a:solidFill>
                 <a:latin typeface="Microsoft YaHei"/>
               </a:rPr>
-              <a:t>• resultId为模型侧短标识；内部toolCallId继续用于追踪</a:t>
+              <a:t>• 语义引用 ${app.抖音.bundleName} → 词典</a:t>
+            </a:r>
+          </a:p>
+          <a:p>
+            <a:pPr>
+              <a:spcAft>
+                <a:spcPts val="0"/>
+              </a:spcAft>
+            </a:pPr>
+            <a:r>
+              <a:rPr sz="840" b="1">
+                <a:solidFill>
+                  <a:srgbClr val="15231F"/>
+                </a:solidFill>
+                <a:latin typeface="Microsoft YaHei"/>
+              </a:rPr>
+              <a:t>两种可见性</a:t>
             </a:r>
           </a:p>
           <a:p>
@@ -5215,37 +4992,53 @@
               </a:spcAft>
             </a:pPr>
             <a:r>
-              <a:rPr sz="819" b="0">
+              <a:rPr sz="780" b="0">
                 <a:solidFill>
                   <a:srgbClr val="15231F"/>
                 </a:solidFill>
                 <a:latin typeface="Microsoft YaHei"/>
               </a:rPr>
-              <a:t>• 通用mask字段（fileUri/fileId等）支持工具级覆盖</a:t>
-            </a:r>
-          </a:p>
-        </p:txBody>
-      </p:sp>
-      <p:sp>
-        <p:nvSpPr>
-          <p:cNvPr id="49" name="Rounded Rectangle 48"/>
+              <a:t>• 不用看值：mask后所见即所填</a:t>
+            </a:r>
+          </a:p>
+          <a:p>
+            <a:pPr>
+              <a:spcAft>
+                <a:spcPts val="100"/>
+              </a:spcAft>
+            </a:pPr>
+            <a:r>
+              <a:rPr sz="780" b="0">
+                <a:solidFill>
+                  <a:srgbClr val="15231F"/>
+                </a:solidFill>
+                <a:latin typeface="Microsoft YaHei"/>
+              </a:rPr>
+              <a:t>• 需要看值：内容供推理，入参仍写引用</a:t>
+            </a:r>
+          </a:p>
+        </p:txBody>
+      </p:sp>
+      <p:sp>
+        <p:nvSpPr>
+          <p:cNvPr id="48" name="Rounded Rectangle 47"/>
           <p:cNvSpPr/>
           <p:nvPr/>
         </p:nvSpPr>
         <p:spPr>
           <a:xfrm>
-            <a:off x="5001768" y="4471416"/>
-            <a:ext cx="3154680" cy="1234440"/>
+            <a:off x="3657600" y="3364992"/>
+            <a:ext cx="3840480" cy="2011680"/>
           </a:xfrm>
           <a:prstGeom prst="roundRect">
             <a:avLst/>
           </a:prstGeom>
           <a:solidFill>
-            <a:srgbClr val="ECF8F4"/>
+            <a:srgbClr val="FFF7E4"/>
           </a:solidFill>
           <a:ln w="12700">
             <a:solidFill>
-              <a:srgbClr val="CFDBD5"/>
+              <a:srgbClr val="EBD79B"/>
             </a:solidFill>
           </a:ln>
         </p:spPr>
@@ -5273,14 +5066,14 @@
       </p:sp>
       <p:sp>
         <p:nvSpPr>
-          <p:cNvPr id="50" name="TextBox 49"/>
+          <p:cNvPr id="49" name="TextBox 48"/>
           <p:cNvSpPr txBox="1"/>
           <p:nvPr/>
         </p:nvSpPr>
         <p:spPr>
           <a:xfrm>
-            <a:off x="5111496" y="4544568"/>
-            <a:ext cx="2935224" cy="1088136"/>
+            <a:off x="3767328" y="3419856"/>
+            <a:ext cx="3657600" cy="201168"/>
           </a:xfrm>
           <a:prstGeom prst="rect">
             <a:avLst/>
@@ -5288,19 +5081,35 @@
           <a:noFill/>
         </p:spPr>
         <p:txBody>
-          <a:bodyPr wrap="square" lIns="45720" rIns="45720">
+          <a:bodyPr wrap="square" lIns="0" rIns="0" tIns="0" bIns="0">
             <a:spAutoFit/>
           </a:bodyPr>
           <a:lstStyle/>
           <a:p>
             <a:r>
-              <a:rPr sz="1100" b="1">
-                <a:solidFill>
-                  <a:srgbClr val="115E59"/>
-                </a:solidFill>
-                <a:latin typeface="Microsoft YaHei"/>
-              </a:rPr>
-              <a:t>核心收益</a:t>
+              <a:rPr sz="1000" b="1">
+                <a:solidFill>
+                  <a:srgbClr val="8A5A00"/>
+                </a:solidFill>
+                <a:latin typeface="Microsoft YaHei"/>
+              </a:rPr>
+              <a:t>支柱Ⅱ：真值怎么来</a:t>
+            </a:r>
+          </a:p>
+          <a:p>
+            <a:pPr>
+              <a:spcAft>
+                <a:spcPts val="0"/>
+              </a:spcAft>
+            </a:pPr>
+            <a:r>
+              <a:rPr sz="840" b="1">
+                <a:solidFill>
+                  <a:srgbClr val="15231F"/>
+                </a:solidFill>
+                <a:latin typeface="Microsoft YaHei"/>
+              </a:rPr>
+              <a:t>可信数据源</a:t>
             </a:r>
           </a:p>
           <a:p>
@@ -5310,13 +5119,13 @@
               </a:spcAft>
             </a:pPr>
             <a:r>
-              <a:rPr sz="830" b="0">
+              <a:rPr sz="780" b="0">
                 <a:solidFill>
                   <a:srgbClr val="15231F"/>
                 </a:solidFill>
                 <a:latin typeface="Microsoft YaHei"/>
               </a:rPr>
-              <a:t>• 降Input Token与串行时延</a:t>
+              <a:t>• 工作记忆：全量结果集 → 工具适配视图</a:t>
             </a:r>
           </a:p>
           <a:p>
@@ -5326,13 +5135,29 @@
               </a:spcAft>
             </a:pPr>
             <a:r>
-              <a:rPr sz="830" b="0">
+              <a:rPr sz="780" b="0">
                 <a:solidFill>
                   <a:srgbClr val="15231F"/>
                 </a:solidFill>
                 <a:latin typeface="Microsoft YaHei"/>
               </a:rPr>
-              <a:t>• 减少长值抄错和业务标识幻觉</a:t>
+              <a:t>• 语义词典：别名归一表 + 实体属性映射表</a:t>
+            </a:r>
+          </a:p>
+          <a:p>
+            <a:pPr>
+              <a:spcAft>
+                <a:spcPts val="0"/>
+              </a:spcAft>
+            </a:pPr>
+            <a:r>
+              <a:rPr sz="840" b="1">
+                <a:solidFill>
+                  <a:srgbClr val="15231F"/>
+                </a:solidFill>
+                <a:latin typeface="Microsoft YaHei"/>
+              </a:rPr>
+              <a:t>结构适配（Policy）</a:t>
             </a:r>
           </a:p>
           <a:p>
@@ -5342,27 +5167,43 @@
               </a:spcAft>
             </a:pPr>
             <a:r>
-              <a:rPr sz="830" b="0">
+              <a:rPr sz="780" b="0">
                 <a:solidFill>
                   <a:srgbClr val="15231F"/>
                 </a:solidFill>
                 <a:latin typeface="Microsoft YaHei"/>
               </a:rPr>
-              <a:t>• 热路径少一次查询Loop；工具零改动</a:t>
-            </a:r>
-          </a:p>
-        </p:txBody>
-      </p:sp>
-      <p:sp>
-        <p:nvSpPr>
-          <p:cNvPr id="51" name="Rounded Rectangle 50"/>
+              <a:t>• ${rid.merged_id_list} → [563,728]</a:t>
+            </a:r>
+          </a:p>
+          <a:p>
+            <a:pPr>
+              <a:spcAft>
+                <a:spcPts val="100"/>
+              </a:spcAft>
+            </a:pPr>
+            <a:r>
+              <a:rPr sz="780" b="0">
+                <a:solidFill>
+                  <a:srgbClr val="15231F"/>
+                </a:solidFill>
+                <a:latin typeface="Microsoft YaHei"/>
+              </a:rPr>
+              <a:t>• → [{"file_id":"563"}, {"file_id":"728"}]</a:t>
+            </a:r>
+          </a:p>
+        </p:txBody>
+      </p:sp>
+      <p:sp>
+        <p:nvSpPr>
+          <p:cNvPr id="50" name="Rounded Rectangle 49"/>
           <p:cNvSpPr/>
           <p:nvPr/>
         </p:nvSpPr>
         <p:spPr>
           <a:xfrm>
-            <a:off x="8266175" y="4471416"/>
-            <a:ext cx="3602736" cy="1234440"/>
+            <a:off x="7589520" y="3364992"/>
+            <a:ext cx="4279392" cy="2011680"/>
           </a:xfrm>
           <a:prstGeom prst="roundRect">
             <a:avLst/>
@@ -5372,7 +5213,7 @@
           </a:solidFill>
           <a:ln w="12700">
             <a:solidFill>
-              <a:srgbClr val="CFDBD5"/>
+              <a:srgbClr val="E7C4CC"/>
             </a:solidFill>
           </a:ln>
         </p:spPr>
@@ -5400,14 +5241,14 @@
       </p:sp>
       <p:sp>
         <p:nvSpPr>
-          <p:cNvPr id="52" name="TextBox 51"/>
+          <p:cNvPr id="51" name="TextBox 50"/>
           <p:cNvSpPr txBox="1"/>
           <p:nvPr/>
         </p:nvSpPr>
         <p:spPr>
           <a:xfrm>
-            <a:off x="8375903" y="4544568"/>
-            <a:ext cx="3383280" cy="1088136"/>
+            <a:off x="7699248" y="3419856"/>
+            <a:ext cx="4096512" cy="201168"/>
           </a:xfrm>
           <a:prstGeom prst="rect">
             <a:avLst/>
@@ -5415,19 +5256,35 @@
           <a:noFill/>
         </p:spPr>
         <p:txBody>
-          <a:bodyPr wrap="square" lIns="45720" rIns="45720">
+          <a:bodyPr wrap="square" lIns="0" rIns="0" tIns="0" bIns="0">
             <a:spAutoFit/>
           </a:bodyPr>
           <a:lstStyle/>
           <a:p>
             <a:r>
-              <a:rPr sz="1100" b="1">
-                <a:solidFill>
-                  <a:srgbClr val="115E59"/>
-                </a:solidFill>
-                <a:latin typeface="Microsoft YaHei"/>
-              </a:rPr>
-              <a:t>边界与兜底</a:t>
+              <a:rPr sz="1000" b="1">
+                <a:solidFill>
+                  <a:srgbClr val="8B3144"/>
+                </a:solidFill>
+                <a:latin typeface="Microsoft YaHei"/>
+              </a:rPr>
+              <a:t>支柱Ⅲ：错误怎么兜</a:t>
+            </a:r>
+          </a:p>
+          <a:p>
+            <a:pPr>
+              <a:spcAft>
+                <a:spcPts val="0"/>
+              </a:spcAft>
+            </a:pPr>
+            <a:r>
+              <a:rPr sz="840" b="1">
+                <a:solidFill>
+                  <a:srgbClr val="15231F"/>
+                </a:solidFill>
+                <a:latin typeface="Microsoft YaHei"/>
+              </a:rPr>
+              <a:t>硬约束（Runtime）</a:t>
             </a:r>
           </a:p>
           <a:p>
@@ -5437,13 +5294,13 @@
               </a:spcAft>
             </a:pPr>
             <a:r>
-              <a:rPr sz="819" b="0">
+              <a:rPr sz="780" b="0">
                 <a:solidFill>
                   <a:srgbClr val="15231F"/>
                 </a:solidFill>
                 <a:latin typeface="Microsoft YaHei"/>
               </a:rPr>
-              <a:t>• 多候选不静默猜：返回候选/动态枚举</a:t>
+              <a:t>• 解析/映射/转换/Schema失败即短路，禁止${…}透传</a:t>
             </a:r>
           </a:p>
           <a:p>
@@ -5453,13 +5310,29 @@
               </a:spcAft>
             </a:pPr>
             <a:r>
-              <a:rPr sz="819" b="0">
+              <a:rPr sz="780" b="0">
                 <a:solidFill>
                   <a:srgbClr val="15231F"/>
                 </a:solidFill>
                 <a:latin typeface="Microsoft YaHei"/>
               </a:rPr>
-              <a:t>• 未命中可查询并在确认后刷新映射</a:t>
+              <a:t>• 作用域与权限由Runtime校验，模型无权决定</a:t>
+            </a:r>
+          </a:p>
+          <a:p>
+            <a:pPr>
+              <a:spcAft>
+                <a:spcPts val="0"/>
+              </a:spcAft>
+            </a:pPr>
+            <a:r>
+              <a:rPr sz="840" b="1">
+                <a:solidFill>
+                  <a:srgbClr val="15231F"/>
+                </a:solidFill>
+                <a:latin typeface="Microsoft YaHei"/>
+              </a:rPr>
+              <a:t>可恢复（兜底）</a:t>
             </a:r>
           </a:p>
           <a:p>
@@ -5469,94 +5342,42 @@
               </a:spcAft>
             </a:pPr>
             <a:r>
-              <a:rPr sz="819" b="0">
+              <a:rPr sz="780" b="0">
                 <a:solidFill>
                   <a:srgbClr val="15231F"/>
                 </a:solidFill>
                 <a:latin typeface="Microsoft YaHei"/>
               </a:rPr>
-              <a:t>• 并行链路必须显式引用，不用含糊“上一条”</a:t>
-            </a:r>
-          </a:p>
-        </p:txBody>
-      </p:sp>
-      <p:sp>
-        <p:nvSpPr>
-          <p:cNvPr id="53" name="TextBox 52"/>
-          <p:cNvSpPr txBox="1"/>
-          <p:nvPr/>
-        </p:nvSpPr>
-        <p:spPr>
-          <a:xfrm>
-            <a:off x="365760" y="5925312"/>
-            <a:ext cx="8869680" cy="256032"/>
-          </a:xfrm>
-          <a:prstGeom prst="rect">
-            <a:avLst/>
-          </a:prstGeom>
-          <a:noFill/>
-        </p:spPr>
-        <p:txBody>
-          <a:bodyPr wrap="square" lIns="0" rIns="0" tIns="0" bIns="0">
-            <a:spAutoFit/>
-          </a:bodyPr>
-          <a:lstStyle/>
-          <a:p>
-            <a:r>
-              <a:rPr sz="930" b="1">
-                <a:solidFill>
-                  <a:srgbClr val="115E59"/>
-                </a:solidFill>
-                <a:latin typeface="Microsoft YaHei"/>
-              </a:rPr>
-              <a:t>一句话：模型只决定“引用哪个对象/结果”，Runtime保证“真实、适配、合法”后再执行。</a:t>
-            </a:r>
-          </a:p>
-        </p:txBody>
-      </p:sp>
-      <p:sp>
-        <p:nvSpPr>
-          <p:cNvPr id="54" name="TextBox 53"/>
-          <p:cNvSpPr txBox="1"/>
-          <p:nvPr/>
-        </p:nvSpPr>
-        <p:spPr>
-          <a:xfrm>
-            <a:off x="9006840" y="5925312"/>
-            <a:ext cx="2834640" cy="256032"/>
-          </a:xfrm>
-          <a:prstGeom prst="rect">
-            <a:avLst/>
-          </a:prstGeom>
-          <a:noFill/>
-        </p:spPr>
-        <p:txBody>
-          <a:bodyPr wrap="square" lIns="0" rIns="0" tIns="0" bIns="0">
-            <a:spAutoFit/>
-          </a:bodyPr>
-          <a:lstStyle/>
-          <a:p>
+              <a:t>• 多候选返回列表/动态枚举，不静默猜</a:t>
+            </a:r>
+          </a:p>
+          <a:p>
+            <a:pPr>
+              <a:spcAft>
+                <a:spcPts val="100"/>
+              </a:spcAft>
+            </a:pPr>
             <a:r>
               <a:rPr sz="780" b="0">
                 <a:solidFill>
-                  <a:srgbClr val="60706A"/>
-                </a:solidFill>
-                <a:latin typeface="Microsoft YaHei"/>
-              </a:rPr>
-              <a:t>Reference → Resolve → Transform → Validate → Invoke</a:t>
-            </a:r>
-          </a:p>
-        </p:txBody>
-      </p:sp>
-      <p:sp>
-        <p:nvSpPr>
-          <p:cNvPr id="55" name="Rectangle 54"/>
+                  <a:srgbClr val="15231F"/>
+                </a:solidFill>
+                <a:latin typeface="Microsoft YaHei"/>
+              </a:rPr>
+              <a:t>• 未命中→查询工具→确认后刷新映射→重试</a:t>
+            </a:r>
+          </a:p>
+        </p:txBody>
+      </p:sp>
+      <p:sp>
+        <p:nvSpPr>
+          <p:cNvPr id="52" name="Rectangle 51"/>
           <p:cNvSpPr/>
           <p:nvPr/>
         </p:nvSpPr>
         <p:spPr>
           <a:xfrm>
-            <a:off x="320040" y="5824728"/>
+            <a:off x="320040" y="5504688"/>
             <a:ext cx="11548872" cy="13716"/>
           </a:xfrm>
           <a:prstGeom prst="rect">
@@ -5565,7 +5386,7 @@
           <a:solidFill>
             <a:srgbClr val="CFDBD5"/>
           </a:solidFill>
-          <a:ln>
+          <a:ln w="6350">
             <a:noFill/>
           </a:ln>
         </p:spPr>
@@ -5588,6 +5409,321 @@
           <a:lstStyle/>
           <a:p>
             <a:pPr algn="ctr"/>
+          </a:p>
+        </p:txBody>
+      </p:sp>
+      <p:sp>
+        <p:nvSpPr>
+          <p:cNvPr id="53" name="TextBox 52"/>
+          <p:cNvSpPr txBox="1"/>
+          <p:nvPr/>
+        </p:nvSpPr>
+        <p:spPr>
+          <a:xfrm>
+            <a:off x="320040" y="5596128"/>
+            <a:ext cx="2834640" cy="219456"/>
+          </a:xfrm>
+          <a:prstGeom prst="rect">
+            <a:avLst/>
+          </a:prstGeom>
+          <a:noFill/>
+        </p:spPr>
+        <p:txBody>
+          <a:bodyPr wrap="square" lIns="0" rIns="0" tIns="0" bIns="0">
+            <a:spAutoFit/>
+          </a:bodyPr>
+          <a:lstStyle/>
+          <a:p>
+            <a:pPr algn="ctr"/>
+            <a:r>
+              <a:rPr sz="1100" b="1">
+                <a:solidFill>
+                  <a:srgbClr val="115E59"/>
+                </a:solidFill>
+                <a:latin typeface="Microsoft YaHei"/>
+              </a:rPr>
+              <a:t>省Token</a:t>
+            </a:r>
+          </a:p>
+        </p:txBody>
+      </p:sp>
+      <p:sp>
+        <p:nvSpPr>
+          <p:cNvPr id="54" name="TextBox 53"/>
+          <p:cNvSpPr txBox="1"/>
+          <p:nvPr/>
+        </p:nvSpPr>
+        <p:spPr>
+          <a:xfrm>
+            <a:off x="320040" y="5833872"/>
+            <a:ext cx="2834640" cy="219456"/>
+          </a:xfrm>
+          <a:prstGeom prst="rect">
+            <a:avLst/>
+          </a:prstGeom>
+          <a:noFill/>
+        </p:spPr>
+        <p:txBody>
+          <a:bodyPr wrap="square" lIns="0" rIns="0" tIns="0" bIns="0">
+            <a:spAutoFit/>
+          </a:bodyPr>
+          <a:lstStyle/>
+          <a:p>
+            <a:pPr algn="ctr"/>
+            <a:r>
+              <a:rPr sz="800" b="0">
+                <a:solidFill>
+                  <a:srgbClr val="60706A"/>
+                </a:solidFill>
+                <a:latin typeface="Microsoft YaHei"/>
+              </a:rPr>
+              <a:t>长值不回灌不复述，降输入与时延</a:t>
+            </a:r>
+          </a:p>
+        </p:txBody>
+      </p:sp>
+      <p:sp>
+        <p:nvSpPr>
+          <p:cNvPr id="55" name="TextBox 54"/>
+          <p:cNvSpPr txBox="1"/>
+          <p:nvPr/>
+        </p:nvSpPr>
+        <p:spPr>
+          <a:xfrm>
+            <a:off x="3227832" y="5596128"/>
+            <a:ext cx="2834640" cy="219456"/>
+          </a:xfrm>
+          <a:prstGeom prst="rect">
+            <a:avLst/>
+          </a:prstGeom>
+          <a:noFill/>
+        </p:spPr>
+        <p:txBody>
+          <a:bodyPr wrap="square" lIns="0" rIns="0" tIns="0" bIns="0">
+            <a:spAutoFit/>
+          </a:bodyPr>
+          <a:lstStyle/>
+          <a:p>
+            <a:pPr algn="ctr"/>
+            <a:r>
+              <a:rPr sz="1100" b="1">
+                <a:solidFill>
+                  <a:srgbClr val="115E59"/>
+                </a:solidFill>
+                <a:latin typeface="Microsoft YaHei"/>
+              </a:rPr>
+              <a:t>消幻觉</a:t>
+            </a:r>
+          </a:p>
+        </p:txBody>
+      </p:sp>
+      <p:sp>
+        <p:nvSpPr>
+          <p:cNvPr id="56" name="TextBox 55"/>
+          <p:cNvSpPr txBox="1"/>
+          <p:nvPr/>
+        </p:nvSpPr>
+        <p:spPr>
+          <a:xfrm>
+            <a:off x="3227832" y="5833872"/>
+            <a:ext cx="2834640" cy="219456"/>
+          </a:xfrm>
+          <a:prstGeom prst="rect">
+            <a:avLst/>
+          </a:prstGeom>
+          <a:noFill/>
+        </p:spPr>
+        <p:txBody>
+          <a:bodyPr wrap="square" lIns="0" rIns="0" tIns="0" bIns="0">
+            <a:spAutoFit/>
+          </a:bodyPr>
+          <a:lstStyle/>
+          <a:p>
+            <a:pPr algn="ctr"/>
+            <a:r>
+              <a:rPr sz="800" b="0">
+                <a:solidFill>
+                  <a:srgbClr val="60706A"/>
+                </a:solidFill>
+                <a:latin typeface="Microsoft YaHei"/>
+              </a:rPr>
+              <a:t>真值只出自查表，标识不再编造</a:t>
+            </a:r>
+          </a:p>
+        </p:txBody>
+      </p:sp>
+      <p:sp>
+        <p:nvSpPr>
+          <p:cNvPr id="57" name="TextBox 56"/>
+          <p:cNvSpPr txBox="1"/>
+          <p:nvPr/>
+        </p:nvSpPr>
+        <p:spPr>
+          <a:xfrm>
+            <a:off x="6135624" y="5596128"/>
+            <a:ext cx="2834640" cy="219456"/>
+          </a:xfrm>
+          <a:prstGeom prst="rect">
+            <a:avLst/>
+          </a:prstGeom>
+          <a:noFill/>
+        </p:spPr>
+        <p:txBody>
+          <a:bodyPr wrap="square" lIns="0" rIns="0" tIns="0" bIns="0">
+            <a:spAutoFit/>
+          </a:bodyPr>
+          <a:lstStyle/>
+          <a:p>
+            <a:pPr algn="ctr"/>
+            <a:r>
+              <a:rPr sz="1100" b="1">
+                <a:solidFill>
+                  <a:srgbClr val="115E59"/>
+                </a:solidFill>
+                <a:latin typeface="Microsoft YaHei"/>
+              </a:rPr>
+              <a:t>少一轮</a:t>
+            </a:r>
+          </a:p>
+        </p:txBody>
+      </p:sp>
+      <p:sp>
+        <p:nvSpPr>
+          <p:cNvPr id="58" name="TextBox 57"/>
+          <p:cNvSpPr txBox="1"/>
+          <p:nvPr/>
+        </p:nvSpPr>
+        <p:spPr>
+          <a:xfrm>
+            <a:off x="6135624" y="5833872"/>
+            <a:ext cx="2834640" cy="219456"/>
+          </a:xfrm>
+          <a:prstGeom prst="rect">
+            <a:avLst/>
+          </a:prstGeom>
+          <a:noFill/>
+        </p:spPr>
+        <p:txBody>
+          <a:bodyPr wrap="square" lIns="0" rIns="0" tIns="0" bIns="0">
+            <a:spAutoFit/>
+          </a:bodyPr>
+          <a:lstStyle/>
+          <a:p>
+            <a:pPr algn="ctr"/>
+            <a:r>
+              <a:rPr sz="800" b="0">
+                <a:solidFill>
+                  <a:srgbClr val="60706A"/>
+                </a:solidFill>
+                <a:latin typeface="Microsoft YaHei"/>
+              </a:rPr>
+              <a:t>映射命中时业务调用1次Loop完成</a:t>
+            </a:r>
+          </a:p>
+        </p:txBody>
+      </p:sp>
+      <p:sp>
+        <p:nvSpPr>
+          <p:cNvPr id="59" name="TextBox 58"/>
+          <p:cNvSpPr txBox="1"/>
+          <p:nvPr/>
+        </p:nvSpPr>
+        <p:spPr>
+          <a:xfrm>
+            <a:off x="9043416" y="5596128"/>
+            <a:ext cx="2834640" cy="219456"/>
+          </a:xfrm>
+          <a:prstGeom prst="rect">
+            <a:avLst/>
+          </a:prstGeom>
+          <a:noFill/>
+        </p:spPr>
+        <p:txBody>
+          <a:bodyPr wrap="square" lIns="0" rIns="0" tIns="0" bIns="0">
+            <a:spAutoFit/>
+          </a:bodyPr>
+          <a:lstStyle/>
+          <a:p>
+            <a:pPr algn="ctr"/>
+            <a:r>
+              <a:rPr sz="1100" b="1">
+                <a:solidFill>
+                  <a:srgbClr val="115E59"/>
+                </a:solidFill>
+                <a:latin typeface="Microsoft YaHei"/>
+              </a:rPr>
+              <a:t>零改动</a:t>
+            </a:r>
+          </a:p>
+        </p:txBody>
+      </p:sp>
+      <p:sp>
+        <p:nvSpPr>
+          <p:cNvPr id="60" name="TextBox 59"/>
+          <p:cNvSpPr txBox="1"/>
+          <p:nvPr/>
+        </p:nvSpPr>
+        <p:spPr>
+          <a:xfrm>
+            <a:off x="9043416" y="5833872"/>
+            <a:ext cx="2834640" cy="219456"/>
+          </a:xfrm>
+          <a:prstGeom prst="rect">
+            <a:avLst/>
+          </a:prstGeom>
+          <a:noFill/>
+        </p:spPr>
+        <p:txBody>
+          <a:bodyPr wrap="square" lIns="0" rIns="0" tIns="0" bIns="0">
+            <a:spAutoFit/>
+          </a:bodyPr>
+          <a:lstStyle/>
+          <a:p>
+            <a:pPr algn="ctr"/>
+            <a:r>
+              <a:rPr sz="800" b="0">
+                <a:solidFill>
+                  <a:srgbClr val="60706A"/>
+                </a:solidFill>
+                <a:latin typeface="Microsoft YaHei"/>
+              </a:rPr>
+              <a:t>框架层统一生效，存量工具无感</a:t>
+            </a:r>
+          </a:p>
+        </p:txBody>
+      </p:sp>
+      <p:sp>
+        <p:nvSpPr>
+          <p:cNvPr id="61" name="TextBox 60"/>
+          <p:cNvSpPr txBox="1"/>
+          <p:nvPr/>
+        </p:nvSpPr>
+        <p:spPr>
+          <a:xfrm>
+            <a:off x="320040" y="6199632"/>
+            <a:ext cx="11548872" cy="274320"/>
+          </a:xfrm>
+          <a:prstGeom prst="rect">
+            <a:avLst/>
+          </a:prstGeom>
+          <a:noFill/>
+        </p:spPr>
+        <p:txBody>
+          <a:bodyPr wrap="square" lIns="0" rIns="0" tIns="0" bIns="0">
+            <a:spAutoFit/>
+          </a:bodyPr>
+          <a:lstStyle/>
+          <a:p>
+            <a:pPr algn="ctr"/>
+            <a:r>
+              <a:rPr sz="1000" b="1">
+                <a:solidFill>
+                  <a:srgbClr val="115E59"/>
+                </a:solidFill>
+                <a:latin typeface="Microsoft YaHei"/>
+              </a:rPr>
+              <a:t>一句话：模型决定“引用哪个对象”，Runtime保证“真实、适配、合法”后再执行。</a:t>
+            </a:r>
           </a:p>
         </p:txBody>
       </p:sp>

</xml_diff>

<commit_message>
docs: restyle one-page scheme with editorial typography
Co-authored-by: Lizzy67 <Lizzy67@users.noreply.github.com>
</commit_message>
<xml_diff>
--- a/docs/tool_param_ref_onepage.pptx
+++ b/docs/tool_param_ref_onepage.pptx
@@ -3139,8 +3139,8 @@
         </p:nvSpPr>
         <p:spPr>
           <a:xfrm>
-            <a:off x="320040" y="137160"/>
-            <a:ext cx="6400800" cy="310896"/>
+            <a:off x="566928" y="274320"/>
+            <a:ext cx="11057839" cy="182880"/>
           </a:xfrm>
           <a:prstGeom prst="rect">
             <a:avLst/>
@@ -3153,14 +3153,22 @@
           </a:bodyPr>
           <a:lstStyle/>
           <a:p>
-            <a:r>
-              <a:rPr sz="1900" b="1">
-                <a:solidFill>
-                  <a:srgbClr val="115E59"/>
+            <a:pPr algn="l">
+              <a:lnSpc>
+                <a:spcPct val="115000"/>
+              </a:lnSpc>
+              <a:spcAft>
+                <a:spcPts val="200"/>
+              </a:spcAft>
+            </a:pPr>
+            <a:r>
+              <a:rPr sz="900" b="1">
+                <a:solidFill>
+                  <a:srgbClr val="0E6F66"/>
                 </a:solidFill>
                 <a:latin typeface="Microsoft YaHei"/>
               </a:rPr>
-              <a:t>智能体工具参数引用方案</a:t>
+              <a:t>A G E N T · T O O L   C A L L I N G</a:t>
             </a:r>
           </a:p>
         </p:txBody>
@@ -3173,8 +3181,8 @@
         </p:nvSpPr>
         <p:spPr>
           <a:xfrm>
-            <a:off x="6858000" y="201168"/>
-            <a:ext cx="4983480" cy="274320"/>
+            <a:off x="566928" y="475488"/>
+            <a:ext cx="11057839" cy="384048"/>
           </a:xfrm>
           <a:prstGeom prst="rect">
             <a:avLst/>
@@ -3187,36 +3195,128 @@
           </a:bodyPr>
           <a:lstStyle/>
           <a:p>
-            <a:r>
-              <a:rPr sz="840" b="0">
-                <a:solidFill>
-                  <a:srgbClr val="60706A"/>
+            <a:pPr algn="l">
+              <a:lnSpc>
+                <a:spcPct val="115000"/>
+              </a:lnSpc>
+              <a:spcAft>
+                <a:spcPts val="200"/>
+              </a:spcAft>
+            </a:pPr>
+            <a:r>
+              <a:rPr sz="2150" b="1">
+                <a:solidFill>
+                  <a:srgbClr val="1C2925"/>
                 </a:solidFill>
                 <a:latin typeface="Microsoft YaHei"/>
               </a:rPr>
-              <a:t>结果引用 ${resultId.path}    语义引用 ${namespace.entity.attribute}</a:t>
-            </a:r>
-          </a:p>
-        </p:txBody>
-      </p:sp>
-      <p:sp>
-        <p:nvSpPr>
-          <p:cNvPr id="5" name="Rectangle 4"/>
+              <a:t>工具参数引用：让模型写「引用」，让 Runtime 填「真值」</a:t>
+            </a:r>
+          </a:p>
+        </p:txBody>
+      </p:sp>
+      <p:sp>
+        <p:nvSpPr>
+          <p:cNvPr id="5" name="TextBox 4"/>
+          <p:cNvSpPr txBox="1"/>
+          <p:nvPr/>
+        </p:nvSpPr>
+        <p:spPr>
+          <a:xfrm>
+            <a:off x="566928" y="896112"/>
+            <a:ext cx="10607040" cy="274320"/>
+          </a:xfrm>
+          <a:prstGeom prst="rect">
+            <a:avLst/>
+          </a:prstGeom>
+          <a:noFill/>
+        </p:spPr>
+        <p:txBody>
+          <a:bodyPr wrap="square" lIns="0" rIns="0" tIns="0" bIns="0">
+            <a:spAutoFit/>
+          </a:bodyPr>
+          <a:lstStyle/>
+          <a:p>
+            <a:pPr algn="l">
+              <a:lnSpc>
+                <a:spcPct val="115000"/>
+              </a:lnSpc>
+              <a:spcAft>
+                <a:spcPts val="200"/>
+              </a:spcAft>
+            </a:pPr>
+            <a:r>
+              <a:rPr sz="1050" b="0">
+                <a:solidFill>
+                  <a:srgbClr val="1C2925"/>
+                </a:solidFill>
+                <a:latin typeface="Microsoft YaHei"/>
+              </a:rPr>
+              <a:t>工具入参不再由模型亲手写出真实值，而是写一个引用；Runtime 在工具执行前查表求值、按需转换、校验合法，再去调用工具。</a:t>
+            </a:r>
+          </a:p>
+        </p:txBody>
+      </p:sp>
+      <p:sp>
+        <p:nvSpPr>
+          <p:cNvPr id="6" name="TextBox 5"/>
+          <p:cNvSpPr txBox="1"/>
+          <p:nvPr/>
+        </p:nvSpPr>
+        <p:spPr>
+          <a:xfrm>
+            <a:off x="566928" y="1133856"/>
+            <a:ext cx="10607040" cy="219456"/>
+          </a:xfrm>
+          <a:prstGeom prst="rect">
+            <a:avLst/>
+          </a:prstGeom>
+          <a:noFill/>
+        </p:spPr>
+        <p:txBody>
+          <a:bodyPr wrap="square" lIns="0" rIns="0" tIns="0" bIns="0">
+            <a:spAutoFit/>
+          </a:bodyPr>
+          <a:lstStyle/>
+          <a:p>
+            <a:pPr algn="l">
+              <a:lnSpc>
+                <a:spcPct val="115000"/>
+              </a:lnSpc>
+              <a:spcAft>
+                <a:spcPts val="200"/>
+              </a:spcAft>
+            </a:pPr>
+            <a:r>
+              <a:rPr sz="1050" b="1">
+                <a:solidFill>
+                  <a:srgbClr val="0B544E"/>
+                </a:solidFill>
+                <a:latin typeface="Microsoft YaHei"/>
+              </a:rPr>
+              <a:t>真值始终出自可信数据源，存量工具一行不改。</a:t>
+            </a:r>
+          </a:p>
+        </p:txBody>
+      </p:sp>
+      <p:sp>
+        <p:nvSpPr>
+          <p:cNvPr id="7" name="Rectangle 6"/>
           <p:cNvSpPr/>
           <p:nvPr/>
         </p:nvSpPr>
         <p:spPr>
           <a:xfrm>
-            <a:off x="320040" y="512064"/>
-            <a:ext cx="11548872" cy="32004"/>
+            <a:off x="566928" y="1444752"/>
+            <a:ext cx="11057839" cy="20320"/>
           </a:xfrm>
           <a:prstGeom prst="rect">
             <a:avLst/>
           </a:prstGeom>
           <a:solidFill>
-            <a:srgbClr val="0F766E"/>
+            <a:srgbClr val="1C2925"/>
           </a:solidFill>
-          <a:ln w="6350">
+          <a:ln>
             <a:noFill/>
           </a:ln>
         </p:spPr>
@@ -3244,25 +3344,362 @@
       </p:sp>
       <p:sp>
         <p:nvSpPr>
-          <p:cNvPr id="6" name="Rounded Rectangle 5"/>
+          <p:cNvPr id="8" name="TextBox 7"/>
+          <p:cNvSpPr txBox="1"/>
+          <p:nvPr/>
+        </p:nvSpPr>
+        <p:spPr>
+          <a:xfrm>
+            <a:off x="566928" y="1591056"/>
+            <a:ext cx="502920" cy="219456"/>
+          </a:xfrm>
+          <a:prstGeom prst="rect">
+            <a:avLst/>
+          </a:prstGeom>
+          <a:noFill/>
+        </p:spPr>
+        <p:txBody>
+          <a:bodyPr wrap="square" lIns="0" rIns="0" tIns="0" bIns="0">
+            <a:spAutoFit/>
+          </a:bodyPr>
+          <a:lstStyle/>
+          <a:p>
+            <a:pPr algn="l">
+              <a:lnSpc>
+                <a:spcPct val="115000"/>
+              </a:lnSpc>
+              <a:spcAft>
+                <a:spcPts val="200"/>
+              </a:spcAft>
+            </a:pPr>
+            <a:r>
+              <a:rPr sz="1100" b="1">
+                <a:solidFill>
+                  <a:srgbClr val="0E6F66"/>
+                </a:solidFill>
+                <a:latin typeface="Microsoft YaHei"/>
+              </a:rPr>
+              <a:t>01</a:t>
+            </a:r>
+          </a:p>
+        </p:txBody>
+      </p:sp>
+      <p:sp>
+        <p:nvSpPr>
+          <p:cNvPr id="9" name="TextBox 8"/>
+          <p:cNvSpPr txBox="1"/>
+          <p:nvPr/>
+        </p:nvSpPr>
+        <p:spPr>
+          <a:xfrm>
+            <a:off x="1042416" y="1577340"/>
+            <a:ext cx="3108960" cy="237744"/>
+          </a:xfrm>
+          <a:prstGeom prst="rect">
+            <a:avLst/>
+          </a:prstGeom>
+          <a:noFill/>
+        </p:spPr>
+        <p:txBody>
+          <a:bodyPr wrap="square" lIns="0" rIns="0" tIns="0" bIns="0">
+            <a:spAutoFit/>
+          </a:bodyPr>
+          <a:lstStyle/>
+          <a:p>
+            <a:pPr algn="l">
+              <a:lnSpc>
+                <a:spcPct val="115000"/>
+              </a:lnSpc>
+              <a:spcAft>
+                <a:spcPts val="200"/>
+              </a:spcAft>
+            </a:pPr>
+            <a:r>
+              <a:rPr sz="1300" b="1">
+                <a:solidFill>
+                  <a:srgbClr val="1C2925"/>
+                </a:solidFill>
+                <a:latin typeface="Microsoft YaHei"/>
+              </a:rPr>
+              <a:t>为什么要做</a:t>
+            </a:r>
+          </a:p>
+        </p:txBody>
+      </p:sp>
+      <p:sp>
+        <p:nvSpPr>
+          <p:cNvPr id="10" name="TextBox 9"/>
+          <p:cNvSpPr txBox="1"/>
+          <p:nvPr/>
+        </p:nvSpPr>
+        <p:spPr>
+          <a:xfrm>
+            <a:off x="566928" y="1847088"/>
+            <a:ext cx="11057839" cy="475488"/>
+          </a:xfrm>
+          <a:prstGeom prst="rect">
+            <a:avLst/>
+          </a:prstGeom>
+          <a:noFill/>
+        </p:spPr>
+        <p:txBody>
+          <a:bodyPr wrap="square" lIns="0" rIns="0" tIns="0" bIns="0">
+            <a:spAutoFit/>
+          </a:bodyPr>
+          <a:lstStyle/>
+          <a:p>
+            <a:pPr algn="l">
+              <a:lnSpc>
+                <a:spcPct val="130000"/>
+              </a:lnSpc>
+              <a:spcAft>
+                <a:spcPts val="200"/>
+              </a:spcAft>
+            </a:pPr>
+            <a:r>
+              <a:rPr sz="1000" b="0">
+                <a:solidFill>
+                  <a:srgbClr val="1C2925"/>
+                </a:solidFill>
+                <a:latin typeface="Microsoft YaHei"/>
+              </a:rPr>
+              <a:t>下一个工具的参数，常来自上一个工具的结果，或「抖音」这类口语名称背后的真实标识。这些值现在都靠模型亲手写：长 URI 抄着抄着就断了；包名靠记忆，就编出了 com.douyin.app；结构不一致时还要模型改写大段 JSON。抄写、回忆、改写——三件事模型都做不稳。</a:t>
+            </a:r>
+          </a:p>
+        </p:txBody>
+      </p:sp>
+      <p:sp>
+        <p:nvSpPr>
+          <p:cNvPr id="11" name="TextBox 10"/>
+          <p:cNvSpPr txBox="1"/>
+          <p:nvPr/>
+        </p:nvSpPr>
+        <p:spPr>
+          <a:xfrm>
+            <a:off x="566928" y="2395728"/>
+            <a:ext cx="11057839" cy="201168"/>
+          </a:xfrm>
+          <a:prstGeom prst="rect">
+            <a:avLst/>
+          </a:prstGeom>
+          <a:noFill/>
+        </p:spPr>
+        <p:txBody>
+          <a:bodyPr wrap="square" lIns="0" rIns="0" tIns="0" bIns="0">
+            <a:spAutoFit/>
+          </a:bodyPr>
+          <a:lstStyle/>
+          <a:p>
+            <a:pPr algn="l">
+              <a:lnSpc>
+                <a:spcPct val="115000"/>
+              </a:lnSpc>
+              <a:spcAft>
+                <a:spcPts val="200"/>
+              </a:spcAft>
+            </a:pPr>
+            <a:r>
+              <a:rPr sz="950" b="1">
+                <a:solidFill>
+                  <a:srgbClr val="1C2925"/>
+                </a:solidFill>
+                <a:latin typeface="Microsoft YaHei"/>
+              </a:rPr>
+              <a:t>抄不准 </a:t>
+            </a:r>
+            <a:r>
+              <a:rPr sz="950" b="0">
+                <a:solidFill>
+                  <a:srgbClr val="6B7A74"/>
+                </a:solidFill>
+                <a:latin typeface="Microsoft YaHei"/>
+              </a:rPr>
+              <a:t>长值复述易截断改写，抬高输入Token　　</a:t>
+            </a:r>
+            <a:r>
+              <a:rPr sz="950" b="1">
+                <a:solidFill>
+                  <a:srgbClr val="1C2925"/>
+                </a:solidFill>
+                <a:latin typeface="Microsoft YaHei"/>
+              </a:rPr>
+              <a:t>会编造 </a:t>
+            </a:r>
+            <a:r>
+              <a:rPr sz="950" b="0">
+                <a:solidFill>
+                  <a:srgbClr val="6B7A74"/>
+                </a:solidFill>
+                <a:latin typeface="Microsoft YaHei"/>
+              </a:rPr>
+              <a:t>弱语义标识凭记忆幻觉　　</a:t>
+            </a:r>
+            <a:r>
+              <a:rPr sz="950" b="1">
+                <a:solidFill>
+                  <a:srgbClr val="1C2925"/>
+                </a:solidFill>
+                <a:latin typeface="Microsoft YaHei"/>
+              </a:rPr>
+              <a:t>改不动 </a:t>
+            </a:r>
+            <a:r>
+              <a:rPr sz="950" b="0">
+                <a:solidFill>
+                  <a:srgbClr val="6B7A74"/>
+                </a:solidFill>
+                <a:latin typeface="Microsoft YaHei"/>
+              </a:rPr>
+              <a:t>结构适配靠模型或逐个改工具，都不划算</a:t>
+            </a:r>
+          </a:p>
+        </p:txBody>
+      </p:sp>
+      <p:sp>
+        <p:nvSpPr>
+          <p:cNvPr id="12" name="TextBox 11"/>
+          <p:cNvSpPr txBox="1"/>
+          <p:nvPr/>
+        </p:nvSpPr>
+        <p:spPr>
+          <a:xfrm>
+            <a:off x="566928" y="2761488"/>
+            <a:ext cx="502920" cy="219456"/>
+          </a:xfrm>
+          <a:prstGeom prst="rect">
+            <a:avLst/>
+          </a:prstGeom>
+          <a:noFill/>
+        </p:spPr>
+        <p:txBody>
+          <a:bodyPr wrap="square" lIns="0" rIns="0" tIns="0" bIns="0">
+            <a:spAutoFit/>
+          </a:bodyPr>
+          <a:lstStyle/>
+          <a:p>
+            <a:pPr algn="l">
+              <a:lnSpc>
+                <a:spcPct val="115000"/>
+              </a:lnSpc>
+              <a:spcAft>
+                <a:spcPts val="200"/>
+              </a:spcAft>
+            </a:pPr>
+            <a:r>
+              <a:rPr sz="1100" b="1">
+                <a:solidFill>
+                  <a:srgbClr val="0E6F66"/>
+                </a:solidFill>
+                <a:latin typeface="Microsoft YaHei"/>
+              </a:rPr>
+              <a:t>02</a:t>
+            </a:r>
+          </a:p>
+        </p:txBody>
+      </p:sp>
+      <p:sp>
+        <p:nvSpPr>
+          <p:cNvPr id="13" name="TextBox 12"/>
+          <p:cNvSpPr txBox="1"/>
+          <p:nvPr/>
+        </p:nvSpPr>
+        <p:spPr>
+          <a:xfrm>
+            <a:off x="1042416" y="2747772"/>
+            <a:ext cx="3108960" cy="237744"/>
+          </a:xfrm>
+          <a:prstGeom prst="rect">
+            <a:avLst/>
+          </a:prstGeom>
+          <a:noFill/>
+        </p:spPr>
+        <p:txBody>
+          <a:bodyPr wrap="square" lIns="0" rIns="0" tIns="0" bIns="0">
+            <a:spAutoFit/>
+          </a:bodyPr>
+          <a:lstStyle/>
+          <a:p>
+            <a:pPr algn="l">
+              <a:lnSpc>
+                <a:spcPct val="115000"/>
+              </a:lnSpc>
+              <a:spcAft>
+                <a:spcPts val="200"/>
+              </a:spcAft>
+            </a:pPr>
+            <a:r>
+              <a:rPr sz="1300" b="1">
+                <a:solidFill>
+                  <a:srgbClr val="1C2925"/>
+                </a:solidFill>
+                <a:latin typeface="Microsoft YaHei"/>
+              </a:rPr>
+              <a:t>方案主链路</a:t>
+            </a:r>
+          </a:p>
+        </p:txBody>
+      </p:sp>
+      <p:sp>
+        <p:nvSpPr>
+          <p:cNvPr id="14" name="TextBox 13"/>
+          <p:cNvSpPr txBox="1"/>
+          <p:nvPr/>
+        </p:nvSpPr>
+        <p:spPr>
+          <a:xfrm>
+            <a:off x="4133087" y="2779776"/>
+            <a:ext cx="7863840" cy="219456"/>
+          </a:xfrm>
+          <a:prstGeom prst="rect">
+            <a:avLst/>
+          </a:prstGeom>
+          <a:noFill/>
+        </p:spPr>
+        <p:txBody>
+          <a:bodyPr wrap="square" lIns="0" rIns="0" tIns="0" bIns="0">
+            <a:spAutoFit/>
+          </a:bodyPr>
+          <a:lstStyle/>
+          <a:p>
+            <a:pPr algn="l">
+              <a:lnSpc>
+                <a:spcPct val="115000"/>
+              </a:lnSpc>
+              <a:spcAft>
+                <a:spcPts val="200"/>
+              </a:spcAft>
+            </a:pPr>
+            <a:r>
+              <a:rPr sz="900" b="0">
+                <a:solidFill>
+                  <a:srgbClr val="9AA8A2"/>
+                </a:solidFill>
+                <a:latin typeface="Microsoft YaHei"/>
+              </a:rPr>
+              <a:t>Reference → Resolve → Invoke，全部发生在工具执行之前</a:t>
+            </a:r>
+          </a:p>
+        </p:txBody>
+      </p:sp>
+      <p:sp>
+        <p:nvSpPr>
+          <p:cNvPr id="15" name="Rectangle 14"/>
           <p:cNvSpPr/>
           <p:nvPr/>
         </p:nvSpPr>
         <p:spPr>
           <a:xfrm>
-            <a:off x="320040" y="640080"/>
-            <a:ext cx="5623560" cy="1024128"/>
-          </a:xfrm>
-          <a:prstGeom prst="roundRect">
+            <a:off x="566928" y="3035808"/>
+            <a:ext cx="2029968" cy="27940"/>
+          </a:xfrm>
+          <a:prstGeom prst="rect">
             <a:avLst/>
           </a:prstGeom>
           <a:solidFill>
-            <a:srgbClr val="FFF0F3"/>
+            <a:srgbClr val="0E6F66"/>
           </a:solidFill>
-          <a:ln w="12700">
-            <a:solidFill>
-              <a:srgbClr val="E7C4CC"/>
-            </a:solidFill>
+          <a:ln>
+            <a:noFill/>
           </a:ln>
         </p:spPr>
         <p:style>
@@ -3289,141 +3726,23 @@
       </p:sp>
       <p:sp>
         <p:nvSpPr>
-          <p:cNvPr id="7" name="TextBox 6"/>
-          <p:cNvSpPr txBox="1"/>
-          <p:nvPr/>
-        </p:nvSpPr>
-        <p:spPr>
-          <a:xfrm>
-            <a:off x="429768" y="694944"/>
-            <a:ext cx="5440680" cy="201168"/>
-          </a:xfrm>
-          <a:prstGeom prst="rect">
-            <a:avLst/>
-          </a:prstGeom>
-          <a:noFill/>
-        </p:spPr>
-        <p:txBody>
-          <a:bodyPr wrap="square" lIns="0" rIns="0" tIns="0" bIns="0">
-            <a:spAutoFit/>
-          </a:bodyPr>
-          <a:lstStyle/>
-          <a:p>
-            <a:r>
-              <a:rPr sz="1050" b="1">
-                <a:solidFill>
-                  <a:srgbClr val="8B3144"/>
-                </a:solidFill>
-                <a:latin typeface="Microsoft YaHei"/>
-              </a:rPr>
-              <a:t>问题：模型直接生成业务真值不可靠</a:t>
-            </a:r>
-          </a:p>
-          <a:p>
-            <a:pPr>
-              <a:spcAft>
-                <a:spcPts val="100"/>
-              </a:spcAft>
-            </a:pPr>
-            <a:r>
-              <a:rPr sz="819" b="0">
-                <a:solidFill>
-                  <a:srgbClr val="15231F"/>
-                </a:solidFill>
-                <a:latin typeface="Microsoft YaHei"/>
-              </a:rPr>
-              <a:t>• 抄不准：长URI/列表照抄易截断改写，Token高</a:t>
-            </a:r>
-          </a:p>
-          <a:p>
-            <a:pPr>
-              <a:spcAft>
-                <a:spcPts val="100"/>
-              </a:spcAft>
-            </a:pPr>
-            <a:r>
-              <a:rPr sz="819" b="0">
-                <a:solidFill>
-                  <a:srgbClr val="15231F"/>
-                </a:solidFill>
-                <a:latin typeface="Microsoft YaHei"/>
-              </a:rPr>
-              <a:t>• 会编造：包名等弱语义标识凭记忆幻觉</a:t>
-            </a:r>
-          </a:p>
-          <a:p>
-            <a:pPr>
-              <a:spcAft>
-                <a:spcPts val="100"/>
-              </a:spcAft>
-            </a:pPr>
-            <a:r>
-              <a:rPr sz="819" b="0">
-                <a:solidFill>
-                  <a:srgbClr val="15231F"/>
-                </a:solidFill>
-                <a:latin typeface="Microsoft YaHei"/>
-              </a:rPr>
-              <a:t>• 改不动：上下游Schema不同，改长JSON不稳、改工具成本高</a:t>
-            </a:r>
-          </a:p>
-        </p:txBody>
-      </p:sp>
-      <p:sp>
-        <p:nvSpPr>
-          <p:cNvPr id="8" name="TextBox 7"/>
-          <p:cNvSpPr txBox="1"/>
-          <p:nvPr/>
-        </p:nvSpPr>
-        <p:spPr>
-          <a:xfrm>
-            <a:off x="5961888" y="987552"/>
-            <a:ext cx="310896" cy="329184"/>
-          </a:xfrm>
-          <a:prstGeom prst="rect">
-            <a:avLst/>
-          </a:prstGeom>
-          <a:noFill/>
-        </p:spPr>
-        <p:txBody>
-          <a:bodyPr wrap="square" lIns="0" rIns="0" tIns="0" bIns="0">
-            <a:spAutoFit/>
-          </a:bodyPr>
-          <a:lstStyle/>
-          <a:p>
-            <a:r>
-              <a:rPr sz="1800" b="1">
-                <a:solidFill>
-                  <a:srgbClr val="0F766E"/>
-                </a:solidFill>
-                <a:latin typeface="Microsoft YaHei"/>
-              </a:rPr>
-              <a:t>→</a:t>
-            </a:r>
-          </a:p>
-        </p:txBody>
-      </p:sp>
-      <p:sp>
-        <p:nvSpPr>
-          <p:cNvPr id="9" name="Rounded Rectangle 8"/>
+          <p:cNvPr id="16" name="Rectangle 15"/>
           <p:cNvSpPr/>
           <p:nvPr/>
         </p:nvSpPr>
         <p:spPr>
           <a:xfrm>
-            <a:off x="6291072" y="640080"/>
-            <a:ext cx="5577840" cy="1024128"/>
-          </a:xfrm>
-          <a:prstGeom prst="roundRect">
+            <a:off x="566928" y="3063239"/>
+            <a:ext cx="2029968" cy="932688"/>
+          </a:xfrm>
+          <a:prstGeom prst="rect">
             <a:avLst/>
           </a:prstGeom>
           <a:solidFill>
-            <a:srgbClr val="ECF8F4"/>
+            <a:srgbClr val="F4F8F6"/>
           </a:solidFill>
-          <a:ln w="12700">
-            <a:solidFill>
-              <a:srgbClr val="BCDED4"/>
-            </a:solidFill>
+          <a:ln>
+            <a:noFill/>
           </a:ln>
         </p:spPr>
         <p:style>
@@ -3450,14 +3769,14 @@
       </p:sp>
       <p:sp>
         <p:nvSpPr>
-          <p:cNvPr id="10" name="TextBox 9"/>
+          <p:cNvPr id="17" name="TextBox 16"/>
           <p:cNvSpPr txBox="1"/>
           <p:nvPr/>
         </p:nvSpPr>
         <p:spPr>
           <a:xfrm>
-            <a:off x="6400800" y="694944"/>
-            <a:ext cx="5394960" cy="201168"/>
+            <a:off x="658368" y="3127248"/>
+            <a:ext cx="1847088" cy="155448"/>
           </a:xfrm>
           <a:prstGeom prst="rect">
             <a:avLst/>
@@ -3470,87 +3789,171 @@
           </a:bodyPr>
           <a:lstStyle/>
           <a:p>
-            <a:r>
-              <a:rPr sz="1050" b="1">
-                <a:solidFill>
-                  <a:srgbClr val="115E59"/>
+            <a:pPr algn="l">
+              <a:lnSpc>
+                <a:spcPct val="115000"/>
+              </a:lnSpc>
+              <a:spcAft>
+                <a:spcPts val="200"/>
+              </a:spcAft>
+            </a:pPr>
+            <a:r>
+              <a:rPr sz="800" b="1">
+                <a:solidFill>
+                  <a:srgbClr val="9AA8A2"/>
                 </a:solidFill>
                 <a:latin typeface="Microsoft YaHei"/>
               </a:rPr>
-              <a:t>核心思路：职责分离</a:t>
-            </a:r>
-          </a:p>
-          <a:p>
-            <a:pPr>
+              <a:t>工具 A</a:t>
+            </a:r>
+          </a:p>
+        </p:txBody>
+      </p:sp>
+      <p:sp>
+        <p:nvSpPr>
+          <p:cNvPr id="18" name="TextBox 17"/>
+          <p:cNvSpPr txBox="1"/>
+          <p:nvPr/>
+        </p:nvSpPr>
+        <p:spPr>
+          <a:xfrm>
+            <a:off x="658368" y="3291839"/>
+            <a:ext cx="1847088" cy="182880"/>
+          </a:xfrm>
+          <a:prstGeom prst="rect">
+            <a:avLst/>
+          </a:prstGeom>
+          <a:noFill/>
+        </p:spPr>
+        <p:txBody>
+          <a:bodyPr wrap="square" lIns="0" rIns="0" tIns="0" bIns="0">
+            <a:spAutoFit/>
+          </a:bodyPr>
+          <a:lstStyle/>
+          <a:p>
+            <a:pPr algn="l">
+              <a:lnSpc>
+                <a:spcPct val="115000"/>
+              </a:lnSpc>
               <a:spcAft>
-                <a:spcPts val="100"/>
+                <a:spcPts val="200"/>
               </a:spcAft>
             </a:pPr>
             <a:r>
-              <a:rPr sz="880" b="1">
-                <a:solidFill>
-                  <a:srgbClr val="15231F"/>
+              <a:rPr sz="1050" b="1">
+                <a:solidFill>
+                  <a:srgbClr val="1C2925"/>
                 </a:solidFill>
                 <a:latin typeface="Microsoft YaHei"/>
               </a:rPr>
-              <a:t>模型只表达“引用谁”，Runtime负责“取真值、做适配、保合法”</a:t>
-            </a:r>
-          </a:p>
-          <a:p>
-            <a:pPr>
+              <a:t>结果入库</a:t>
+            </a:r>
+          </a:p>
+        </p:txBody>
+      </p:sp>
+      <p:sp>
+        <p:nvSpPr>
+          <p:cNvPr id="19" name="TextBox 18"/>
+          <p:cNvSpPr txBox="1"/>
+          <p:nvPr/>
+        </p:nvSpPr>
+        <p:spPr>
+          <a:xfrm>
+            <a:off x="658368" y="3493008"/>
+            <a:ext cx="1847088" cy="457200"/>
+          </a:xfrm>
+          <a:prstGeom prst="rect">
+            <a:avLst/>
+          </a:prstGeom>
+          <a:noFill/>
+        </p:spPr>
+        <p:txBody>
+          <a:bodyPr wrap="square" lIns="0" rIns="0" tIns="0" bIns="0">
+            <a:spAutoFit/>
+          </a:bodyPr>
+          <a:lstStyle/>
+          <a:p>
+            <a:pPr algn="l">
+              <a:lnSpc>
+                <a:spcPct val="120000"/>
+              </a:lnSpc>
               <a:spcAft>
-                <a:spcPts val="100"/>
+                <a:spcPts val="200"/>
               </a:spcAft>
             </a:pPr>
             <a:r>
-              <a:rPr sz="819" b="0">
-                <a:solidFill>
-                  <a:srgbClr val="15231F"/>
+              <a:rPr sz="830" b="0">
+                <a:solidFill>
+                  <a:srgbClr val="6B7A74"/>
                 </a:solidFill>
                 <a:latin typeface="Microsoft YaHei"/>
               </a:rPr>
-              <a:t>• 真值只来自可信数据源（工作记忆 / 语义词典）</a:t>
-            </a:r>
-          </a:p>
-          <a:p>
-            <a:pPr>
+              <a:t>返回结果写入工作记忆，得到短标识 resultId</a:t>
+            </a:r>
+          </a:p>
+        </p:txBody>
+      </p:sp>
+      <p:sp>
+        <p:nvSpPr>
+          <p:cNvPr id="20" name="TextBox 19"/>
+          <p:cNvSpPr txBox="1"/>
+          <p:nvPr/>
+        </p:nvSpPr>
+        <p:spPr>
+          <a:xfrm>
+            <a:off x="2610612" y="3383279"/>
+            <a:ext cx="201168" cy="237744"/>
+          </a:xfrm>
+          <a:prstGeom prst="rect">
+            <a:avLst/>
+          </a:prstGeom>
+          <a:noFill/>
+        </p:spPr>
+        <p:txBody>
+          <a:bodyPr wrap="square" lIns="0" rIns="0" tIns="0" bIns="0">
+            <a:spAutoFit/>
+          </a:bodyPr>
+          <a:lstStyle/>
+          <a:p>
+            <a:pPr algn="ctr">
+              <a:lnSpc>
+                <a:spcPct val="115000"/>
+              </a:lnSpc>
               <a:spcAft>
-                <a:spcPts val="100"/>
+                <a:spcPts val="200"/>
               </a:spcAft>
             </a:pPr>
             <a:r>
-              <a:rPr sz="819" b="0">
-                <a:solidFill>
-                  <a:srgbClr val="15231F"/>
+              <a:rPr sz="1200" b="1">
+                <a:solidFill>
+                  <a:srgbClr val="0E6F66"/>
                 </a:solidFill>
                 <a:latin typeface="Microsoft YaHei"/>
               </a:rPr>
-              <a:t>• 全部处理收敛在工具执行前统一入口，工具零改动</a:t>
-            </a:r>
-          </a:p>
-        </p:txBody>
-      </p:sp>
-      <p:sp>
-        <p:nvSpPr>
-          <p:cNvPr id="11" name="Rounded Rectangle 10"/>
+              <a:t>→</a:t>
+            </a:r>
+          </a:p>
+        </p:txBody>
+      </p:sp>
+      <p:sp>
+        <p:nvSpPr>
+          <p:cNvPr id="21" name="Rectangle 20"/>
           <p:cNvSpPr/>
           <p:nvPr/>
         </p:nvSpPr>
         <p:spPr>
           <a:xfrm>
-            <a:off x="320040" y="1773936"/>
-            <a:ext cx="11548872" cy="1481328"/>
-          </a:xfrm>
-          <a:prstGeom prst="roundRect">
+            <a:off x="2816352" y="3035808"/>
+            <a:ext cx="2029968" cy="27940"/>
+          </a:xfrm>
+          <a:prstGeom prst="rect">
             <a:avLst/>
           </a:prstGeom>
           <a:solidFill>
-            <a:srgbClr val="F5FBF8"/>
+            <a:srgbClr val="0E6F66"/>
           </a:solidFill>
-          <a:ln w="15240">
-            <a:solidFill>
-              <a:srgbClr val="0F766E"/>
-            </a:solidFill>
+          <a:ln>
+            <a:noFill/>
           </a:ln>
         </p:spPr>
         <p:style>
@@ -3577,59 +3980,23 @@
       </p:sp>
       <p:sp>
         <p:nvSpPr>
-          <p:cNvPr id="12" name="TextBox 11"/>
-          <p:cNvSpPr txBox="1"/>
-          <p:nvPr/>
-        </p:nvSpPr>
-        <p:spPr>
-          <a:xfrm>
-            <a:off x="429768" y="1828800"/>
-            <a:ext cx="4572000" cy="201168"/>
-          </a:xfrm>
-          <a:prstGeom prst="rect">
-            <a:avLst/>
-          </a:prstGeom>
-          <a:noFill/>
-        </p:spPr>
-        <p:txBody>
-          <a:bodyPr wrap="square" lIns="0" rIns="0" tIns="0" bIns="0">
-            <a:spAutoFit/>
-          </a:bodyPr>
-          <a:lstStyle/>
-          <a:p>
-            <a:r>
-              <a:rPr sz="1050" b="1">
-                <a:solidFill>
-                  <a:srgbClr val="115E59"/>
-                </a:solidFill>
-                <a:latin typeface="Microsoft YaHei"/>
-              </a:rPr>
-              <a:t>主链路：Reference → Resolve → Invoke</a:t>
-            </a:r>
-          </a:p>
-        </p:txBody>
-      </p:sp>
-      <p:sp>
-        <p:nvSpPr>
-          <p:cNvPr id="13" name="Rounded Rectangle 12"/>
+          <p:cNvPr id="22" name="Rectangle 21"/>
           <p:cNvSpPr/>
           <p:nvPr/>
         </p:nvSpPr>
         <p:spPr>
           <a:xfrm>
-            <a:off x="429768" y="2084831"/>
-            <a:ext cx="3200400" cy="1097280"/>
-          </a:xfrm>
-          <a:prstGeom prst="roundRect">
+            <a:off x="2816352" y="3063239"/>
+            <a:ext cx="2029968" cy="932688"/>
+          </a:xfrm>
+          <a:prstGeom prst="rect">
             <a:avLst/>
           </a:prstGeom>
           <a:solidFill>
-            <a:srgbClr val="EDF4FC"/>
+            <a:srgbClr val="F4F8F6"/>
           </a:solidFill>
-          <a:ln w="12700">
-            <a:solidFill>
-              <a:srgbClr val="EDF4FC"/>
-            </a:solidFill>
+          <a:ln>
+            <a:noFill/>
           </a:ln>
         </p:spPr>
         <p:style>
@@ -3656,14 +4023,14 @@
       </p:sp>
       <p:sp>
         <p:nvSpPr>
-          <p:cNvPr id="14" name="TextBox 13"/>
+          <p:cNvPr id="23" name="TextBox 22"/>
           <p:cNvSpPr txBox="1"/>
           <p:nvPr/>
         </p:nvSpPr>
         <p:spPr>
           <a:xfrm>
-            <a:off x="429768" y="2112263"/>
-            <a:ext cx="3200400" cy="182880"/>
+            <a:off x="2907792" y="3127248"/>
+            <a:ext cx="1847088" cy="155448"/>
           </a:xfrm>
           <a:prstGeom prst="rect">
             <a:avLst/>
@@ -3676,40 +4043,171 @@
           </a:bodyPr>
           <a:lstStyle/>
           <a:p>
-            <a:pPr algn="ctr"/>
-            <a:r>
-              <a:rPr sz="840" b="1">
-                <a:solidFill>
-                  <a:srgbClr val="1D4F91"/>
+            <a:pPr algn="l">
+              <a:lnSpc>
+                <a:spcPct val="115000"/>
+              </a:lnSpc>
+              <a:spcAft>
+                <a:spcPts val="200"/>
+              </a:spcAft>
+            </a:pPr>
+            <a:r>
+              <a:rPr sz="800" b="1">
+                <a:solidFill>
+                  <a:srgbClr val="9AA8A2"/>
                 </a:solidFill>
                 <a:latin typeface="Microsoft YaHei"/>
               </a:rPr>
-              <a:t>Ⅰ 引用表达（模型侧）</a:t>
-            </a:r>
-          </a:p>
-        </p:txBody>
-      </p:sp>
-      <p:sp>
-        <p:nvSpPr>
-          <p:cNvPr id="15" name="Rounded Rectangle 14"/>
+              <a:t>Runtime</a:t>
+            </a:r>
+          </a:p>
+        </p:txBody>
+      </p:sp>
+      <p:sp>
+        <p:nvSpPr>
+          <p:cNvPr id="24" name="TextBox 23"/>
+          <p:cNvSpPr txBox="1"/>
+          <p:nvPr/>
+        </p:nvSpPr>
+        <p:spPr>
+          <a:xfrm>
+            <a:off x="2907792" y="3291839"/>
+            <a:ext cx="1847088" cy="182880"/>
+          </a:xfrm>
+          <a:prstGeom prst="rect">
+            <a:avLst/>
+          </a:prstGeom>
+          <a:noFill/>
+        </p:spPr>
+        <p:txBody>
+          <a:bodyPr wrap="square" lIns="0" rIns="0" tIns="0" bIns="0">
+            <a:spAutoFit/>
+          </a:bodyPr>
+          <a:lstStyle/>
+          <a:p>
+            <a:pPr algn="l">
+              <a:lnSpc>
+                <a:spcPct val="115000"/>
+              </a:lnSpc>
+              <a:spcAft>
+                <a:spcPts val="200"/>
+              </a:spcAft>
+            </a:pPr>
+            <a:r>
+              <a:rPr sz="1050" b="1">
+                <a:solidFill>
+                  <a:srgbClr val="1C2925"/>
+                </a:solidFill>
+                <a:latin typeface="Microsoft YaHei"/>
+              </a:rPr>
+              <a:t>送模呈现</a:t>
+            </a:r>
+          </a:p>
+        </p:txBody>
+      </p:sp>
+      <p:sp>
+        <p:nvSpPr>
+          <p:cNvPr id="25" name="TextBox 24"/>
+          <p:cNvSpPr txBox="1"/>
+          <p:nvPr/>
+        </p:nvSpPr>
+        <p:spPr>
+          <a:xfrm>
+            <a:off x="2907792" y="3493008"/>
+            <a:ext cx="1847088" cy="457200"/>
+          </a:xfrm>
+          <a:prstGeom prst="rect">
+            <a:avLst/>
+          </a:prstGeom>
+          <a:noFill/>
+        </p:spPr>
+        <p:txBody>
+          <a:bodyPr wrap="square" lIns="0" rIns="0" tIns="0" bIns="0">
+            <a:spAutoFit/>
+          </a:bodyPr>
+          <a:lstStyle/>
+          <a:p>
+            <a:pPr algn="l">
+              <a:lnSpc>
+                <a:spcPct val="120000"/>
+              </a:lnSpc>
+              <a:spcAft>
+                <a:spcPts val="200"/>
+              </a:spcAft>
+            </a:pPr>
+            <a:r>
+              <a:rPr sz="830" b="0">
+                <a:solidFill>
+                  <a:srgbClr val="6B7A74"/>
+                </a:solidFill>
+                <a:latin typeface="Microsoft YaHei"/>
+              </a:rPr>
+              <a:t>指针字段直接换成引用给模型；要推理的内容照常给</a:t>
+            </a:r>
+          </a:p>
+        </p:txBody>
+      </p:sp>
+      <p:sp>
+        <p:nvSpPr>
+          <p:cNvPr id="26" name="TextBox 25"/>
+          <p:cNvSpPr txBox="1"/>
+          <p:nvPr/>
+        </p:nvSpPr>
+        <p:spPr>
+          <a:xfrm>
+            <a:off x="4860036" y="3383279"/>
+            <a:ext cx="201168" cy="237744"/>
+          </a:xfrm>
+          <a:prstGeom prst="rect">
+            <a:avLst/>
+          </a:prstGeom>
+          <a:noFill/>
+        </p:spPr>
+        <p:txBody>
+          <a:bodyPr wrap="square" lIns="0" rIns="0" tIns="0" bIns="0">
+            <a:spAutoFit/>
+          </a:bodyPr>
+          <a:lstStyle/>
+          <a:p>
+            <a:pPr algn="ctr">
+              <a:lnSpc>
+                <a:spcPct val="115000"/>
+              </a:lnSpc>
+              <a:spcAft>
+                <a:spcPts val="200"/>
+              </a:spcAft>
+            </a:pPr>
+            <a:r>
+              <a:rPr sz="1200" b="1">
+                <a:solidFill>
+                  <a:srgbClr val="0E6F66"/>
+                </a:solidFill>
+                <a:latin typeface="Microsoft YaHei"/>
+              </a:rPr>
+              <a:t>→</a:t>
+            </a:r>
+          </a:p>
+        </p:txBody>
+      </p:sp>
+      <p:sp>
+        <p:nvSpPr>
+          <p:cNvPr id="27" name="Rectangle 26"/>
           <p:cNvSpPr/>
           <p:nvPr/>
         </p:nvSpPr>
         <p:spPr>
           <a:xfrm>
-            <a:off x="3721608" y="2084831"/>
-            <a:ext cx="3200400" cy="1097280"/>
-          </a:xfrm>
-          <a:prstGeom prst="roundRect">
+            <a:off x="5065776" y="3035808"/>
+            <a:ext cx="2029968" cy="27940"/>
+          </a:xfrm>
+          <a:prstGeom prst="rect">
             <a:avLst/>
           </a:prstGeom>
           <a:solidFill>
-            <a:srgbClr val="FFF7E4"/>
+            <a:srgbClr val="0E6F66"/>
           </a:solidFill>
-          <a:ln w="12700">
-            <a:solidFill>
-              <a:srgbClr val="FFF7E4"/>
-            </a:solidFill>
+          <a:ln>
+            <a:noFill/>
           </a:ln>
         </p:spPr>
         <p:style>
@@ -3736,60 +4234,23 @@
       </p:sp>
       <p:sp>
         <p:nvSpPr>
-          <p:cNvPr id="16" name="TextBox 15"/>
-          <p:cNvSpPr txBox="1"/>
-          <p:nvPr/>
-        </p:nvSpPr>
-        <p:spPr>
-          <a:xfrm>
-            <a:off x="3721608" y="2112263"/>
-            <a:ext cx="3200400" cy="182880"/>
-          </a:xfrm>
-          <a:prstGeom prst="rect">
-            <a:avLst/>
-          </a:prstGeom>
-          <a:noFill/>
-        </p:spPr>
-        <p:txBody>
-          <a:bodyPr wrap="square" lIns="0" rIns="0" tIns="0" bIns="0">
-            <a:spAutoFit/>
-          </a:bodyPr>
-          <a:lstStyle/>
-          <a:p>
-            <a:pPr algn="ctr"/>
-            <a:r>
-              <a:rPr sz="840" b="1">
-                <a:solidFill>
-                  <a:srgbClr val="8A5A00"/>
-                </a:solidFill>
-                <a:latin typeface="Microsoft YaHei"/>
-              </a:rPr>
-              <a:t>Ⅱ 求值与适配（Runtime侧）</a:t>
-            </a:r>
-          </a:p>
-        </p:txBody>
-      </p:sp>
-      <p:sp>
-        <p:nvSpPr>
-          <p:cNvPr id="17" name="Rounded Rectangle 16"/>
+          <p:cNvPr id="28" name="Rectangle 27"/>
           <p:cNvSpPr/>
           <p:nvPr/>
         </p:nvSpPr>
         <p:spPr>
           <a:xfrm>
-            <a:off x="7013448" y="2084831"/>
-            <a:ext cx="4754880" cy="1097280"/>
-          </a:xfrm>
-          <a:prstGeom prst="roundRect">
+            <a:off x="5065776" y="3063239"/>
+            <a:ext cx="2029968" cy="932688"/>
+          </a:xfrm>
+          <a:prstGeom prst="rect">
             <a:avLst/>
           </a:prstGeom>
           <a:solidFill>
-            <a:srgbClr val="ECF8F4"/>
+            <a:srgbClr val="F4F8F6"/>
           </a:solidFill>
-          <a:ln w="12700">
-            <a:solidFill>
-              <a:srgbClr val="ECF8F4"/>
-            </a:solidFill>
+          <a:ln>
+            <a:noFill/>
           </a:ln>
         </p:spPr>
         <p:style>
@@ -3816,14 +4277,14 @@
       </p:sp>
       <p:sp>
         <p:nvSpPr>
-          <p:cNvPr id="18" name="TextBox 17"/>
+          <p:cNvPr id="29" name="TextBox 28"/>
           <p:cNvSpPr txBox="1"/>
           <p:nvPr/>
         </p:nvSpPr>
         <p:spPr>
           <a:xfrm>
-            <a:off x="7013448" y="2112263"/>
-            <a:ext cx="4754880" cy="182880"/>
+            <a:off x="5157216" y="3127248"/>
+            <a:ext cx="1847088" cy="155448"/>
           </a:xfrm>
           <a:prstGeom prst="rect">
             <a:avLst/>
@@ -3836,40 +4297,171 @@
           </a:bodyPr>
           <a:lstStyle/>
           <a:p>
-            <a:pPr algn="ctr"/>
-            <a:r>
-              <a:rPr sz="840" b="1">
-                <a:solidFill>
-                  <a:srgbClr val="115E59"/>
+            <a:pPr algn="l">
+              <a:lnSpc>
+                <a:spcPct val="115000"/>
+              </a:lnSpc>
+              <a:spcAft>
+                <a:spcPts val="200"/>
+              </a:spcAft>
+            </a:pPr>
+            <a:r>
+              <a:rPr sz="800" b="1">
+                <a:solidFill>
+                  <a:srgbClr val="9AA8A2"/>
                 </a:solidFill>
                 <a:latin typeface="Microsoft YaHei"/>
               </a:rPr>
-              <a:t>Ⅲ 校验与执行（工具侧）</a:t>
-            </a:r>
-          </a:p>
-        </p:txBody>
-      </p:sp>
-      <p:sp>
-        <p:nvSpPr>
-          <p:cNvPr id="19" name="Rounded Rectangle 18"/>
+              <a:t>模型</a:t>
+            </a:r>
+          </a:p>
+        </p:txBody>
+      </p:sp>
+      <p:sp>
+        <p:nvSpPr>
+          <p:cNvPr id="30" name="TextBox 29"/>
+          <p:cNvSpPr txBox="1"/>
+          <p:nvPr/>
+        </p:nvSpPr>
+        <p:spPr>
+          <a:xfrm>
+            <a:off x="5157216" y="3291839"/>
+            <a:ext cx="1847088" cy="182880"/>
+          </a:xfrm>
+          <a:prstGeom prst="rect">
+            <a:avLst/>
+          </a:prstGeom>
+          <a:noFill/>
+        </p:spPr>
+        <p:txBody>
+          <a:bodyPr wrap="square" lIns="0" rIns="0" tIns="0" bIns="0">
+            <a:spAutoFit/>
+          </a:bodyPr>
+          <a:lstStyle/>
+          <a:p>
+            <a:pPr algn="l">
+              <a:lnSpc>
+                <a:spcPct val="115000"/>
+              </a:lnSpc>
+              <a:spcAft>
+                <a:spcPts val="200"/>
+              </a:spcAft>
+            </a:pPr>
+            <a:r>
+              <a:rPr sz="1050" b="1">
+                <a:solidFill>
+                  <a:srgbClr val="1C2925"/>
+                </a:solidFill>
+                <a:latin typeface="Microsoft YaHei"/>
+              </a:rPr>
+              <a:t>只写引用</a:t>
+            </a:r>
+          </a:p>
+        </p:txBody>
+      </p:sp>
+      <p:sp>
+        <p:nvSpPr>
+          <p:cNvPr id="31" name="TextBox 30"/>
+          <p:cNvSpPr txBox="1"/>
+          <p:nvPr/>
+        </p:nvSpPr>
+        <p:spPr>
+          <a:xfrm>
+            <a:off x="5157216" y="3493008"/>
+            <a:ext cx="1847088" cy="457200"/>
+          </a:xfrm>
+          <a:prstGeom prst="rect">
+            <a:avLst/>
+          </a:prstGeom>
+          <a:noFill/>
+        </p:spPr>
+        <p:txBody>
+          <a:bodyPr wrap="square" lIns="0" rIns="0" tIns="0" bIns="0">
+            <a:spAutoFit/>
+          </a:bodyPr>
+          <a:lstStyle/>
+          <a:p>
+            <a:pPr algn="l">
+              <a:lnSpc>
+                <a:spcPct val="120000"/>
+              </a:lnSpc>
+              <a:spcAft>
+                <a:spcPts val="200"/>
+              </a:spcAft>
+            </a:pPr>
+            <a:r>
+              <a:rPr sz="830" b="0">
+                <a:solidFill>
+                  <a:srgbClr val="6B7A74"/>
+                </a:solidFill>
+                <a:latin typeface="Microsoft YaHei"/>
+              </a:rPr>
+              <a:t>下游参数填 ${…}，不复述真值，所见即所填</a:t>
+            </a:r>
+          </a:p>
+        </p:txBody>
+      </p:sp>
+      <p:sp>
+        <p:nvSpPr>
+          <p:cNvPr id="32" name="TextBox 31"/>
+          <p:cNvSpPr txBox="1"/>
+          <p:nvPr/>
+        </p:nvSpPr>
+        <p:spPr>
+          <a:xfrm>
+            <a:off x="7109459" y="3383279"/>
+            <a:ext cx="201168" cy="237744"/>
+          </a:xfrm>
+          <a:prstGeom prst="rect">
+            <a:avLst/>
+          </a:prstGeom>
+          <a:noFill/>
+        </p:spPr>
+        <p:txBody>
+          <a:bodyPr wrap="square" lIns="0" rIns="0" tIns="0" bIns="0">
+            <a:spAutoFit/>
+          </a:bodyPr>
+          <a:lstStyle/>
+          <a:p>
+            <a:pPr algn="ctr">
+              <a:lnSpc>
+                <a:spcPct val="115000"/>
+              </a:lnSpc>
+              <a:spcAft>
+                <a:spcPts val="200"/>
+              </a:spcAft>
+            </a:pPr>
+            <a:r>
+              <a:rPr sz="1200" b="1">
+                <a:solidFill>
+                  <a:srgbClr val="0E6F66"/>
+                </a:solidFill>
+                <a:latin typeface="Microsoft YaHei"/>
+              </a:rPr>
+              <a:t>→</a:t>
+            </a:r>
+          </a:p>
+        </p:txBody>
+      </p:sp>
+      <p:sp>
+        <p:nvSpPr>
+          <p:cNvPr id="33" name="Rectangle 32"/>
           <p:cNvSpPr/>
           <p:nvPr/>
         </p:nvSpPr>
         <p:spPr>
           <a:xfrm>
-            <a:off x="493776" y="2331720"/>
-            <a:ext cx="1481328" cy="768096"/>
-          </a:xfrm>
-          <a:prstGeom prst="roundRect">
+            <a:off x="7315200" y="3035808"/>
+            <a:ext cx="2029968" cy="27940"/>
+          </a:xfrm>
+          <a:prstGeom prst="rect">
             <a:avLst/>
           </a:prstGeom>
           <a:solidFill>
-            <a:srgbClr val="FFFFFF"/>
+            <a:srgbClr val="0E6F66"/>
           </a:solidFill>
-          <a:ln w="12700">
-            <a:solidFill>
-              <a:srgbClr val="CFDBD5"/>
-            </a:solidFill>
+          <a:ln>
+            <a:noFill/>
           </a:ln>
         </p:spPr>
         <p:style>
@@ -3896,127 +4488,23 @@
       </p:sp>
       <p:sp>
         <p:nvSpPr>
-          <p:cNvPr id="20" name="TextBox 19"/>
-          <p:cNvSpPr txBox="1"/>
-          <p:nvPr/>
-        </p:nvSpPr>
-        <p:spPr>
-          <a:xfrm>
-            <a:off x="548640" y="2377439"/>
-            <a:ext cx="1371600" cy="182880"/>
-          </a:xfrm>
-          <a:prstGeom prst="rect">
-            <a:avLst/>
-          </a:prstGeom>
-          <a:noFill/>
-        </p:spPr>
-        <p:txBody>
-          <a:bodyPr wrap="square" lIns="0" rIns="0" tIns="0" bIns="0">
-            <a:spAutoFit/>
-          </a:bodyPr>
-          <a:lstStyle/>
-          <a:p>
-            <a:r>
-              <a:rPr sz="819" b="1">
-                <a:solidFill>
-                  <a:srgbClr val="115E59"/>
-                </a:solidFill>
-                <a:latin typeface="Microsoft YaHei"/>
-              </a:rPr>
-              <a:t>① 结果入库</a:t>
-            </a:r>
-          </a:p>
-        </p:txBody>
-      </p:sp>
-      <p:sp>
-        <p:nvSpPr>
-          <p:cNvPr id="21" name="TextBox 20"/>
-          <p:cNvSpPr txBox="1"/>
-          <p:nvPr/>
-        </p:nvSpPr>
-        <p:spPr>
-          <a:xfrm>
-            <a:off x="548640" y="2578608"/>
-            <a:ext cx="1371600" cy="493776"/>
-          </a:xfrm>
-          <a:prstGeom prst="rect">
-            <a:avLst/>
-          </a:prstGeom>
-          <a:noFill/>
-        </p:spPr>
-        <p:txBody>
-          <a:bodyPr wrap="square" lIns="0" rIns="0" tIns="0" bIns="0">
-            <a:spAutoFit/>
-          </a:bodyPr>
-          <a:lstStyle/>
-          <a:p>
-            <a:r>
-              <a:rPr sz="740" b="0">
-                <a:solidFill>
-                  <a:srgbClr val="60706A"/>
-                </a:solidFill>
-                <a:latin typeface="Microsoft YaHei"/>
-              </a:rPr>
-              <a:t>工具A返回，写工作记忆并生成resultId</a:t>
-            </a:r>
-          </a:p>
-        </p:txBody>
-      </p:sp>
-      <p:sp>
-        <p:nvSpPr>
-          <p:cNvPr id="22" name="TextBox 21"/>
-          <p:cNvSpPr txBox="1"/>
-          <p:nvPr/>
-        </p:nvSpPr>
-        <p:spPr>
-          <a:xfrm>
-            <a:off x="1956816" y="2596896"/>
-            <a:ext cx="182880" cy="237744"/>
-          </a:xfrm>
-          <a:prstGeom prst="rect">
-            <a:avLst/>
-          </a:prstGeom>
-          <a:noFill/>
-        </p:spPr>
-        <p:txBody>
-          <a:bodyPr wrap="square" lIns="0" rIns="0" tIns="0" bIns="0">
-            <a:spAutoFit/>
-          </a:bodyPr>
-          <a:lstStyle/>
-          <a:p>
-            <a:r>
-              <a:rPr sz="1200" b="1">
-                <a:solidFill>
-                  <a:srgbClr val="0F766E"/>
-                </a:solidFill>
-                <a:latin typeface="Microsoft YaHei"/>
-              </a:rPr>
-              <a:t>→</a:t>
-            </a:r>
-          </a:p>
-        </p:txBody>
-      </p:sp>
-      <p:sp>
-        <p:nvSpPr>
-          <p:cNvPr id="23" name="Rounded Rectangle 22"/>
+          <p:cNvPr id="34" name="Rectangle 33"/>
           <p:cNvSpPr/>
           <p:nvPr/>
         </p:nvSpPr>
         <p:spPr>
           <a:xfrm>
-            <a:off x="2066543" y="2331720"/>
-            <a:ext cx="1481328" cy="768096"/>
-          </a:xfrm>
-          <a:prstGeom prst="roundRect">
+            <a:off x="7315200" y="3063239"/>
+            <a:ext cx="2029968" cy="932688"/>
+          </a:xfrm>
+          <a:prstGeom prst="rect">
             <a:avLst/>
           </a:prstGeom>
           <a:solidFill>
-            <a:srgbClr val="FFFFFF"/>
+            <a:srgbClr val="F4F8F6"/>
           </a:solidFill>
-          <a:ln w="12700">
-            <a:solidFill>
-              <a:srgbClr val="CFDBD5"/>
-            </a:solidFill>
+          <a:ln>
+            <a:noFill/>
           </a:ln>
         </p:spPr>
         <p:style>
@@ -4043,14 +4531,14 @@
       </p:sp>
       <p:sp>
         <p:nvSpPr>
-          <p:cNvPr id="24" name="TextBox 23"/>
+          <p:cNvPr id="35" name="TextBox 34"/>
           <p:cNvSpPr txBox="1"/>
           <p:nvPr/>
         </p:nvSpPr>
         <p:spPr>
           <a:xfrm>
-            <a:off x="2121408" y="2377439"/>
-            <a:ext cx="1371600" cy="182880"/>
+            <a:off x="7406640" y="3127248"/>
+            <a:ext cx="1847088" cy="155448"/>
           </a:xfrm>
           <a:prstGeom prst="rect">
             <a:avLst/>
@@ -4063,28 +4551,36 @@
           </a:bodyPr>
           <a:lstStyle/>
           <a:p>
-            <a:r>
-              <a:rPr sz="819" b="1">
-                <a:solidFill>
-                  <a:srgbClr val="115E59"/>
+            <a:pPr algn="l">
+              <a:lnSpc>
+                <a:spcPct val="115000"/>
+              </a:lnSpc>
+              <a:spcAft>
+                <a:spcPts val="200"/>
+              </a:spcAft>
+            </a:pPr>
+            <a:r>
+              <a:rPr sz="800" b="1">
+                <a:solidFill>
+                  <a:srgbClr val="9AA8A2"/>
                 </a:solidFill>
                 <a:latin typeface="Microsoft YaHei"/>
               </a:rPr>
-              <a:t>② 送模呈现</a:t>
-            </a:r>
-          </a:p>
-        </p:txBody>
-      </p:sp>
-      <p:sp>
-        <p:nvSpPr>
-          <p:cNvPr id="25" name="TextBox 24"/>
+              <a:t>Runtime</a:t>
+            </a:r>
+          </a:p>
+        </p:txBody>
+      </p:sp>
+      <p:sp>
+        <p:nvSpPr>
+          <p:cNvPr id="36" name="TextBox 35"/>
           <p:cNvSpPr txBox="1"/>
           <p:nvPr/>
         </p:nvSpPr>
         <p:spPr>
           <a:xfrm>
-            <a:off x="2121408" y="2578608"/>
-            <a:ext cx="1371600" cy="493776"/>
+            <a:off x="7406640" y="3291839"/>
+            <a:ext cx="1847088" cy="182880"/>
           </a:xfrm>
           <a:prstGeom prst="rect">
             <a:avLst/>
@@ -4097,28 +4593,36 @@
           </a:bodyPr>
           <a:lstStyle/>
           <a:p>
-            <a:r>
-              <a:rPr sz="740" b="0">
-                <a:solidFill>
-                  <a:srgbClr val="60706A"/>
+            <a:pPr algn="l">
+              <a:lnSpc>
+                <a:spcPct val="115000"/>
+              </a:lnSpc>
+              <a:spcAft>
+                <a:spcPts val="200"/>
+              </a:spcAft>
+            </a:pPr>
+            <a:r>
+              <a:rPr sz="1050" b="1">
+                <a:solidFill>
+                  <a:srgbClr val="1C2925"/>
                 </a:solidFill>
                 <a:latin typeface="Microsoft YaHei"/>
               </a:rPr>
-              <a:t>指针字段mask；要推理的留内容+引用</a:t>
-            </a:r>
-          </a:p>
-        </p:txBody>
-      </p:sp>
-      <p:sp>
-        <p:nvSpPr>
-          <p:cNvPr id="26" name="TextBox 25"/>
+              <a:t>求值·转换·校验</a:t>
+            </a:r>
+          </a:p>
+        </p:txBody>
+      </p:sp>
+      <p:sp>
+        <p:nvSpPr>
+          <p:cNvPr id="37" name="TextBox 36"/>
           <p:cNvSpPr txBox="1"/>
           <p:nvPr/>
         </p:nvSpPr>
         <p:spPr>
           <a:xfrm>
-            <a:off x="3529584" y="2596896"/>
-            <a:ext cx="182880" cy="237744"/>
+            <a:off x="7406640" y="3493008"/>
+            <a:ext cx="1847088" cy="457200"/>
           </a:xfrm>
           <a:prstGeom prst="rect">
             <a:avLst/>
@@ -4131,10 +4635,60 @@
           </a:bodyPr>
           <a:lstStyle/>
           <a:p>
+            <a:pPr algn="l">
+              <a:lnSpc>
+                <a:spcPct val="120000"/>
+              </a:lnSpc>
+              <a:spcAft>
+                <a:spcPts val="200"/>
+              </a:spcAft>
+            </a:pPr>
+            <a:r>
+              <a:rPr sz="830" b="0">
+                <a:solidFill>
+                  <a:srgbClr val="6B7A74"/>
+                </a:solidFill>
+                <a:latin typeface="Microsoft YaHei"/>
+              </a:rPr>
+              <a:t>查表回填真值，按策略适配结构，验完Schema与权限</a:t>
+            </a:r>
+          </a:p>
+        </p:txBody>
+      </p:sp>
+      <p:sp>
+        <p:nvSpPr>
+          <p:cNvPr id="38" name="TextBox 37"/>
+          <p:cNvSpPr txBox="1"/>
+          <p:nvPr/>
+        </p:nvSpPr>
+        <p:spPr>
+          <a:xfrm>
+            <a:off x="9358884" y="3383279"/>
+            <a:ext cx="201168" cy="237744"/>
+          </a:xfrm>
+          <a:prstGeom prst="rect">
+            <a:avLst/>
+          </a:prstGeom>
+          <a:noFill/>
+        </p:spPr>
+        <p:txBody>
+          <a:bodyPr wrap="square" lIns="0" rIns="0" tIns="0" bIns="0">
+            <a:spAutoFit/>
+          </a:bodyPr>
+          <a:lstStyle/>
+          <a:p>
+            <a:pPr algn="ctr">
+              <a:lnSpc>
+                <a:spcPct val="115000"/>
+              </a:lnSpc>
+              <a:spcAft>
+                <a:spcPts val="200"/>
+              </a:spcAft>
+            </a:pPr>
             <a:r>
               <a:rPr sz="1200" b="1">
                 <a:solidFill>
-                  <a:srgbClr val="0F766E"/>
+                  <a:srgbClr val="0E6F66"/>
                 </a:solidFill>
                 <a:latin typeface="Microsoft YaHei"/>
               </a:rPr>
@@ -4145,25 +4699,23 @@
       </p:sp>
       <p:sp>
         <p:nvSpPr>
-          <p:cNvPr id="27" name="Rounded Rectangle 26"/>
+          <p:cNvPr id="39" name="Rectangle 38"/>
           <p:cNvSpPr/>
           <p:nvPr/>
         </p:nvSpPr>
         <p:spPr>
           <a:xfrm>
-            <a:off x="3785616" y="2331720"/>
-            <a:ext cx="1481328" cy="768096"/>
-          </a:xfrm>
-          <a:prstGeom prst="roundRect">
+            <a:off x="9564624" y="3035808"/>
+            <a:ext cx="2029968" cy="27940"/>
+          </a:xfrm>
+          <a:prstGeom prst="rect">
             <a:avLst/>
           </a:prstGeom>
           <a:solidFill>
-            <a:srgbClr val="FFFFFF"/>
+            <a:srgbClr val="0E6F66"/>
           </a:solidFill>
-          <a:ln w="12700">
-            <a:solidFill>
-              <a:srgbClr val="CFDBD5"/>
-            </a:solidFill>
+          <a:ln>
+            <a:noFill/>
           </a:ln>
         </p:spPr>
         <p:style>
@@ -4190,127 +4742,23 @@
       </p:sp>
       <p:sp>
         <p:nvSpPr>
-          <p:cNvPr id="28" name="TextBox 27"/>
-          <p:cNvSpPr txBox="1"/>
-          <p:nvPr/>
-        </p:nvSpPr>
-        <p:spPr>
-          <a:xfrm>
-            <a:off x="3840480" y="2377439"/>
-            <a:ext cx="1371600" cy="182880"/>
-          </a:xfrm>
-          <a:prstGeom prst="rect">
-            <a:avLst/>
-          </a:prstGeom>
-          <a:noFill/>
-        </p:spPr>
-        <p:txBody>
-          <a:bodyPr wrap="square" lIns="0" rIns="0" tIns="0" bIns="0">
-            <a:spAutoFit/>
-          </a:bodyPr>
-          <a:lstStyle/>
-          <a:p>
-            <a:r>
-              <a:rPr sz="819" b="1">
-                <a:solidFill>
-                  <a:srgbClr val="115E59"/>
-                </a:solidFill>
-                <a:latin typeface="Microsoft YaHei"/>
-              </a:rPr>
-              <a:t>③ 模型填引用</a:t>
-            </a:r>
-          </a:p>
-        </p:txBody>
-      </p:sp>
-      <p:sp>
-        <p:nvSpPr>
-          <p:cNvPr id="29" name="TextBox 28"/>
-          <p:cNvSpPr txBox="1"/>
-          <p:nvPr/>
-        </p:nvSpPr>
-        <p:spPr>
-          <a:xfrm>
-            <a:off x="3840480" y="2578608"/>
-            <a:ext cx="1371600" cy="493776"/>
-          </a:xfrm>
-          <a:prstGeom prst="rect">
-            <a:avLst/>
-          </a:prstGeom>
-          <a:noFill/>
-        </p:spPr>
-        <p:txBody>
-          <a:bodyPr wrap="square" lIns="0" rIns="0" tIns="0" bIns="0">
-            <a:spAutoFit/>
-          </a:bodyPr>
-          <a:lstStyle/>
-          <a:p>
-            <a:r>
-              <a:rPr sz="740" b="0">
-                <a:solidFill>
-                  <a:srgbClr val="60706A"/>
-                </a:solidFill>
-                <a:latin typeface="Microsoft YaHei"/>
-              </a:rPr>
-              <a:t>下游入参写${…}，不复述真值</a:t>
-            </a:r>
-          </a:p>
-        </p:txBody>
-      </p:sp>
-      <p:sp>
-        <p:nvSpPr>
-          <p:cNvPr id="30" name="TextBox 29"/>
-          <p:cNvSpPr txBox="1"/>
-          <p:nvPr/>
-        </p:nvSpPr>
-        <p:spPr>
-          <a:xfrm>
-            <a:off x="5248656" y="2596896"/>
-            <a:ext cx="182880" cy="237744"/>
-          </a:xfrm>
-          <a:prstGeom prst="rect">
-            <a:avLst/>
-          </a:prstGeom>
-          <a:noFill/>
-        </p:spPr>
-        <p:txBody>
-          <a:bodyPr wrap="square" lIns="0" rIns="0" tIns="0" bIns="0">
-            <a:spAutoFit/>
-          </a:bodyPr>
-          <a:lstStyle/>
-          <a:p>
-            <a:r>
-              <a:rPr sz="1200" b="1">
-                <a:solidFill>
-                  <a:srgbClr val="0F766E"/>
-                </a:solidFill>
-                <a:latin typeface="Microsoft YaHei"/>
-              </a:rPr>
-              <a:t>→</a:t>
-            </a:r>
-          </a:p>
-        </p:txBody>
-      </p:sp>
-      <p:sp>
-        <p:nvSpPr>
-          <p:cNvPr id="31" name="Rounded Rectangle 30"/>
+          <p:cNvPr id="40" name="Rectangle 39"/>
           <p:cNvSpPr/>
           <p:nvPr/>
         </p:nvSpPr>
         <p:spPr>
           <a:xfrm>
-            <a:off x="5358384" y="2331720"/>
-            <a:ext cx="1481328" cy="768096"/>
-          </a:xfrm>
-          <a:prstGeom prst="roundRect">
+            <a:off x="9564624" y="3063239"/>
+            <a:ext cx="2029968" cy="932688"/>
+          </a:xfrm>
+          <a:prstGeom prst="rect">
             <a:avLst/>
           </a:prstGeom>
           <a:solidFill>
-            <a:srgbClr val="FFFFFF"/>
+            <a:srgbClr val="F4F8F6"/>
           </a:solidFill>
-          <a:ln w="12700">
-            <a:solidFill>
-              <a:srgbClr val="CFDBD5"/>
-            </a:solidFill>
+          <a:ln>
+            <a:noFill/>
           </a:ln>
         </p:spPr>
         <p:style>
@@ -4337,14 +4785,14 @@
       </p:sp>
       <p:sp>
         <p:nvSpPr>
-          <p:cNvPr id="32" name="TextBox 31"/>
+          <p:cNvPr id="41" name="TextBox 40"/>
           <p:cNvSpPr txBox="1"/>
           <p:nvPr/>
         </p:nvSpPr>
         <p:spPr>
           <a:xfrm>
-            <a:off x="5413248" y="2377439"/>
-            <a:ext cx="1371600" cy="182880"/>
+            <a:off x="9656063" y="3127248"/>
+            <a:ext cx="1847088" cy="155448"/>
           </a:xfrm>
           <a:prstGeom prst="rect">
             <a:avLst/>
@@ -4357,28 +4805,36 @@
           </a:bodyPr>
           <a:lstStyle/>
           <a:p>
-            <a:r>
-              <a:rPr sz="819" b="1">
-                <a:solidFill>
-                  <a:srgbClr val="115E59"/>
+            <a:pPr algn="l">
+              <a:lnSpc>
+                <a:spcPct val="115000"/>
+              </a:lnSpc>
+              <a:spcAft>
+                <a:spcPts val="200"/>
+              </a:spcAft>
+            </a:pPr>
+            <a:r>
+              <a:rPr sz="800" b="1">
+                <a:solidFill>
+                  <a:srgbClr val="9AA8A2"/>
                 </a:solidFill>
                 <a:latin typeface="Microsoft YaHei"/>
               </a:rPr>
-              <a:t>④ 引用求值</a:t>
-            </a:r>
-          </a:p>
-        </p:txBody>
-      </p:sp>
-      <p:sp>
-        <p:nvSpPr>
-          <p:cNvPr id="33" name="TextBox 32"/>
+              <a:t>工具 B</a:t>
+            </a:r>
+          </a:p>
+        </p:txBody>
+      </p:sp>
+      <p:sp>
+        <p:nvSpPr>
+          <p:cNvPr id="42" name="TextBox 41"/>
           <p:cNvSpPr txBox="1"/>
           <p:nvPr/>
         </p:nvSpPr>
         <p:spPr>
           <a:xfrm>
-            <a:off x="5413248" y="2578608"/>
-            <a:ext cx="1371600" cy="493776"/>
+            <a:off x="9656063" y="3291839"/>
+            <a:ext cx="1847088" cy="182880"/>
           </a:xfrm>
           <a:prstGeom prst="rect">
             <a:avLst/>
@@ -4391,28 +4847,36 @@
           </a:bodyPr>
           <a:lstStyle/>
           <a:p>
-            <a:r>
-              <a:rPr sz="740" b="0">
-                <a:solidFill>
-                  <a:srgbClr val="60706A"/>
+            <a:pPr algn="l">
+              <a:lnSpc>
+                <a:spcPct val="115000"/>
+              </a:lnSpc>
+              <a:spcAft>
+                <a:spcPts val="200"/>
+              </a:spcAft>
+            </a:pPr>
+            <a:r>
+              <a:rPr sz="1050" b="1">
+                <a:solidFill>
+                  <a:srgbClr val="1C2925"/>
                 </a:solidFill>
                 <a:latin typeface="Microsoft YaHei"/>
               </a:rPr>
-              <a:t>查记忆/词典，回填真值</a:t>
-            </a:r>
-          </a:p>
-        </p:txBody>
-      </p:sp>
-      <p:sp>
-        <p:nvSpPr>
-          <p:cNvPr id="34" name="TextBox 33"/>
+              <a:t>真值执行</a:t>
+            </a:r>
+          </a:p>
+        </p:txBody>
+      </p:sp>
+      <p:sp>
+        <p:nvSpPr>
+          <p:cNvPr id="43" name="TextBox 42"/>
           <p:cNvSpPr txBox="1"/>
           <p:nvPr/>
         </p:nvSpPr>
         <p:spPr>
           <a:xfrm>
-            <a:off x="6821424" y="2596896"/>
-            <a:ext cx="182880" cy="237744"/>
+            <a:off x="9656063" y="3493008"/>
+            <a:ext cx="1847088" cy="457200"/>
           </a:xfrm>
           <a:prstGeom prst="rect">
             <a:avLst/>
@@ -4425,39 +4889,232 @@
           </a:bodyPr>
           <a:lstStyle/>
           <a:p>
-            <a:r>
-              <a:rPr sz="1200" b="1">
-                <a:solidFill>
-                  <a:srgbClr val="0F766E"/>
+            <a:pPr algn="l">
+              <a:lnSpc>
+                <a:spcPct val="120000"/>
+              </a:lnSpc>
+              <a:spcAft>
+                <a:spcPts val="200"/>
+              </a:spcAft>
+            </a:pPr>
+            <a:r>
+              <a:rPr sz="830" b="0">
+                <a:solidFill>
+                  <a:srgbClr val="6B7A74"/>
                 </a:solidFill>
                 <a:latin typeface="Microsoft YaHei"/>
               </a:rPr>
-              <a:t>→</a:t>
-            </a:r>
-          </a:p>
-        </p:txBody>
-      </p:sp>
-      <p:sp>
-        <p:nvSpPr>
-          <p:cNvPr id="35" name="Rounded Rectangle 34"/>
+              <a:t>校验通过才调用；结果再入库，链路闭环</a:t>
+            </a:r>
+          </a:p>
+        </p:txBody>
+      </p:sp>
+      <p:sp>
+        <p:nvSpPr>
+          <p:cNvPr id="44" name="TextBox 43"/>
+          <p:cNvSpPr txBox="1"/>
+          <p:nvPr/>
+        </p:nvSpPr>
+        <p:spPr>
+          <a:xfrm>
+            <a:off x="566928" y="4224528"/>
+            <a:ext cx="502920" cy="219456"/>
+          </a:xfrm>
+          <a:prstGeom prst="rect">
+            <a:avLst/>
+          </a:prstGeom>
+          <a:noFill/>
+        </p:spPr>
+        <p:txBody>
+          <a:bodyPr wrap="square" lIns="0" rIns="0" tIns="0" bIns="0">
+            <a:spAutoFit/>
+          </a:bodyPr>
+          <a:lstStyle/>
+          <a:p>
+            <a:pPr algn="l">
+              <a:lnSpc>
+                <a:spcPct val="115000"/>
+              </a:lnSpc>
+              <a:spcAft>
+                <a:spcPts val="200"/>
+              </a:spcAft>
+            </a:pPr>
+            <a:r>
+              <a:rPr sz="1100" b="1">
+                <a:solidFill>
+                  <a:srgbClr val="0E6F66"/>
+                </a:solidFill>
+                <a:latin typeface="Microsoft YaHei"/>
+              </a:rPr>
+              <a:t>03</a:t>
+            </a:r>
+          </a:p>
+        </p:txBody>
+      </p:sp>
+      <p:sp>
+        <p:nvSpPr>
+          <p:cNvPr id="45" name="TextBox 44"/>
+          <p:cNvSpPr txBox="1"/>
+          <p:nvPr/>
+        </p:nvSpPr>
+        <p:spPr>
+          <a:xfrm>
+            <a:off x="1042416" y="4210812"/>
+            <a:ext cx="3108960" cy="237744"/>
+          </a:xfrm>
+          <a:prstGeom prst="rect">
+            <a:avLst/>
+          </a:prstGeom>
+          <a:noFill/>
+        </p:spPr>
+        <p:txBody>
+          <a:bodyPr wrap="square" lIns="0" rIns="0" tIns="0" bIns="0">
+            <a:spAutoFit/>
+          </a:bodyPr>
+          <a:lstStyle/>
+          <a:p>
+            <a:pPr algn="l">
+              <a:lnSpc>
+                <a:spcPct val="115000"/>
+              </a:lnSpc>
+              <a:spcAft>
+                <a:spcPts val="200"/>
+              </a:spcAft>
+            </a:pPr>
+            <a:r>
+              <a:rPr sz="1300" b="1">
+                <a:solidFill>
+                  <a:srgbClr val="1C2925"/>
+                </a:solidFill>
+                <a:latin typeface="Microsoft YaHei"/>
+              </a:rPr>
+              <a:t>三个关键问题</a:t>
+            </a:r>
+          </a:p>
+        </p:txBody>
+      </p:sp>
+      <p:sp>
+        <p:nvSpPr>
+          <p:cNvPr id="46" name="TextBox 45"/>
+          <p:cNvSpPr txBox="1"/>
+          <p:nvPr/>
+        </p:nvSpPr>
+        <p:spPr>
+          <a:xfrm>
+            <a:off x="566928" y="4498848"/>
+            <a:ext cx="3442106" cy="201168"/>
+          </a:xfrm>
+          <a:prstGeom prst="rect">
+            <a:avLst/>
+          </a:prstGeom>
+          <a:noFill/>
+        </p:spPr>
+        <p:txBody>
+          <a:bodyPr wrap="square" lIns="0" rIns="0" tIns="0" bIns="0">
+            <a:spAutoFit/>
+          </a:bodyPr>
+          <a:lstStyle/>
+          <a:p>
+            <a:pPr algn="l">
+              <a:lnSpc>
+                <a:spcPct val="115000"/>
+              </a:lnSpc>
+              <a:spcAft>
+                <a:spcPts val="200"/>
+              </a:spcAft>
+            </a:pPr>
+            <a:r>
+              <a:rPr sz="1150" b="1">
+                <a:solidFill>
+                  <a:srgbClr val="0B544E"/>
+                </a:solidFill>
+                <a:latin typeface="Microsoft YaHei"/>
+              </a:rPr>
+              <a:t>引用怎么写</a:t>
+            </a:r>
+          </a:p>
+        </p:txBody>
+      </p:sp>
+      <p:sp>
+        <p:nvSpPr>
+          <p:cNvPr id="47" name="TextBox 46"/>
+          <p:cNvSpPr txBox="1"/>
+          <p:nvPr/>
+        </p:nvSpPr>
+        <p:spPr>
+          <a:xfrm>
+            <a:off x="566928" y="4736592"/>
+            <a:ext cx="3442106" cy="1005840"/>
+          </a:xfrm>
+          <a:prstGeom prst="rect">
+            <a:avLst/>
+          </a:prstGeom>
+          <a:noFill/>
+        </p:spPr>
+        <p:txBody>
+          <a:bodyPr wrap="square" lIns="0" rIns="0" tIns="0" bIns="0">
+            <a:spAutoFit/>
+          </a:bodyPr>
+          <a:lstStyle/>
+          <a:p>
+            <a:pPr algn="l">
+              <a:lnSpc>
+                <a:spcPct val="125000"/>
+              </a:lnSpc>
+              <a:spcAft>
+                <a:spcPts val="200"/>
+              </a:spcAft>
+            </a:pPr>
+            <a:r>
+              <a:rPr sz="860" b="0">
+                <a:solidFill>
+                  <a:srgbClr val="1C2925"/>
+                </a:solidFill>
+                <a:latin typeface="Microsoft YaHei"/>
+              </a:rPr>
+              <a:t>上一步的结果用 ${resultId.path} 指定字段；「抖音的包名」写成 ${app.抖音.bundleName}。两种写法走同一条解析管道。</a:t>
+            </a:r>
+          </a:p>
+          <a:p>
+            <a:pPr algn="l">
+              <a:lnSpc>
+                <a:spcPct val="125000"/>
+              </a:lnSpc>
+              <a:spcAft>
+                <a:spcPts val="200"/>
+              </a:spcAft>
+            </a:pPr>
+            <a:r>
+              <a:rPr sz="860" b="0">
+                <a:solidFill>
+                  <a:srgbClr val="6B7A74"/>
+                </a:solidFill>
+                <a:latin typeface="Microsoft YaHei"/>
+              </a:rPr>
+              <a:t>模型不需要看值时，送模前就换成引用，照抄即可；需要看值时内容照常给，参数仍写引用——「看」与「传」分开。</a:t>
+            </a:r>
+          </a:p>
+        </p:txBody>
+      </p:sp>
+      <p:sp>
+        <p:nvSpPr>
+          <p:cNvPr id="48" name="Rectangle 47"/>
           <p:cNvSpPr/>
           <p:nvPr/>
         </p:nvSpPr>
         <p:spPr>
           <a:xfrm>
-            <a:off x="7077456" y="2331720"/>
-            <a:ext cx="1481328" cy="768096"/>
-          </a:xfrm>
-          <a:prstGeom prst="roundRect">
+            <a:off x="4173626" y="4526280"/>
+            <a:ext cx="9525" cy="1170432"/>
+          </a:xfrm>
+          <a:prstGeom prst="rect">
             <a:avLst/>
           </a:prstGeom>
           <a:solidFill>
-            <a:srgbClr val="FFFFFF"/>
+            <a:srgbClr val="DDE5E1"/>
           </a:solidFill>
-          <a:ln w="12700">
-            <a:solidFill>
-              <a:srgbClr val="CFDBD5"/>
-            </a:solidFill>
+          <a:ln>
+            <a:noFill/>
           </a:ln>
         </p:spPr>
         <p:style>
@@ -4484,14 +5141,14 @@
       </p:sp>
       <p:sp>
         <p:nvSpPr>
-          <p:cNvPr id="36" name="TextBox 35"/>
+          <p:cNvPr id="49" name="TextBox 48"/>
           <p:cNvSpPr txBox="1"/>
           <p:nvPr/>
         </p:nvSpPr>
         <p:spPr>
           <a:xfrm>
-            <a:off x="7132320" y="2377439"/>
-            <a:ext cx="1371600" cy="182880"/>
+            <a:off x="4374794" y="4498848"/>
+            <a:ext cx="3442106" cy="201168"/>
           </a:xfrm>
           <a:prstGeom prst="rect">
             <a:avLst/>
@@ -4504,28 +5161,36 @@
           </a:bodyPr>
           <a:lstStyle/>
           <a:p>
-            <a:r>
-              <a:rPr sz="819" b="1">
-                <a:solidFill>
-                  <a:srgbClr val="115E59"/>
+            <a:pPr algn="l">
+              <a:lnSpc>
+                <a:spcPct val="115000"/>
+              </a:lnSpc>
+              <a:spcAft>
+                <a:spcPts val="200"/>
+              </a:spcAft>
+            </a:pPr>
+            <a:r>
+              <a:rPr sz="1150" b="1">
+                <a:solidFill>
+                  <a:srgbClr val="0B544E"/>
                 </a:solidFill>
                 <a:latin typeface="Microsoft YaHei"/>
               </a:rPr>
-              <a:t>⑤ 结构适配</a:t>
-            </a:r>
-          </a:p>
-        </p:txBody>
-      </p:sp>
-      <p:sp>
-        <p:nvSpPr>
-          <p:cNvPr id="37" name="TextBox 36"/>
+              <a:t>真值从哪来</a:t>
+            </a:r>
+          </a:p>
+        </p:txBody>
+      </p:sp>
+      <p:sp>
+        <p:nvSpPr>
+          <p:cNvPr id="50" name="TextBox 49"/>
           <p:cNvSpPr txBox="1"/>
           <p:nvPr/>
         </p:nvSpPr>
         <p:spPr>
           <a:xfrm>
-            <a:off x="7132320" y="2578608"/>
-            <a:ext cx="1371600" cy="493776"/>
+            <a:off x="4374794" y="4736592"/>
+            <a:ext cx="3442106" cy="1005840"/>
           </a:xfrm>
           <a:prstGeom prst="rect">
             <a:avLst/>
@@ -4538,73 +5203,64 @@
           </a:bodyPr>
           <a:lstStyle/>
           <a:p>
-            <a:r>
-              <a:rPr sz="740" b="0">
-                <a:solidFill>
-                  <a:srgbClr val="60706A"/>
+            <a:pPr algn="l">
+              <a:lnSpc>
+                <a:spcPct val="125000"/>
+              </a:lnSpc>
+              <a:spcAft>
+                <a:spcPts val="200"/>
+              </a:spcAft>
+            </a:pPr>
+            <a:r>
+              <a:rPr sz="860" b="0">
+                <a:solidFill>
+                  <a:srgbClr val="1C2925"/>
                 </a:solidFill>
                 <a:latin typeface="Microsoft YaHei"/>
               </a:rPr>
-              <a:t>按参数Policy转换（可选）</a:t>
-            </a:r>
-          </a:p>
-        </p:txBody>
-      </p:sp>
-      <p:sp>
-        <p:nvSpPr>
-          <p:cNvPr id="38" name="TextBox 37"/>
-          <p:cNvSpPr txBox="1"/>
-          <p:nvPr/>
-        </p:nvSpPr>
-        <p:spPr>
-          <a:xfrm>
-            <a:off x="8540496" y="2596896"/>
-            <a:ext cx="182880" cy="237744"/>
-          </a:xfrm>
-          <a:prstGeom prst="rect">
-            <a:avLst/>
-          </a:prstGeom>
-          <a:noFill/>
-        </p:spPr>
-        <p:txBody>
-          <a:bodyPr wrap="square" lIns="0" rIns="0" tIns="0" bIns="0">
-            <a:spAutoFit/>
-          </a:bodyPr>
-          <a:lstStyle/>
-          <a:p>
-            <a:r>
-              <a:rPr sz="1200" b="1">
-                <a:solidFill>
-                  <a:srgbClr val="0F766E"/>
+              <a:t>结果引用查工作记忆：先查全量结果集，再查工具适配视图。语义引用查词典：先把 douyin 归一成「抖音」，再由映射表给出真实包名。</a:t>
+            </a:r>
+          </a:p>
+          <a:p>
+            <a:pPr algn="l">
+              <a:lnSpc>
+                <a:spcPct val="125000"/>
+              </a:lnSpc>
+              <a:spcAft>
+                <a:spcPts val="200"/>
+              </a:spcAft>
+            </a:pPr>
+            <a:r>
+              <a:rPr sz="860" b="0">
+                <a:solidFill>
+                  <a:srgbClr val="6B7A74"/>
                 </a:solidFill>
                 <a:latin typeface="Microsoft YaHei"/>
               </a:rPr>
-              <a:t>→</a:t>
-            </a:r>
-          </a:p>
-        </p:txBody>
-      </p:sp>
-      <p:sp>
-        <p:nvSpPr>
-          <p:cNvPr id="39" name="Rounded Rectangle 38"/>
+              <a:t>结构不一致时按参数策略转换：[563,728] 自动变成 [{"file_id":"563"},…]，模型和工具都不用动。</a:t>
+            </a:r>
+          </a:p>
+        </p:txBody>
+      </p:sp>
+      <p:sp>
+        <p:nvSpPr>
+          <p:cNvPr id="51" name="Rectangle 50"/>
           <p:cNvSpPr/>
           <p:nvPr/>
         </p:nvSpPr>
         <p:spPr>
           <a:xfrm>
-            <a:off x="8631936" y="2331720"/>
-            <a:ext cx="1481328" cy="768096"/>
-          </a:xfrm>
-          <a:prstGeom prst="roundRect">
+            <a:off x="7981492" y="4526280"/>
+            <a:ext cx="9525" cy="1170432"/>
+          </a:xfrm>
+          <a:prstGeom prst="rect">
             <a:avLst/>
           </a:prstGeom>
           <a:solidFill>
-            <a:srgbClr val="FFFFFF"/>
+            <a:srgbClr val="DDE5E1"/>
           </a:solidFill>
-          <a:ln w="12700">
-            <a:solidFill>
-              <a:srgbClr val="CFDBD5"/>
-            </a:solidFill>
+          <a:ln>
+            <a:noFill/>
           </a:ln>
         </p:spPr>
         <p:style>
@@ -4631,14 +5287,14 @@
       </p:sp>
       <p:sp>
         <p:nvSpPr>
-          <p:cNvPr id="40" name="TextBox 39"/>
+          <p:cNvPr id="52" name="TextBox 51"/>
           <p:cNvSpPr txBox="1"/>
           <p:nvPr/>
         </p:nvSpPr>
         <p:spPr>
           <a:xfrm>
-            <a:off x="8686800" y="2377439"/>
-            <a:ext cx="1371600" cy="182880"/>
+            <a:off x="8182660" y="4498848"/>
+            <a:ext cx="3442106" cy="201168"/>
           </a:xfrm>
           <a:prstGeom prst="rect">
             <a:avLst/>
@@ -4651,28 +5307,36 @@
           </a:bodyPr>
           <a:lstStyle/>
           <a:p>
-            <a:r>
-              <a:rPr sz="819" b="1">
-                <a:solidFill>
-                  <a:srgbClr val="115E59"/>
+            <a:pPr algn="l">
+              <a:lnSpc>
+                <a:spcPct val="115000"/>
+              </a:lnSpc>
+              <a:spcAft>
+                <a:spcPts val="200"/>
+              </a:spcAft>
+            </a:pPr>
+            <a:r>
+              <a:rPr sz="1150" b="1">
+                <a:solidFill>
+                  <a:srgbClr val="0B544E"/>
                 </a:solidFill>
                 <a:latin typeface="Microsoft YaHei"/>
               </a:rPr>
-              <a:t>⑥ 校验/短路</a:t>
-            </a:r>
-          </a:p>
-        </p:txBody>
-      </p:sp>
-      <p:sp>
-        <p:nvSpPr>
-          <p:cNvPr id="41" name="TextBox 40"/>
+              <a:t>出错怎么办</a:t>
+            </a:r>
+          </a:p>
+        </p:txBody>
+      </p:sp>
+      <p:sp>
+        <p:nvSpPr>
+          <p:cNvPr id="53" name="TextBox 52"/>
           <p:cNvSpPr txBox="1"/>
           <p:nvPr/>
         </p:nvSpPr>
         <p:spPr>
           <a:xfrm>
-            <a:off x="8686800" y="2578608"/>
-            <a:ext cx="1371600" cy="493776"/>
+            <a:off x="8182660" y="4736592"/>
+            <a:ext cx="3442106" cy="1005840"/>
           </a:xfrm>
           <a:prstGeom prst="rect">
             <a:avLst/>
@@ -4685,73 +5349,64 @@
           </a:bodyPr>
           <a:lstStyle/>
           <a:p>
-            <a:r>
-              <a:rPr sz="740" b="0">
-                <a:solidFill>
-                  <a:srgbClr val="60706A"/>
+            <a:pPr algn="l">
+              <a:lnSpc>
+                <a:spcPct val="125000"/>
+              </a:lnSpc>
+              <a:spcAft>
+                <a:spcPts val="200"/>
+              </a:spcAft>
+            </a:pPr>
+            <a:r>
+              <a:rPr sz="860" b="0">
+                <a:solidFill>
+                  <a:srgbClr val="1C2925"/>
                 </a:solidFill>
                 <a:latin typeface="Microsoft YaHei"/>
               </a:rPr>
-              <a:t>Schema与权限校验；失败不透传</a:t>
-            </a:r>
-          </a:p>
-        </p:txBody>
-      </p:sp>
-      <p:sp>
-        <p:nvSpPr>
-          <p:cNvPr id="42" name="TextBox 41"/>
-          <p:cNvSpPr txBox="1"/>
-          <p:nvPr/>
-        </p:nvSpPr>
-        <p:spPr>
-          <a:xfrm>
-            <a:off x="10094976" y="2596896"/>
-            <a:ext cx="182880" cy="237744"/>
-          </a:xfrm>
-          <a:prstGeom prst="rect">
-            <a:avLst/>
-          </a:prstGeom>
-          <a:noFill/>
-        </p:spPr>
-        <p:txBody>
-          <a:bodyPr wrap="square" lIns="0" rIns="0" tIns="0" bIns="0">
-            <a:spAutoFit/>
-          </a:bodyPr>
-          <a:lstStyle/>
-          <a:p>
-            <a:r>
-              <a:rPr sz="1200" b="1">
-                <a:solidFill>
-                  <a:srgbClr val="0F766E"/>
+              <a:t>解析失败、映射歧义、转换出错，一律短路：${…} 原文绝不透传给工具，错误明确回给模型。权限与作用域由 Runtime 校验。</a:t>
+            </a:r>
+          </a:p>
+          <a:p>
+            <a:pPr algn="l">
+              <a:lnSpc>
+                <a:spcPct val="125000"/>
+              </a:lnSpc>
+              <a:spcAft>
+                <a:spcPts val="200"/>
+              </a:spcAft>
+            </a:pPr>
+            <a:r>
+              <a:rPr sz="860" b="0">
+                <a:solidFill>
+                  <a:srgbClr val="6B7A74"/>
                 </a:solidFill>
                 <a:latin typeface="Microsoft YaHei"/>
               </a:rPr>
-              <a:t>→</a:t>
-            </a:r>
-          </a:p>
-        </p:txBody>
-      </p:sp>
-      <p:sp>
-        <p:nvSpPr>
-          <p:cNvPr id="43" name="Rounded Rectangle 42"/>
+              <a:t>语义映射没命中，就退回查询工具拿候选，确认后刷新词典再重试——失败只是多一轮，不会错着执行。</a:t>
+            </a:r>
+          </a:p>
+        </p:txBody>
+      </p:sp>
+      <p:sp>
+        <p:nvSpPr>
+          <p:cNvPr id="54" name="Rectangle 53"/>
           <p:cNvSpPr/>
           <p:nvPr/>
         </p:nvSpPr>
         <p:spPr>
           <a:xfrm>
-            <a:off x="10186416" y="2331720"/>
-            <a:ext cx="1481328" cy="768096"/>
-          </a:xfrm>
-          <a:prstGeom prst="roundRect">
+            <a:off x="566928" y="5870448"/>
+            <a:ext cx="11057839" cy="9525"/>
+          </a:xfrm>
+          <a:prstGeom prst="rect">
             <a:avLst/>
           </a:prstGeom>
           <a:solidFill>
-            <a:srgbClr val="FFFFFF"/>
+            <a:srgbClr val="DDE5E1"/>
           </a:solidFill>
-          <a:ln w="12700">
-            <a:solidFill>
-              <a:srgbClr val="CFDBD5"/>
-            </a:solidFill>
+          <a:ln>
+            <a:noFill/>
           </a:ln>
         </p:spPr>
         <p:style>
@@ -4778,14 +5433,14 @@
       </p:sp>
       <p:sp>
         <p:nvSpPr>
-          <p:cNvPr id="44" name="TextBox 43"/>
+          <p:cNvPr id="55" name="TextBox 54"/>
           <p:cNvSpPr txBox="1"/>
           <p:nvPr/>
         </p:nvSpPr>
         <p:spPr>
           <a:xfrm>
-            <a:off x="10241280" y="2377439"/>
-            <a:ext cx="1371600" cy="182880"/>
+            <a:off x="566928" y="5998464"/>
+            <a:ext cx="2581579" cy="201168"/>
           </a:xfrm>
           <a:prstGeom prst="rect">
             <a:avLst/>
@@ -4798,28 +5453,36 @@
           </a:bodyPr>
           <a:lstStyle/>
           <a:p>
-            <a:r>
-              <a:rPr sz="819" b="1">
-                <a:solidFill>
-                  <a:srgbClr val="115E59"/>
+            <a:pPr algn="l">
+              <a:lnSpc>
+                <a:spcPct val="115000"/>
+              </a:lnSpc>
+              <a:spcAft>
+                <a:spcPts val="200"/>
+              </a:spcAft>
+            </a:pPr>
+            <a:r>
+              <a:rPr sz="1100" b="1">
+                <a:solidFill>
+                  <a:srgbClr val="0B544E"/>
                 </a:solidFill>
                 <a:latin typeface="Microsoft YaHei"/>
               </a:rPr>
-              <a:t>⑦ 执行闭环</a:t>
-            </a:r>
-          </a:p>
-        </p:txBody>
-      </p:sp>
-      <p:sp>
-        <p:nvSpPr>
-          <p:cNvPr id="45" name="TextBox 44"/>
+              <a:t>省 Token</a:t>
+            </a:r>
+          </a:p>
+        </p:txBody>
+      </p:sp>
+      <p:sp>
+        <p:nvSpPr>
+          <p:cNvPr id="56" name="TextBox 55"/>
           <p:cNvSpPr txBox="1"/>
           <p:nvPr/>
         </p:nvSpPr>
         <p:spPr>
           <a:xfrm>
-            <a:off x="10241280" y="2578608"/>
-            <a:ext cx="1371600" cy="493776"/>
+            <a:off x="566928" y="6217920"/>
+            <a:ext cx="2581579" cy="182880"/>
           </a:xfrm>
           <a:prstGeom prst="rect">
             <a:avLst/>
@@ -4832,73 +5495,36 @@
           </a:bodyPr>
           <a:lstStyle/>
           <a:p>
-            <a:r>
-              <a:rPr sz="740" b="0">
-                <a:solidFill>
-                  <a:srgbClr val="60706A"/>
+            <a:pPr algn="l">
+              <a:lnSpc>
+                <a:spcPct val="115000"/>
+              </a:lnSpc>
+              <a:spcAft>
+                <a:spcPts val="200"/>
+              </a:spcAft>
+            </a:pPr>
+            <a:r>
+              <a:rPr sz="850" b="0">
+                <a:solidFill>
+                  <a:srgbClr val="6B7A74"/>
                 </a:solidFill>
                 <a:latin typeface="Microsoft YaHei"/>
               </a:rPr>
-              <a:t>真值调工具B；结果再入库</a:t>
-            </a:r>
-          </a:p>
-        </p:txBody>
-      </p:sp>
-      <p:sp>
-        <p:nvSpPr>
-          <p:cNvPr id="46" name="Rounded Rectangle 45"/>
-          <p:cNvSpPr/>
-          <p:nvPr/>
-        </p:nvSpPr>
-        <p:spPr>
-          <a:xfrm>
-            <a:off x="320040" y="3364992"/>
-            <a:ext cx="3246120" cy="2011680"/>
-          </a:xfrm>
-          <a:prstGeom prst="roundRect">
-            <a:avLst/>
-          </a:prstGeom>
-          <a:solidFill>
-            <a:srgbClr val="EDF4FC"/>
-          </a:solidFill>
-          <a:ln w="12700">
-            <a:solidFill>
-              <a:srgbClr val="BED4EC"/>
-            </a:solidFill>
-          </a:ln>
-        </p:spPr>
-        <p:style>
-          <a:lnRef idx="1">
-            <a:schemeClr val="accent1"/>
-          </a:lnRef>
-          <a:fillRef idx="3">
-            <a:schemeClr val="accent1"/>
-          </a:fillRef>
-          <a:effectRef idx="2">
-            <a:schemeClr val="accent1"/>
-          </a:effectRef>
-          <a:fontRef idx="minor">
-            <a:schemeClr val="lt1"/>
-          </a:fontRef>
-        </p:style>
-        <p:txBody>
-          <a:bodyPr rtlCol="0" anchor="ctr"/>
-          <a:lstStyle/>
-          <a:p>
-            <a:pPr algn="ctr"/>
-          </a:p>
-        </p:txBody>
-      </p:sp>
-      <p:sp>
-        <p:nvSpPr>
-          <p:cNvPr id="47" name="TextBox 46"/>
+              <a:t>长值不再回灌复述，输入与时延同降</a:t>
+            </a:r>
+          </a:p>
+        </p:txBody>
+      </p:sp>
+      <p:sp>
+        <p:nvSpPr>
+          <p:cNvPr id="57" name="TextBox 56"/>
           <p:cNvSpPr txBox="1"/>
           <p:nvPr/>
         </p:nvSpPr>
         <p:spPr>
           <a:xfrm>
-            <a:off x="429768" y="3419856"/>
-            <a:ext cx="3063240" cy="201168"/>
+            <a:off x="3331387" y="5998464"/>
+            <a:ext cx="2581579" cy="201168"/>
           </a:xfrm>
           <a:prstGeom prst="rect">
             <a:avLst/>
@@ -4911,169 +5537,36 @@
           </a:bodyPr>
           <a:lstStyle/>
           <a:p>
-            <a:r>
-              <a:rPr sz="1000" b="1">
-                <a:solidFill>
-                  <a:srgbClr val="1D4F91"/>
+            <a:pPr algn="l">
+              <a:lnSpc>
+                <a:spcPct val="115000"/>
+              </a:lnSpc>
+              <a:spcAft>
+                <a:spcPts val="200"/>
+              </a:spcAft>
+            </a:pPr>
+            <a:r>
+              <a:rPr sz="1100" b="1">
+                <a:solidFill>
+                  <a:srgbClr val="0B544E"/>
                 </a:solidFill>
                 <a:latin typeface="Microsoft YaHei"/>
               </a:rPr>
-              <a:t>支柱Ⅰ：引用怎么写</a:t>
-            </a:r>
-          </a:p>
-          <a:p>
-            <a:pPr>
-              <a:spcAft>
-                <a:spcPts val="0"/>
-              </a:spcAft>
-            </a:pPr>
-            <a:r>
-              <a:rPr sz="840" b="1">
-                <a:solidFill>
-                  <a:srgbClr val="15231F"/>
-                </a:solidFill>
-                <a:latin typeface="Microsoft YaHei"/>
-              </a:rPr>
-              <a:t>两类引用，同一管道</a:t>
-            </a:r>
-          </a:p>
-          <a:p>
-            <a:pPr>
-              <a:spcAft>
-                <a:spcPts val="100"/>
-              </a:spcAft>
-            </a:pPr>
-            <a:r>
-              <a:rPr sz="780" b="0">
-                <a:solidFill>
-                  <a:srgbClr val="15231F"/>
-                </a:solidFill>
-                <a:latin typeface="Microsoft YaHei"/>
-              </a:rPr>
-              <a:t>• 结果引用 ${a1b2c3d4.fileUri} → 工作记忆</a:t>
-            </a:r>
-          </a:p>
-          <a:p>
-            <a:pPr>
-              <a:spcAft>
-                <a:spcPts val="100"/>
-              </a:spcAft>
-            </a:pPr>
-            <a:r>
-              <a:rPr sz="780" b="0">
-                <a:solidFill>
-                  <a:srgbClr val="15231F"/>
-                </a:solidFill>
-                <a:latin typeface="Microsoft YaHei"/>
-              </a:rPr>
-              <a:t>• 语义引用 ${app.抖音.bundleName} → 词典</a:t>
-            </a:r>
-          </a:p>
-          <a:p>
-            <a:pPr>
-              <a:spcAft>
-                <a:spcPts val="0"/>
-              </a:spcAft>
-            </a:pPr>
-            <a:r>
-              <a:rPr sz="840" b="1">
-                <a:solidFill>
-                  <a:srgbClr val="15231F"/>
-                </a:solidFill>
-                <a:latin typeface="Microsoft YaHei"/>
-              </a:rPr>
-              <a:t>两种可见性</a:t>
-            </a:r>
-          </a:p>
-          <a:p>
-            <a:pPr>
-              <a:spcAft>
-                <a:spcPts val="100"/>
-              </a:spcAft>
-            </a:pPr>
-            <a:r>
-              <a:rPr sz="780" b="0">
-                <a:solidFill>
-                  <a:srgbClr val="15231F"/>
-                </a:solidFill>
-                <a:latin typeface="Microsoft YaHei"/>
-              </a:rPr>
-              <a:t>• 不用看值：mask后所见即所填</a:t>
-            </a:r>
-          </a:p>
-          <a:p>
-            <a:pPr>
-              <a:spcAft>
-                <a:spcPts val="100"/>
-              </a:spcAft>
-            </a:pPr>
-            <a:r>
-              <a:rPr sz="780" b="0">
-                <a:solidFill>
-                  <a:srgbClr val="15231F"/>
-                </a:solidFill>
-                <a:latin typeface="Microsoft YaHei"/>
-              </a:rPr>
-              <a:t>• 需要看值：内容供推理，入参仍写引用</a:t>
-            </a:r>
-          </a:p>
-        </p:txBody>
-      </p:sp>
-      <p:sp>
-        <p:nvSpPr>
-          <p:cNvPr id="48" name="Rounded Rectangle 47"/>
-          <p:cNvSpPr/>
-          <p:nvPr/>
-        </p:nvSpPr>
-        <p:spPr>
-          <a:xfrm>
-            <a:off x="3657600" y="3364992"/>
-            <a:ext cx="3840480" cy="2011680"/>
-          </a:xfrm>
-          <a:prstGeom prst="roundRect">
-            <a:avLst/>
-          </a:prstGeom>
-          <a:solidFill>
-            <a:srgbClr val="FFF7E4"/>
-          </a:solidFill>
-          <a:ln w="12700">
-            <a:solidFill>
-              <a:srgbClr val="EBD79B"/>
-            </a:solidFill>
-          </a:ln>
-        </p:spPr>
-        <p:style>
-          <a:lnRef idx="1">
-            <a:schemeClr val="accent1"/>
-          </a:lnRef>
-          <a:fillRef idx="3">
-            <a:schemeClr val="accent1"/>
-          </a:fillRef>
-          <a:effectRef idx="2">
-            <a:schemeClr val="accent1"/>
-          </a:effectRef>
-          <a:fontRef idx="minor">
-            <a:schemeClr val="lt1"/>
-          </a:fontRef>
-        </p:style>
-        <p:txBody>
-          <a:bodyPr rtlCol="0" anchor="ctr"/>
-          <a:lstStyle/>
-          <a:p>
-            <a:pPr algn="ctr"/>
-          </a:p>
-        </p:txBody>
-      </p:sp>
-      <p:sp>
-        <p:nvSpPr>
-          <p:cNvPr id="49" name="TextBox 48"/>
+              <a:t>消幻觉</a:t>
+            </a:r>
+          </a:p>
+        </p:txBody>
+      </p:sp>
+      <p:sp>
+        <p:nvSpPr>
+          <p:cNvPr id="58" name="TextBox 57"/>
           <p:cNvSpPr txBox="1"/>
           <p:nvPr/>
         </p:nvSpPr>
         <p:spPr>
           <a:xfrm>
-            <a:off x="3767328" y="3419856"/>
-            <a:ext cx="3657600" cy="201168"/>
+            <a:off x="3331387" y="6217920"/>
+            <a:ext cx="2581579" cy="182880"/>
           </a:xfrm>
           <a:prstGeom prst="rect">
             <a:avLst/>
@@ -5086,169 +5579,36 @@
           </a:bodyPr>
           <a:lstStyle/>
           <a:p>
-            <a:r>
-              <a:rPr sz="1000" b="1">
-                <a:solidFill>
-                  <a:srgbClr val="8A5A00"/>
+            <a:pPr algn="l">
+              <a:lnSpc>
+                <a:spcPct val="115000"/>
+              </a:lnSpc>
+              <a:spcAft>
+                <a:spcPts val="200"/>
+              </a:spcAft>
+            </a:pPr>
+            <a:r>
+              <a:rPr sz="850" b="0">
+                <a:solidFill>
+                  <a:srgbClr val="6B7A74"/>
                 </a:solidFill>
                 <a:latin typeface="Microsoft YaHei"/>
               </a:rPr>
-              <a:t>支柱Ⅱ：真值怎么来</a:t>
-            </a:r>
-          </a:p>
-          <a:p>
-            <a:pPr>
-              <a:spcAft>
-                <a:spcPts val="0"/>
-              </a:spcAft>
-            </a:pPr>
-            <a:r>
-              <a:rPr sz="840" b="1">
-                <a:solidFill>
-                  <a:srgbClr val="15231F"/>
-                </a:solidFill>
-                <a:latin typeface="Microsoft YaHei"/>
-              </a:rPr>
-              <a:t>可信数据源</a:t>
-            </a:r>
-          </a:p>
-          <a:p>
-            <a:pPr>
-              <a:spcAft>
-                <a:spcPts val="100"/>
-              </a:spcAft>
-            </a:pPr>
-            <a:r>
-              <a:rPr sz="780" b="0">
-                <a:solidFill>
-                  <a:srgbClr val="15231F"/>
-                </a:solidFill>
-                <a:latin typeface="Microsoft YaHei"/>
-              </a:rPr>
-              <a:t>• 工作记忆：全量结果集 → 工具适配视图</a:t>
-            </a:r>
-          </a:p>
-          <a:p>
-            <a:pPr>
-              <a:spcAft>
-                <a:spcPts val="100"/>
-              </a:spcAft>
-            </a:pPr>
-            <a:r>
-              <a:rPr sz="780" b="0">
-                <a:solidFill>
-                  <a:srgbClr val="15231F"/>
-                </a:solidFill>
-                <a:latin typeface="Microsoft YaHei"/>
-              </a:rPr>
-              <a:t>• 语义词典：别名归一表 + 实体属性映射表</a:t>
-            </a:r>
-          </a:p>
-          <a:p>
-            <a:pPr>
-              <a:spcAft>
-                <a:spcPts val="0"/>
-              </a:spcAft>
-            </a:pPr>
-            <a:r>
-              <a:rPr sz="840" b="1">
-                <a:solidFill>
-                  <a:srgbClr val="15231F"/>
-                </a:solidFill>
-                <a:latin typeface="Microsoft YaHei"/>
-              </a:rPr>
-              <a:t>结构适配（Policy）</a:t>
-            </a:r>
-          </a:p>
-          <a:p>
-            <a:pPr>
-              <a:spcAft>
-                <a:spcPts val="100"/>
-              </a:spcAft>
-            </a:pPr>
-            <a:r>
-              <a:rPr sz="780" b="0">
-                <a:solidFill>
-                  <a:srgbClr val="15231F"/>
-                </a:solidFill>
-                <a:latin typeface="Microsoft YaHei"/>
-              </a:rPr>
-              <a:t>• ${rid.merged_id_list} → [563,728]</a:t>
-            </a:r>
-          </a:p>
-          <a:p>
-            <a:pPr>
-              <a:spcAft>
-                <a:spcPts val="100"/>
-              </a:spcAft>
-            </a:pPr>
-            <a:r>
-              <a:rPr sz="780" b="0">
-                <a:solidFill>
-                  <a:srgbClr val="15231F"/>
-                </a:solidFill>
-                <a:latin typeface="Microsoft YaHei"/>
-              </a:rPr>
-              <a:t>• → [{"file_id":"563"}, {"file_id":"728"}]</a:t>
-            </a:r>
-          </a:p>
-        </p:txBody>
-      </p:sp>
-      <p:sp>
-        <p:nvSpPr>
-          <p:cNvPr id="50" name="Rounded Rectangle 49"/>
-          <p:cNvSpPr/>
-          <p:nvPr/>
-        </p:nvSpPr>
-        <p:spPr>
-          <a:xfrm>
-            <a:off x="7589520" y="3364992"/>
-            <a:ext cx="4279392" cy="2011680"/>
-          </a:xfrm>
-          <a:prstGeom prst="roundRect">
-            <a:avLst/>
-          </a:prstGeom>
-          <a:solidFill>
-            <a:srgbClr val="FFF0F3"/>
-          </a:solidFill>
-          <a:ln w="12700">
-            <a:solidFill>
-              <a:srgbClr val="E7C4CC"/>
-            </a:solidFill>
-          </a:ln>
-        </p:spPr>
-        <p:style>
-          <a:lnRef idx="1">
-            <a:schemeClr val="accent1"/>
-          </a:lnRef>
-          <a:fillRef idx="3">
-            <a:schemeClr val="accent1"/>
-          </a:fillRef>
-          <a:effectRef idx="2">
-            <a:schemeClr val="accent1"/>
-          </a:effectRef>
-          <a:fontRef idx="minor">
-            <a:schemeClr val="lt1"/>
-          </a:fontRef>
-        </p:style>
-        <p:txBody>
-          <a:bodyPr rtlCol="0" anchor="ctr"/>
-          <a:lstStyle/>
-          <a:p>
-            <a:pPr algn="ctr"/>
-          </a:p>
-        </p:txBody>
-      </p:sp>
-      <p:sp>
-        <p:nvSpPr>
-          <p:cNvPr id="51" name="TextBox 50"/>
+              <a:t>标识只出自查表，不靠模型记忆</a:t>
+            </a:r>
+          </a:p>
+        </p:txBody>
+      </p:sp>
+      <p:sp>
+        <p:nvSpPr>
+          <p:cNvPr id="59" name="TextBox 58"/>
           <p:cNvSpPr txBox="1"/>
           <p:nvPr/>
         </p:nvSpPr>
         <p:spPr>
           <a:xfrm>
-            <a:off x="7699248" y="3419856"/>
-            <a:ext cx="4096512" cy="201168"/>
+            <a:off x="6095847" y="5998464"/>
+            <a:ext cx="2581579" cy="201168"/>
           </a:xfrm>
           <a:prstGeom prst="rect">
             <a:avLst/>
@@ -5261,167 +5621,36 @@
           </a:bodyPr>
           <a:lstStyle/>
           <a:p>
-            <a:r>
-              <a:rPr sz="1000" b="1">
-                <a:solidFill>
-                  <a:srgbClr val="8B3144"/>
+            <a:pPr algn="l">
+              <a:lnSpc>
+                <a:spcPct val="115000"/>
+              </a:lnSpc>
+              <a:spcAft>
+                <a:spcPts val="200"/>
+              </a:spcAft>
+            </a:pPr>
+            <a:r>
+              <a:rPr sz="1100" b="1">
+                <a:solidFill>
+                  <a:srgbClr val="0B544E"/>
                 </a:solidFill>
                 <a:latin typeface="Microsoft YaHei"/>
               </a:rPr>
-              <a:t>支柱Ⅲ：错误怎么兜</a:t>
-            </a:r>
-          </a:p>
-          <a:p>
-            <a:pPr>
-              <a:spcAft>
-                <a:spcPts val="0"/>
-              </a:spcAft>
-            </a:pPr>
-            <a:r>
-              <a:rPr sz="840" b="1">
-                <a:solidFill>
-                  <a:srgbClr val="15231F"/>
-                </a:solidFill>
-                <a:latin typeface="Microsoft YaHei"/>
-              </a:rPr>
-              <a:t>硬约束（Runtime）</a:t>
-            </a:r>
-          </a:p>
-          <a:p>
-            <a:pPr>
-              <a:spcAft>
-                <a:spcPts val="100"/>
-              </a:spcAft>
-            </a:pPr>
-            <a:r>
-              <a:rPr sz="780" b="0">
-                <a:solidFill>
-                  <a:srgbClr val="15231F"/>
-                </a:solidFill>
-                <a:latin typeface="Microsoft YaHei"/>
-              </a:rPr>
-              <a:t>• 解析/映射/转换/Schema失败即短路，禁止${…}透传</a:t>
-            </a:r>
-          </a:p>
-          <a:p>
-            <a:pPr>
-              <a:spcAft>
-                <a:spcPts val="100"/>
-              </a:spcAft>
-            </a:pPr>
-            <a:r>
-              <a:rPr sz="780" b="0">
-                <a:solidFill>
-                  <a:srgbClr val="15231F"/>
-                </a:solidFill>
-                <a:latin typeface="Microsoft YaHei"/>
-              </a:rPr>
-              <a:t>• 作用域与权限由Runtime校验，模型无权决定</a:t>
-            </a:r>
-          </a:p>
-          <a:p>
-            <a:pPr>
-              <a:spcAft>
-                <a:spcPts val="0"/>
-              </a:spcAft>
-            </a:pPr>
-            <a:r>
-              <a:rPr sz="840" b="1">
-                <a:solidFill>
-                  <a:srgbClr val="15231F"/>
-                </a:solidFill>
-                <a:latin typeface="Microsoft YaHei"/>
-              </a:rPr>
-              <a:t>可恢复（兜底）</a:t>
-            </a:r>
-          </a:p>
-          <a:p>
-            <a:pPr>
-              <a:spcAft>
-                <a:spcPts val="100"/>
-              </a:spcAft>
-            </a:pPr>
-            <a:r>
-              <a:rPr sz="780" b="0">
-                <a:solidFill>
-                  <a:srgbClr val="15231F"/>
-                </a:solidFill>
-                <a:latin typeface="Microsoft YaHei"/>
-              </a:rPr>
-              <a:t>• 多候选返回列表/动态枚举，不静默猜</a:t>
-            </a:r>
-          </a:p>
-          <a:p>
-            <a:pPr>
-              <a:spcAft>
-                <a:spcPts val="100"/>
-              </a:spcAft>
-            </a:pPr>
-            <a:r>
-              <a:rPr sz="780" b="0">
-                <a:solidFill>
-                  <a:srgbClr val="15231F"/>
-                </a:solidFill>
-                <a:latin typeface="Microsoft YaHei"/>
-              </a:rPr>
-              <a:t>• 未命中→查询工具→确认后刷新映射→重试</a:t>
-            </a:r>
-          </a:p>
-        </p:txBody>
-      </p:sp>
-      <p:sp>
-        <p:nvSpPr>
-          <p:cNvPr id="52" name="Rectangle 51"/>
-          <p:cNvSpPr/>
-          <p:nvPr/>
-        </p:nvSpPr>
-        <p:spPr>
-          <a:xfrm>
-            <a:off x="320040" y="5504688"/>
-            <a:ext cx="11548872" cy="13716"/>
-          </a:xfrm>
-          <a:prstGeom prst="rect">
-            <a:avLst/>
-          </a:prstGeom>
-          <a:solidFill>
-            <a:srgbClr val="CFDBD5"/>
-          </a:solidFill>
-          <a:ln w="6350">
-            <a:noFill/>
-          </a:ln>
-        </p:spPr>
-        <p:style>
-          <a:lnRef idx="1">
-            <a:schemeClr val="accent1"/>
-          </a:lnRef>
-          <a:fillRef idx="3">
-            <a:schemeClr val="accent1"/>
-          </a:fillRef>
-          <a:effectRef idx="2">
-            <a:schemeClr val="accent1"/>
-          </a:effectRef>
-          <a:fontRef idx="minor">
-            <a:schemeClr val="lt1"/>
-          </a:fontRef>
-        </p:style>
-        <p:txBody>
-          <a:bodyPr rtlCol="0" anchor="ctr"/>
-          <a:lstStyle/>
-          <a:p>
-            <a:pPr algn="ctr"/>
-          </a:p>
-        </p:txBody>
-      </p:sp>
-      <p:sp>
-        <p:nvSpPr>
-          <p:cNvPr id="53" name="TextBox 52"/>
+              <a:t>少一轮</a:t>
+            </a:r>
+          </a:p>
+        </p:txBody>
+      </p:sp>
+      <p:sp>
+        <p:nvSpPr>
+          <p:cNvPr id="60" name="TextBox 59"/>
           <p:cNvSpPr txBox="1"/>
           <p:nvPr/>
         </p:nvSpPr>
         <p:spPr>
           <a:xfrm>
-            <a:off x="320040" y="5596128"/>
-            <a:ext cx="2834640" cy="219456"/>
+            <a:off x="6095847" y="6217920"/>
+            <a:ext cx="2581579" cy="182880"/>
           </a:xfrm>
           <a:prstGeom prst="rect">
             <a:avLst/>
@@ -5434,29 +5663,36 @@
           </a:bodyPr>
           <a:lstStyle/>
           <a:p>
-            <a:pPr algn="ctr"/>
-            <a:r>
-              <a:rPr sz="1100" b="1">
-                <a:solidFill>
-                  <a:srgbClr val="115E59"/>
+            <a:pPr algn="l">
+              <a:lnSpc>
+                <a:spcPct val="115000"/>
+              </a:lnSpc>
+              <a:spcAft>
+                <a:spcPts val="200"/>
+              </a:spcAft>
+            </a:pPr>
+            <a:r>
+              <a:rPr sz="850" b="0">
+                <a:solidFill>
+                  <a:srgbClr val="6B7A74"/>
                 </a:solidFill>
                 <a:latin typeface="Microsoft YaHei"/>
               </a:rPr>
-              <a:t>省Token</a:t>
-            </a:r>
-          </a:p>
-        </p:txBody>
-      </p:sp>
-      <p:sp>
-        <p:nvSpPr>
-          <p:cNvPr id="54" name="TextBox 53"/>
+              <a:t>映射命中时，一次业务调用完成</a:t>
+            </a:r>
+          </a:p>
+        </p:txBody>
+      </p:sp>
+      <p:sp>
+        <p:nvSpPr>
+          <p:cNvPr id="61" name="TextBox 60"/>
           <p:cNvSpPr txBox="1"/>
           <p:nvPr/>
         </p:nvSpPr>
         <p:spPr>
           <a:xfrm>
-            <a:off x="320040" y="5833872"/>
-            <a:ext cx="2834640" cy="219456"/>
+            <a:off x="8860307" y="5998464"/>
+            <a:ext cx="2581579" cy="201168"/>
           </a:xfrm>
           <a:prstGeom prst="rect">
             <a:avLst/>
@@ -5469,29 +5705,36 @@
           </a:bodyPr>
           <a:lstStyle/>
           <a:p>
-            <a:pPr algn="ctr"/>
-            <a:r>
-              <a:rPr sz="800" b="0">
-                <a:solidFill>
-                  <a:srgbClr val="60706A"/>
+            <a:pPr algn="l">
+              <a:lnSpc>
+                <a:spcPct val="115000"/>
+              </a:lnSpc>
+              <a:spcAft>
+                <a:spcPts val="200"/>
+              </a:spcAft>
+            </a:pPr>
+            <a:r>
+              <a:rPr sz="1100" b="1">
+                <a:solidFill>
+                  <a:srgbClr val="0B544E"/>
                 </a:solidFill>
                 <a:latin typeface="Microsoft YaHei"/>
               </a:rPr>
-              <a:t>长值不回灌不复述，降输入与时延</a:t>
-            </a:r>
-          </a:p>
-        </p:txBody>
-      </p:sp>
-      <p:sp>
-        <p:nvSpPr>
-          <p:cNvPr id="55" name="TextBox 54"/>
+              <a:t>零改动</a:t>
+            </a:r>
+          </a:p>
+        </p:txBody>
+      </p:sp>
+      <p:sp>
+        <p:nvSpPr>
+          <p:cNvPr id="62" name="TextBox 61"/>
           <p:cNvSpPr txBox="1"/>
           <p:nvPr/>
         </p:nvSpPr>
         <p:spPr>
           <a:xfrm>
-            <a:off x="3227832" y="5596128"/>
-            <a:ext cx="2834640" cy="219456"/>
+            <a:off x="8860307" y="6217920"/>
+            <a:ext cx="2581579" cy="182880"/>
           </a:xfrm>
           <a:prstGeom prst="rect">
             <a:avLst/>
@@ -5504,29 +5747,36 @@
           </a:bodyPr>
           <a:lstStyle/>
           <a:p>
-            <a:pPr algn="ctr"/>
-            <a:r>
-              <a:rPr sz="1100" b="1">
-                <a:solidFill>
-                  <a:srgbClr val="115E59"/>
+            <a:pPr algn="l">
+              <a:lnSpc>
+                <a:spcPct val="115000"/>
+              </a:lnSpc>
+              <a:spcAft>
+                <a:spcPts val="200"/>
+              </a:spcAft>
+            </a:pPr>
+            <a:r>
+              <a:rPr sz="850" b="0">
+                <a:solidFill>
+                  <a:srgbClr val="6B7A74"/>
                 </a:solidFill>
                 <a:latin typeface="Microsoft YaHei"/>
               </a:rPr>
-              <a:t>消幻觉</a:t>
-            </a:r>
-          </a:p>
-        </p:txBody>
-      </p:sp>
-      <p:sp>
-        <p:nvSpPr>
-          <p:cNvPr id="56" name="TextBox 55"/>
+              <a:t>能力在框架层，存量工具无感接入</a:t>
+            </a:r>
+          </a:p>
+        </p:txBody>
+      </p:sp>
+      <p:sp>
+        <p:nvSpPr>
+          <p:cNvPr id="63" name="TextBox 62"/>
           <p:cNvSpPr txBox="1"/>
           <p:nvPr/>
         </p:nvSpPr>
         <p:spPr>
           <a:xfrm>
-            <a:off x="3227832" y="5833872"/>
-            <a:ext cx="2834640" cy="219456"/>
+            <a:off x="566928" y="6473952"/>
+            <a:ext cx="11057839" cy="237744"/>
           </a:xfrm>
           <a:prstGeom prst="rect">
             <a:avLst/>
@@ -5539,190 +5789,22 @@
           </a:bodyPr>
           <a:lstStyle/>
           <a:p>
-            <a:pPr algn="ctr"/>
-            <a:r>
-              <a:rPr sz="800" b="0">
-                <a:solidFill>
-                  <a:srgbClr val="60706A"/>
+            <a:pPr algn="ctr">
+              <a:lnSpc>
+                <a:spcPct val="115000"/>
+              </a:lnSpc>
+              <a:spcAft>
+                <a:spcPts val="200"/>
+              </a:spcAft>
+            </a:pPr>
+            <a:r>
+              <a:rPr sz="1050" b="1">
+                <a:solidFill>
+                  <a:srgbClr val="1C2925"/>
                 </a:solidFill>
                 <a:latin typeface="Microsoft YaHei"/>
               </a:rPr>
-              <a:t>真值只出自查表，标识不再编造</a:t>
-            </a:r>
-          </a:p>
-        </p:txBody>
-      </p:sp>
-      <p:sp>
-        <p:nvSpPr>
-          <p:cNvPr id="57" name="TextBox 56"/>
-          <p:cNvSpPr txBox="1"/>
-          <p:nvPr/>
-        </p:nvSpPr>
-        <p:spPr>
-          <a:xfrm>
-            <a:off x="6135624" y="5596128"/>
-            <a:ext cx="2834640" cy="219456"/>
-          </a:xfrm>
-          <a:prstGeom prst="rect">
-            <a:avLst/>
-          </a:prstGeom>
-          <a:noFill/>
-        </p:spPr>
-        <p:txBody>
-          <a:bodyPr wrap="square" lIns="0" rIns="0" tIns="0" bIns="0">
-            <a:spAutoFit/>
-          </a:bodyPr>
-          <a:lstStyle/>
-          <a:p>
-            <a:pPr algn="ctr"/>
-            <a:r>
-              <a:rPr sz="1100" b="1">
-                <a:solidFill>
-                  <a:srgbClr val="115E59"/>
-                </a:solidFill>
-                <a:latin typeface="Microsoft YaHei"/>
-              </a:rPr>
-              <a:t>少一轮</a:t>
-            </a:r>
-          </a:p>
-        </p:txBody>
-      </p:sp>
-      <p:sp>
-        <p:nvSpPr>
-          <p:cNvPr id="58" name="TextBox 57"/>
-          <p:cNvSpPr txBox="1"/>
-          <p:nvPr/>
-        </p:nvSpPr>
-        <p:spPr>
-          <a:xfrm>
-            <a:off x="6135624" y="5833872"/>
-            <a:ext cx="2834640" cy="219456"/>
-          </a:xfrm>
-          <a:prstGeom prst="rect">
-            <a:avLst/>
-          </a:prstGeom>
-          <a:noFill/>
-        </p:spPr>
-        <p:txBody>
-          <a:bodyPr wrap="square" lIns="0" rIns="0" tIns="0" bIns="0">
-            <a:spAutoFit/>
-          </a:bodyPr>
-          <a:lstStyle/>
-          <a:p>
-            <a:pPr algn="ctr"/>
-            <a:r>
-              <a:rPr sz="800" b="0">
-                <a:solidFill>
-                  <a:srgbClr val="60706A"/>
-                </a:solidFill>
-                <a:latin typeface="Microsoft YaHei"/>
-              </a:rPr>
-              <a:t>映射命中时业务调用1次Loop完成</a:t>
-            </a:r>
-          </a:p>
-        </p:txBody>
-      </p:sp>
-      <p:sp>
-        <p:nvSpPr>
-          <p:cNvPr id="59" name="TextBox 58"/>
-          <p:cNvSpPr txBox="1"/>
-          <p:nvPr/>
-        </p:nvSpPr>
-        <p:spPr>
-          <a:xfrm>
-            <a:off x="9043416" y="5596128"/>
-            <a:ext cx="2834640" cy="219456"/>
-          </a:xfrm>
-          <a:prstGeom prst="rect">
-            <a:avLst/>
-          </a:prstGeom>
-          <a:noFill/>
-        </p:spPr>
-        <p:txBody>
-          <a:bodyPr wrap="square" lIns="0" rIns="0" tIns="0" bIns="0">
-            <a:spAutoFit/>
-          </a:bodyPr>
-          <a:lstStyle/>
-          <a:p>
-            <a:pPr algn="ctr"/>
-            <a:r>
-              <a:rPr sz="1100" b="1">
-                <a:solidFill>
-                  <a:srgbClr val="115E59"/>
-                </a:solidFill>
-                <a:latin typeface="Microsoft YaHei"/>
-              </a:rPr>
-              <a:t>零改动</a:t>
-            </a:r>
-          </a:p>
-        </p:txBody>
-      </p:sp>
-      <p:sp>
-        <p:nvSpPr>
-          <p:cNvPr id="60" name="TextBox 59"/>
-          <p:cNvSpPr txBox="1"/>
-          <p:nvPr/>
-        </p:nvSpPr>
-        <p:spPr>
-          <a:xfrm>
-            <a:off x="9043416" y="5833872"/>
-            <a:ext cx="2834640" cy="219456"/>
-          </a:xfrm>
-          <a:prstGeom prst="rect">
-            <a:avLst/>
-          </a:prstGeom>
-          <a:noFill/>
-        </p:spPr>
-        <p:txBody>
-          <a:bodyPr wrap="square" lIns="0" rIns="0" tIns="0" bIns="0">
-            <a:spAutoFit/>
-          </a:bodyPr>
-          <a:lstStyle/>
-          <a:p>
-            <a:pPr algn="ctr"/>
-            <a:r>
-              <a:rPr sz="800" b="0">
-                <a:solidFill>
-                  <a:srgbClr val="60706A"/>
-                </a:solidFill>
-                <a:latin typeface="Microsoft YaHei"/>
-              </a:rPr>
-              <a:t>框架层统一生效，存量工具无感</a:t>
-            </a:r>
-          </a:p>
-        </p:txBody>
-      </p:sp>
-      <p:sp>
-        <p:nvSpPr>
-          <p:cNvPr id="61" name="TextBox 60"/>
-          <p:cNvSpPr txBox="1"/>
-          <p:nvPr/>
-        </p:nvSpPr>
-        <p:spPr>
-          <a:xfrm>
-            <a:off x="320040" y="6199632"/>
-            <a:ext cx="11548872" cy="274320"/>
-          </a:xfrm>
-          <a:prstGeom prst="rect">
-            <a:avLst/>
-          </a:prstGeom>
-          <a:noFill/>
-        </p:spPr>
-        <p:txBody>
-          <a:bodyPr wrap="square" lIns="0" rIns="0" tIns="0" bIns="0">
-            <a:spAutoFit/>
-          </a:bodyPr>
-          <a:lstStyle/>
-          <a:p>
-            <a:pPr algn="ctr"/>
-            <a:r>
-              <a:rPr sz="1000" b="1">
-                <a:solidFill>
-                  <a:srgbClr val="115E59"/>
-                </a:solidFill>
-                <a:latin typeface="Microsoft YaHei"/>
-              </a:rPr>
-              <a:t>一句话：模型决定“引用哪个对象”，Runtime保证“真实、适配、合法”后再执行。</a:t>
+              <a:t>模型决定「引用哪个对象」，Runtime 保证「真实、适配、合法」，然后才执行。</a:t>
             </a:r>
           </a:p>
         </p:txBody>

</xml_diff>

<commit_message>
docs: scope one-pager to result references only
Co-authored-by: Lizzy67 <Lizzy67@users.noreply.github.com>
</commit_message>
<xml_diff>
--- a/docs/tool_param_ref_onepage.pptx
+++ b/docs/tool_param_ref_onepage.pptx
@@ -3210,7 +3210,7 @@
                 </a:solidFill>
                 <a:latin typeface="Microsoft YaHei"/>
               </a:rPr>
-              <a:t>工具参数引用：让模型写「引用」，让 Runtime 填「真值」</a:t>
+              <a:t>工具结果引用：让模型写「引用」，让 Runtime 填「真值」</a:t>
             </a:r>
           </a:p>
         </p:txBody>
@@ -3224,7 +3224,7 @@
         <p:spPr>
           <a:xfrm>
             <a:off x="566928" y="896112"/>
-            <a:ext cx="10607040" cy="274320"/>
+            <a:ext cx="10881360" cy="274320"/>
           </a:xfrm>
           <a:prstGeom prst="rect">
             <a:avLst/>
@@ -3252,7 +3252,7 @@
                 </a:solidFill>
                 <a:latin typeface="Microsoft YaHei"/>
               </a:rPr>
-              <a:t>工具入参不再由模型亲手写出真实值，而是写一个引用；Runtime 在工具执行前查表求值、按需转换、校验合法，再去调用工具。</a:t>
+              <a:t>上一个工具的结果不再回灌给模型抄写，而是由模型在下游参数里写一个引用；Runtime 在工具执行前从工作记忆取出真值、按需转换、校验合法，再去调用工具。</a:t>
             </a:r>
           </a:p>
         </p:txBody>
@@ -3294,7 +3294,7 @@
                 </a:solidFill>
                 <a:latin typeface="Microsoft YaHei"/>
               </a:rPr>
-              <a:t>真值始终出自可信数据源，存量工具一行不改。</a:t>
+              <a:t>真值全程不经模型之手，存量工具一行不改。</a:t>
             </a:r>
           </a:p>
         </p:txBody>
@@ -3463,7 +3463,7 @@
                 </a:solidFill>
                 <a:latin typeface="Microsoft YaHei"/>
               </a:rPr>
-              <a:t>下一个工具的参数，常来自上一个工具的结果，或「抖音」这类口语名称背后的真实标识。这些值现在都靠模型亲手写：长 URI 抄着抄着就断了；包名靠记忆，就编出了 com.douyin.app；结构不一致时还要模型改写大段 JSON。抄写、回忆、改写——三件事模型都做不稳。</a:t>
+              <a:t>下一个工具的参数常来自上一个工具的结果：文件 URI、对象 ID、大段文本、一整个列表。这些值现在要先整段塞回模型上下文，再由模型原样抄进下游参数——长 URI 抄着抄着就断了；结构不一致时还要模型改写大段 JSON。抄写和改写，两件事模型都做不稳，而且每一轮都在烧 Token。</a:t>
             </a:r>
           </a:p>
         </p:txBody>
@@ -3514,7 +3514,7 @@
                 </a:solidFill>
                 <a:latin typeface="Microsoft YaHei"/>
               </a:rPr>
-              <a:t>长值复述易截断改写，抬高输入Token　　</a:t>
+              <a:t>长值复述易截断、改写、漏字符　　</a:t>
             </a:r>
             <a:r>
               <a:rPr sz="950" b="1">
@@ -3523,7 +3523,7 @@
                 </a:solidFill>
                 <a:latin typeface="Microsoft YaHei"/>
               </a:rPr>
-              <a:t>会编造 </a:t>
+              <a:t>太昂贵 </a:t>
             </a:r>
             <a:r>
               <a:rPr sz="950" b="0">
@@ -3532,7 +3532,7 @@
                 </a:solidFill>
                 <a:latin typeface="Microsoft YaHei"/>
               </a:rPr>
-              <a:t>弱语义标识凭记忆幻觉　　</a:t>
+              <a:t>大结果反复回灌，Token和时延一起涨　　</a:t>
             </a:r>
             <a:r>
               <a:rPr sz="950" b="1">
@@ -3550,7 +3550,7 @@
                 </a:solidFill>
                 <a:latin typeface="Microsoft YaHei"/>
               </a:rPr>
-              <a:t>结构适配靠模型或逐个改工具，都不划算</a:t>
+              <a:t>结构适配靠模型改JSON或逐个改工具，都不划算</a:t>
             </a:r>
           </a:p>
         </p:txBody>
@@ -3888,7 +3888,7 @@
                 </a:solidFill>
                 <a:latin typeface="Microsoft YaHei"/>
               </a:rPr>
-              <a:t>返回结果写入工作记忆，得到短标识 resultId</a:t>
+              <a:t>返回结果默认写入工作记忆，得到短标识 resultId</a:t>
             </a:r>
           </a:p>
         </p:txBody>
@@ -4396,7 +4396,7 @@
                 </a:solidFill>
                 <a:latin typeface="Microsoft YaHei"/>
               </a:rPr>
-              <a:t>下游参数填 ${…}，不复述真值，所见即所填</a:t>
+              <a:t>下游参数填 ${resultId.path}，不复述真值，所见即所填</a:t>
             </a:r>
           </a:p>
         </p:txBody>
@@ -4650,7 +4650,7 @@
                 </a:solidFill>
                 <a:latin typeface="Microsoft YaHei"/>
               </a:rPr>
-              <a:t>查表回填真值，按策略适配结构，验完Schema与权限</a:t>
+              <a:t>查工作记忆回填真值，按策略适配结构，验完Schema与权限</a:t>
             </a:r>
           </a:p>
         </p:txBody>
@@ -5072,7 +5072,7 @@
                 </a:solidFill>
                 <a:latin typeface="Microsoft YaHei"/>
               </a:rPr>
-              <a:t>上一步的结果用 ${resultId.path} 指定字段；「抖音的包名」写成 ${app.抖音.bundleName}。两种写法走同一条解析管道。</a:t>
+              <a:t>用 ${resultId.path} 指定「哪条结果的哪个字段」：resultId 是入库时分配的短标识，path 支持点号取嵌套字段，如 ${a1b2c3d4.data.fileUri}。</a:t>
             </a:r>
           </a:p>
           <a:p>
@@ -5218,7 +5218,7 @@
                 </a:solidFill>
                 <a:latin typeface="Microsoft YaHei"/>
               </a:rPr>
-              <a:t>结果引用查工作记忆：先查全量结果集，再查工具适配视图。语义引用查词典：先把 douyin 归一成「抖音」，再由映射表给出真实包名。</a:t>
+              <a:t>只从工作记忆取：先查全量结果集，未命中再查工具适配视图。resultId 由 Runtime 统一生成，对内保留与 toolCallId 的映射，可追踪、可对账。</a:t>
             </a:r>
           </a:p>
           <a:p>
@@ -5364,7 +5364,7 @@
                 </a:solidFill>
                 <a:latin typeface="Microsoft YaHei"/>
               </a:rPr>
-              <a:t>解析失败、映射歧义、转换出错，一律短路：${…} 原文绝不透传给工具，错误明确回给模型。权限与作用域由 Runtime 校验。</a:t>
+              <a:t>引用非法、结果不存在、字段没有、转换失败，一律短路：${…} 原文绝不透传给工具，错误明确回给模型，引导改写后重试。</a:t>
             </a:r>
           </a:p>
           <a:p>
@@ -5383,7 +5383,7 @@
                 </a:solidFill>
                 <a:latin typeface="Microsoft YaHei"/>
               </a:rPr>
-              <a:t>语义映射没命中，就退回查询工具拿候选，确认后刷新词典再重试——失败只是多一轮，不会错着执行。</a:t>
+              <a:t>结果带会话作用域和有效期，过期或越权即拒绝；并行链路必须显式写 resultId，不允许含糊的「上一条」。</a:t>
             </a:r>
           </a:p>
         </p:txBody>
@@ -5510,7 +5510,7 @@
                 </a:solidFill>
                 <a:latin typeface="Microsoft YaHei"/>
               </a:rPr>
-              <a:t>长值不再回灌复述，输入与时延同降</a:t>
+              <a:t>大结果不再回灌复述，输入与时延同降</a:t>
             </a:r>
           </a:p>
         </p:txBody>
@@ -5552,7 +5552,7 @@
                 </a:solidFill>
                 <a:latin typeface="Microsoft YaHei"/>
               </a:rPr>
-              <a:t>消幻觉</a:t>
+              <a:t>抄不错</a:t>
             </a:r>
           </a:p>
         </p:txBody>
@@ -5594,7 +5594,7 @@
                 </a:solidFill>
                 <a:latin typeface="Microsoft YaHei"/>
               </a:rPr>
-              <a:t>标识只出自查表，不靠模型记忆</a:t>
+              <a:t>真值不经模型之手，杜绝截断改写</a:t>
             </a:r>
           </a:p>
         </p:txBody>
@@ -5636,7 +5636,7 @@
                 </a:solidFill>
                 <a:latin typeface="Microsoft YaHei"/>
               </a:rPr>
-              <a:t>少一轮</a:t>
+              <a:t>结构解耦</a:t>
             </a:r>
           </a:p>
         </p:txBody>
@@ -5678,7 +5678,7 @@
                 </a:solidFill>
                 <a:latin typeface="Microsoft YaHei"/>
               </a:rPr>
-              <a:t>映射命中时，一次业务调用完成</a:t>
+              <a:t>上下游 Schema 差异由策略转换消化</a:t>
             </a:r>
           </a:p>
         </p:txBody>
@@ -5804,7 +5804,7 @@
                 </a:solidFill>
                 <a:latin typeface="Microsoft YaHei"/>
               </a:rPr>
-              <a:t>模型决定「引用哪个对象」，Runtime 保证「真实、适配、合法」，然后才执行。</a:t>
+              <a:t>模型决定「引用哪条结果的哪个字段」，Runtime 保证「真实、适配、合法」，然后才执行。</a:t>
             </a:r>
           </a:p>
         </p:txBody>

</xml_diff>

<commit_message>
docs: feature the two visibility scenarios with policy-driven mask
Co-authored-by: Lizzy67 <Lizzy67@users.noreply.github.com>
</commit_message>
<xml_diff>
--- a/docs/tool_param_ref_onepage.pptx
+++ b/docs/tool_param_ref_onepage.pptx
@@ -3139,7 +3139,7 @@
         </p:nvSpPr>
         <p:spPr>
           <a:xfrm>
-            <a:off x="566928" y="274320"/>
+            <a:off x="566928" y="237744"/>
             <a:ext cx="11057839" cy="182880"/>
           </a:xfrm>
           <a:prstGeom prst="rect">
@@ -3181,8 +3181,8 @@
         </p:nvSpPr>
         <p:spPr>
           <a:xfrm>
-            <a:off x="566928" y="475488"/>
-            <a:ext cx="11057839" cy="384048"/>
+            <a:off x="566928" y="429768"/>
+            <a:ext cx="11057839" cy="365760"/>
           </a:xfrm>
           <a:prstGeom prst="rect">
             <a:avLst/>
@@ -3204,7 +3204,7 @@
               </a:spcAft>
             </a:pPr>
             <a:r>
-              <a:rPr sz="2150" b="1">
+              <a:rPr sz="2050" b="1">
                 <a:solidFill>
                   <a:srgbClr val="1C2925"/>
                 </a:solidFill>
@@ -3223,8 +3223,8 @@
         </p:nvSpPr>
         <p:spPr>
           <a:xfrm>
-            <a:off x="566928" y="896112"/>
-            <a:ext cx="10881360" cy="274320"/>
+            <a:off x="566928" y="822960"/>
+            <a:ext cx="10972800" cy="384048"/>
           </a:xfrm>
           <a:prstGeom prst="rect">
             <a:avLst/>
@@ -3246,13 +3246,22 @@
               </a:spcAft>
             </a:pPr>
             <a:r>
-              <a:rPr sz="1050" b="0">
+              <a:rPr sz="1000" b="0">
                 <a:solidFill>
                   <a:srgbClr val="1C2925"/>
                 </a:solidFill>
                 <a:latin typeface="Microsoft YaHei"/>
               </a:rPr>
-              <a:t>上一个工具的结果不再回灌给模型抄写，而是由模型在下游参数里写一个引用；Runtime 在工具执行前从工作记忆取出真值、按需转换、校验合法，再去调用工具。</a:t>
+              <a:t>上一个工具的结果不再由模型抄进下游参数，而是写一个引用 ${resultId.path}；Runtime 在工具执行前从工作记忆取出真值、按需转换、校验合法，再去调用工具。</a:t>
+            </a:r>
+            <a:r>
+              <a:rPr sz="100" b="0">
+                <a:solidFill>
+                  <a:srgbClr val="1C2925"/>
+                </a:solidFill>
+                <a:latin typeface="Microsoft YaHei"/>
+              </a:rPr>
+              <a:t/>
             </a:r>
           </a:p>
         </p:txBody>
@@ -3265,8 +3274,8 @@
         </p:nvSpPr>
         <p:spPr>
           <a:xfrm>
-            <a:off x="566928" y="1133856"/>
-            <a:ext cx="10607040" cy="219456"/>
+            <a:off x="566928" y="1188720"/>
+            <a:ext cx="10607040" cy="201168"/>
           </a:xfrm>
           <a:prstGeom prst="rect">
             <a:avLst/>
@@ -3288,13 +3297,13 @@
               </a:spcAft>
             </a:pPr>
             <a:r>
-              <a:rPr sz="1050" b="1">
+              <a:rPr sz="1000" b="1">
                 <a:solidFill>
                   <a:srgbClr val="0B544E"/>
                 </a:solidFill>
                 <a:latin typeface="Microsoft YaHei"/>
               </a:rPr>
-              <a:t>真值全程不经模型之手，存量工具一行不改。</a:t>
+              <a:t>真值不经模型之手，存量工具一行不改。</a:t>
             </a:r>
           </a:p>
         </p:txBody>
@@ -3350,7 +3359,7 @@
         </p:nvSpPr>
         <p:spPr>
           <a:xfrm>
-            <a:off x="566928" y="1591056"/>
+            <a:off x="566928" y="1554480"/>
             <a:ext cx="502920" cy="219456"/>
           </a:xfrm>
           <a:prstGeom prst="rect">
@@ -3392,7 +3401,7 @@
         </p:nvSpPr>
         <p:spPr>
           <a:xfrm>
-            <a:off x="1042416" y="1577340"/>
+            <a:off x="1042416" y="1540764"/>
             <a:ext cx="3108960" cy="237744"/>
           </a:xfrm>
           <a:prstGeom prst="rect">
@@ -3415,7 +3424,7 @@
               </a:spcAft>
             </a:pPr>
             <a:r>
-              <a:rPr sz="1300" b="1">
+              <a:rPr sz="1250" b="1">
                 <a:solidFill>
                   <a:srgbClr val="1C2925"/>
                 </a:solidFill>
@@ -3434,8 +3443,8 @@
         </p:nvSpPr>
         <p:spPr>
           <a:xfrm>
-            <a:off x="566928" y="1847088"/>
-            <a:ext cx="11057839" cy="475488"/>
+            <a:off x="566928" y="1792224"/>
+            <a:ext cx="11057839" cy="384048"/>
           </a:xfrm>
           <a:prstGeom prst="rect">
             <a:avLst/>
@@ -3450,20 +3459,20 @@
           <a:p>
             <a:pPr algn="l">
               <a:lnSpc>
-                <a:spcPct val="130000"/>
+                <a:spcPct val="125000"/>
               </a:lnSpc>
               <a:spcAft>
                 <a:spcPts val="200"/>
               </a:spcAft>
             </a:pPr>
             <a:r>
-              <a:rPr sz="1000" b="0">
+              <a:rPr sz="950" b="0">
                 <a:solidFill>
                   <a:srgbClr val="1C2925"/>
                 </a:solidFill>
                 <a:latin typeface="Microsoft YaHei"/>
               </a:rPr>
-              <a:t>下一个工具的参数常来自上一个工具的结果：文件 URI、对象 ID、大段文本、一整个列表。这些值现在要先整段塞回模型上下文，再由模型原样抄进下游参数——长 URI 抄着抄着就断了；结构不一致时还要模型改写大段 JSON。抄写和改写，两件事模型都做不稳，而且每一轮都在烧 Token。</a:t>
+              <a:t>下一个工具的参数常来自上一个工具的结果：文件 URI、对象 ID、大段文本、一整个列表。现在要先整段回灌上下文，再由模型原样抄进下游参数——长 URI 抄着抄着就断了；结构不一致时还要模型改写大段 JSON，每一轮都在烧 Token。</a:t>
             </a:r>
           </a:p>
         </p:txBody>
@@ -3476,8 +3485,8 @@
         </p:nvSpPr>
         <p:spPr>
           <a:xfrm>
-            <a:off x="566928" y="2395728"/>
-            <a:ext cx="11057839" cy="201168"/>
+            <a:off x="566928" y="2212848"/>
+            <a:ext cx="11057839" cy="182880"/>
           </a:xfrm>
           <a:prstGeom prst="rect">
             <a:avLst/>
@@ -3499,7 +3508,7 @@
               </a:spcAft>
             </a:pPr>
             <a:r>
-              <a:rPr sz="950" b="1">
+              <a:rPr sz="900" b="1">
                 <a:solidFill>
                   <a:srgbClr val="1C2925"/>
                 </a:solidFill>
@@ -3508,16 +3517,16 @@
               <a:t>抄不准 </a:t>
             </a:r>
             <a:r>
-              <a:rPr sz="950" b="0">
+              <a:rPr sz="900" b="0">
                 <a:solidFill>
                   <a:srgbClr val="6B7A74"/>
                 </a:solidFill>
                 <a:latin typeface="Microsoft YaHei"/>
               </a:rPr>
-              <a:t>长值复述易截断、改写、漏字符　　</a:t>
-            </a:r>
-            <a:r>
-              <a:rPr sz="950" b="1">
+              <a:t>长值复述易截断改写　　</a:t>
+            </a:r>
+            <a:r>
+              <a:rPr sz="900" b="1">
                 <a:solidFill>
                   <a:srgbClr val="1C2925"/>
                 </a:solidFill>
@@ -3526,16 +3535,16 @@
               <a:t>太昂贵 </a:t>
             </a:r>
             <a:r>
-              <a:rPr sz="950" b="0">
+              <a:rPr sz="900" b="0">
                 <a:solidFill>
                   <a:srgbClr val="6B7A74"/>
                 </a:solidFill>
                 <a:latin typeface="Microsoft YaHei"/>
               </a:rPr>
-              <a:t>大结果反复回灌，Token和时延一起涨　　</a:t>
-            </a:r>
-            <a:r>
-              <a:rPr sz="950" b="1">
+              <a:t>大结果反复回灌，Token与时延一起涨　　</a:t>
+            </a:r>
+            <a:r>
+              <a:rPr sz="900" b="1">
                 <a:solidFill>
                   <a:srgbClr val="1C2925"/>
                 </a:solidFill>
@@ -3544,7 +3553,7 @@
               <a:t>改不动 </a:t>
             </a:r>
             <a:r>
-              <a:rPr sz="950" b="0">
+              <a:rPr sz="900" b="0">
                 <a:solidFill>
                   <a:srgbClr val="6B7A74"/>
                 </a:solidFill>
@@ -3563,7 +3572,7 @@
         </p:nvSpPr>
         <p:spPr>
           <a:xfrm>
-            <a:off x="566928" y="2761488"/>
+            <a:off x="566928" y="2523744"/>
             <a:ext cx="502920" cy="219456"/>
           </a:xfrm>
           <a:prstGeom prst="rect">
@@ -3605,7 +3614,7 @@
         </p:nvSpPr>
         <p:spPr>
           <a:xfrm>
-            <a:off x="1042416" y="2747772"/>
+            <a:off x="1042416" y="2510027"/>
             <a:ext cx="3108960" cy="237744"/>
           </a:xfrm>
           <a:prstGeom prst="rect">
@@ -3628,7 +3637,7 @@
               </a:spcAft>
             </a:pPr>
             <a:r>
-              <a:rPr sz="1300" b="1">
+              <a:rPr sz="1250" b="1">
                 <a:solidFill>
                   <a:srgbClr val="1C2925"/>
                 </a:solidFill>
@@ -3647,7 +3656,7 @@
         </p:nvSpPr>
         <p:spPr>
           <a:xfrm>
-            <a:off x="4133087" y="2779776"/>
+            <a:off x="4133087" y="2542032"/>
             <a:ext cx="7863840" cy="219456"/>
           </a:xfrm>
           <a:prstGeom prst="rect">
@@ -3670,7 +3679,7 @@
               </a:spcAft>
             </a:pPr>
             <a:r>
-              <a:rPr sz="900" b="0">
+              <a:rPr sz="850" b="0">
                 <a:solidFill>
                   <a:srgbClr val="9AA8A2"/>
                 </a:solidFill>
@@ -3689,7 +3698,7 @@
         </p:nvSpPr>
         <p:spPr>
           <a:xfrm>
-            <a:off x="566928" y="3035808"/>
+            <a:off x="566928" y="2779776"/>
             <a:ext cx="2029968" cy="27940"/>
           </a:xfrm>
           <a:prstGeom prst="rect">
@@ -3732,8 +3741,8 @@
         </p:nvSpPr>
         <p:spPr>
           <a:xfrm>
-            <a:off x="566928" y="3063239"/>
-            <a:ext cx="2029968" cy="932688"/>
+            <a:off x="566928" y="2807208"/>
+            <a:ext cx="2029968" cy="841248"/>
           </a:xfrm>
           <a:prstGeom prst="rect">
             <a:avLst/>
@@ -3775,8 +3784,8 @@
         </p:nvSpPr>
         <p:spPr>
           <a:xfrm>
-            <a:off x="658368" y="3127248"/>
-            <a:ext cx="1847088" cy="155448"/>
+            <a:off x="658368" y="2862072"/>
+            <a:ext cx="1847088" cy="146304"/>
           </a:xfrm>
           <a:prstGeom prst="rect">
             <a:avLst/>
@@ -3798,7 +3807,7 @@
               </a:spcAft>
             </a:pPr>
             <a:r>
-              <a:rPr sz="800" b="1">
+              <a:rPr sz="760" b="1">
                 <a:solidFill>
                   <a:srgbClr val="9AA8A2"/>
                 </a:solidFill>
@@ -3817,8 +3826,8 @@
         </p:nvSpPr>
         <p:spPr>
           <a:xfrm>
-            <a:off x="658368" y="3291839"/>
-            <a:ext cx="1847088" cy="182880"/>
+            <a:off x="658368" y="3017520"/>
+            <a:ext cx="1847088" cy="173736"/>
           </a:xfrm>
           <a:prstGeom prst="rect">
             <a:avLst/>
@@ -3840,7 +3849,7 @@
               </a:spcAft>
             </a:pPr>
             <a:r>
-              <a:rPr sz="1050" b="1">
+              <a:rPr sz="1000" b="1">
                 <a:solidFill>
                   <a:srgbClr val="1C2925"/>
                 </a:solidFill>
@@ -3859,8 +3868,8 @@
         </p:nvSpPr>
         <p:spPr>
           <a:xfrm>
-            <a:off x="658368" y="3493008"/>
-            <a:ext cx="1847088" cy="457200"/>
+            <a:off x="658368" y="3209544"/>
+            <a:ext cx="1847088" cy="402336"/>
           </a:xfrm>
           <a:prstGeom prst="rect">
             <a:avLst/>
@@ -3875,20 +3884,20 @@
           <a:p>
             <a:pPr algn="l">
               <a:lnSpc>
-                <a:spcPct val="120000"/>
+                <a:spcPct val="118000"/>
               </a:lnSpc>
               <a:spcAft>
                 <a:spcPts val="200"/>
               </a:spcAft>
             </a:pPr>
             <a:r>
-              <a:rPr sz="830" b="0">
+              <a:rPr sz="800" b="0">
                 <a:solidFill>
                   <a:srgbClr val="6B7A74"/>
                 </a:solidFill>
                 <a:latin typeface="Microsoft YaHei"/>
               </a:rPr>
-              <a:t>返回结果默认写入工作记忆，得到短标识 resultId</a:t>
+              <a:t>结果默认写入工作记忆，得到短标识 resultId</a:t>
             </a:r>
           </a:p>
         </p:txBody>
@@ -3901,7 +3910,7 @@
         </p:nvSpPr>
         <p:spPr>
           <a:xfrm>
-            <a:off x="2610612" y="3383279"/>
+            <a:off x="2610612" y="3081528"/>
             <a:ext cx="201168" cy="237744"/>
           </a:xfrm>
           <a:prstGeom prst="rect">
@@ -3943,7 +3952,7 @@
         </p:nvSpPr>
         <p:spPr>
           <a:xfrm>
-            <a:off x="2816352" y="3035808"/>
+            <a:off x="2816352" y="2779776"/>
             <a:ext cx="2029968" cy="27940"/>
           </a:xfrm>
           <a:prstGeom prst="rect">
@@ -3986,8 +3995,8 @@
         </p:nvSpPr>
         <p:spPr>
           <a:xfrm>
-            <a:off x="2816352" y="3063239"/>
-            <a:ext cx="2029968" cy="932688"/>
+            <a:off x="2816352" y="2807208"/>
+            <a:ext cx="2029968" cy="841248"/>
           </a:xfrm>
           <a:prstGeom prst="rect">
             <a:avLst/>
@@ -4029,8 +4038,8 @@
         </p:nvSpPr>
         <p:spPr>
           <a:xfrm>
-            <a:off x="2907792" y="3127248"/>
-            <a:ext cx="1847088" cy="155448"/>
+            <a:off x="2907792" y="2862072"/>
+            <a:ext cx="1847088" cy="146304"/>
           </a:xfrm>
           <a:prstGeom prst="rect">
             <a:avLst/>
@@ -4052,7 +4061,7 @@
               </a:spcAft>
             </a:pPr>
             <a:r>
-              <a:rPr sz="800" b="1">
+              <a:rPr sz="760" b="1">
                 <a:solidFill>
                   <a:srgbClr val="9AA8A2"/>
                 </a:solidFill>
@@ -4071,8 +4080,8 @@
         </p:nvSpPr>
         <p:spPr>
           <a:xfrm>
-            <a:off x="2907792" y="3291839"/>
-            <a:ext cx="1847088" cy="182880"/>
+            <a:off x="2907792" y="3017520"/>
+            <a:ext cx="1847088" cy="173736"/>
           </a:xfrm>
           <a:prstGeom prst="rect">
             <a:avLst/>
@@ -4094,13 +4103,13 @@
               </a:spcAft>
             </a:pPr>
             <a:r>
-              <a:rPr sz="1050" b="1">
+              <a:rPr sz="1000" b="1">
                 <a:solidFill>
                   <a:srgbClr val="1C2925"/>
                 </a:solidFill>
                 <a:latin typeface="Microsoft YaHei"/>
               </a:rPr>
-              <a:t>送模呈现</a:t>
+              <a:t>按 Policy 送模</a:t>
             </a:r>
           </a:p>
         </p:txBody>
@@ -4113,8 +4122,8 @@
         </p:nvSpPr>
         <p:spPr>
           <a:xfrm>
-            <a:off x="2907792" y="3493008"/>
-            <a:ext cx="1847088" cy="457200"/>
+            <a:off x="2907792" y="3209544"/>
+            <a:ext cx="1847088" cy="402336"/>
           </a:xfrm>
           <a:prstGeom prst="rect">
             <a:avLst/>
@@ -4129,20 +4138,20 @@
           <a:p>
             <a:pPr algn="l">
               <a:lnSpc>
-                <a:spcPct val="120000"/>
+                <a:spcPct val="118000"/>
               </a:lnSpc>
               <a:spcAft>
                 <a:spcPts val="200"/>
               </a:spcAft>
             </a:pPr>
             <a:r>
-              <a:rPr sz="830" b="0">
+              <a:rPr sz="800" b="0">
                 <a:solidFill>
                   <a:srgbClr val="6B7A74"/>
                 </a:solidFill>
                 <a:latin typeface="Microsoft YaHei"/>
               </a:rPr>
-              <a:t>指针字段直接换成引用给模型；要推理的内容照常给</a:t>
+              <a:t>命中 mask policy 的字段换成引用，其余全量可见</a:t>
             </a:r>
           </a:p>
         </p:txBody>
@@ -4155,7 +4164,7 @@
         </p:nvSpPr>
         <p:spPr>
           <a:xfrm>
-            <a:off x="4860036" y="3383279"/>
+            <a:off x="4860036" y="3081528"/>
             <a:ext cx="201168" cy="237744"/>
           </a:xfrm>
           <a:prstGeom prst="rect">
@@ -4197,7 +4206,7 @@
         </p:nvSpPr>
         <p:spPr>
           <a:xfrm>
-            <a:off x="5065776" y="3035808"/>
+            <a:off x="5065776" y="2779776"/>
             <a:ext cx="2029968" cy="27940"/>
           </a:xfrm>
           <a:prstGeom prst="rect">
@@ -4240,8 +4249,8 @@
         </p:nvSpPr>
         <p:spPr>
           <a:xfrm>
-            <a:off x="5065776" y="3063239"/>
-            <a:ext cx="2029968" cy="932688"/>
+            <a:off x="5065776" y="2807208"/>
+            <a:ext cx="2029968" cy="841248"/>
           </a:xfrm>
           <a:prstGeom prst="rect">
             <a:avLst/>
@@ -4283,8 +4292,8 @@
         </p:nvSpPr>
         <p:spPr>
           <a:xfrm>
-            <a:off x="5157216" y="3127248"/>
-            <a:ext cx="1847088" cy="155448"/>
+            <a:off x="5157216" y="2862072"/>
+            <a:ext cx="1847088" cy="146304"/>
           </a:xfrm>
           <a:prstGeom prst="rect">
             <a:avLst/>
@@ -4306,7 +4315,7 @@
               </a:spcAft>
             </a:pPr>
             <a:r>
-              <a:rPr sz="800" b="1">
+              <a:rPr sz="760" b="1">
                 <a:solidFill>
                   <a:srgbClr val="9AA8A2"/>
                 </a:solidFill>
@@ -4325,8 +4334,8 @@
         </p:nvSpPr>
         <p:spPr>
           <a:xfrm>
-            <a:off x="5157216" y="3291839"/>
-            <a:ext cx="1847088" cy="182880"/>
+            <a:off x="5157216" y="3017520"/>
+            <a:ext cx="1847088" cy="173736"/>
           </a:xfrm>
           <a:prstGeom prst="rect">
             <a:avLst/>
@@ -4348,7 +4357,7 @@
               </a:spcAft>
             </a:pPr>
             <a:r>
-              <a:rPr sz="1050" b="1">
+              <a:rPr sz="1000" b="1">
                 <a:solidFill>
                   <a:srgbClr val="1C2925"/>
                 </a:solidFill>
@@ -4367,8 +4376,8 @@
         </p:nvSpPr>
         <p:spPr>
           <a:xfrm>
-            <a:off x="5157216" y="3493008"/>
-            <a:ext cx="1847088" cy="457200"/>
+            <a:off x="5157216" y="3209544"/>
+            <a:ext cx="1847088" cy="402336"/>
           </a:xfrm>
           <a:prstGeom prst="rect">
             <a:avLst/>
@@ -4383,20 +4392,20 @@
           <a:p>
             <a:pPr algn="l">
               <a:lnSpc>
-                <a:spcPct val="120000"/>
+                <a:spcPct val="118000"/>
               </a:lnSpc>
               <a:spcAft>
                 <a:spcPts val="200"/>
               </a:spcAft>
             </a:pPr>
             <a:r>
-              <a:rPr sz="830" b="0">
+              <a:rPr sz="800" b="0">
                 <a:solidFill>
                   <a:srgbClr val="6B7A74"/>
                 </a:solidFill>
                 <a:latin typeface="Microsoft YaHei"/>
               </a:rPr>
-              <a:t>下游参数填 ${resultId.path}，不复述真值，所见即所填</a:t>
+              <a:t>下游参数填 ${resultId.path}，可见与否都不复述真值</a:t>
             </a:r>
           </a:p>
         </p:txBody>
@@ -4409,7 +4418,7 @@
         </p:nvSpPr>
         <p:spPr>
           <a:xfrm>
-            <a:off x="7109459" y="3383279"/>
+            <a:off x="7109459" y="3081528"/>
             <a:ext cx="201168" cy="237744"/>
           </a:xfrm>
           <a:prstGeom prst="rect">
@@ -4451,7 +4460,7 @@
         </p:nvSpPr>
         <p:spPr>
           <a:xfrm>
-            <a:off x="7315200" y="3035808"/>
+            <a:off x="7315200" y="2779776"/>
             <a:ext cx="2029968" cy="27940"/>
           </a:xfrm>
           <a:prstGeom prst="rect">
@@ -4494,8 +4503,8 @@
         </p:nvSpPr>
         <p:spPr>
           <a:xfrm>
-            <a:off x="7315200" y="3063239"/>
-            <a:ext cx="2029968" cy="932688"/>
+            <a:off x="7315200" y="2807208"/>
+            <a:ext cx="2029968" cy="841248"/>
           </a:xfrm>
           <a:prstGeom prst="rect">
             <a:avLst/>
@@ -4537,8 +4546,8 @@
         </p:nvSpPr>
         <p:spPr>
           <a:xfrm>
-            <a:off x="7406640" y="3127248"/>
-            <a:ext cx="1847088" cy="155448"/>
+            <a:off x="7406640" y="2862072"/>
+            <a:ext cx="1847088" cy="146304"/>
           </a:xfrm>
           <a:prstGeom prst="rect">
             <a:avLst/>
@@ -4560,7 +4569,7 @@
               </a:spcAft>
             </a:pPr>
             <a:r>
-              <a:rPr sz="800" b="1">
+              <a:rPr sz="760" b="1">
                 <a:solidFill>
                   <a:srgbClr val="9AA8A2"/>
                 </a:solidFill>
@@ -4579,8 +4588,8 @@
         </p:nvSpPr>
         <p:spPr>
           <a:xfrm>
-            <a:off x="7406640" y="3291839"/>
-            <a:ext cx="1847088" cy="182880"/>
+            <a:off x="7406640" y="3017520"/>
+            <a:ext cx="1847088" cy="173736"/>
           </a:xfrm>
           <a:prstGeom prst="rect">
             <a:avLst/>
@@ -4602,7 +4611,7 @@
               </a:spcAft>
             </a:pPr>
             <a:r>
-              <a:rPr sz="1050" b="1">
+              <a:rPr sz="1000" b="1">
                 <a:solidFill>
                   <a:srgbClr val="1C2925"/>
                 </a:solidFill>
@@ -4621,8 +4630,8 @@
         </p:nvSpPr>
         <p:spPr>
           <a:xfrm>
-            <a:off x="7406640" y="3493008"/>
-            <a:ext cx="1847088" cy="457200"/>
+            <a:off x="7406640" y="3209544"/>
+            <a:ext cx="1847088" cy="402336"/>
           </a:xfrm>
           <a:prstGeom prst="rect">
             <a:avLst/>
@@ -4637,20 +4646,20 @@
           <a:p>
             <a:pPr algn="l">
               <a:lnSpc>
-                <a:spcPct val="120000"/>
+                <a:spcPct val="118000"/>
               </a:lnSpc>
               <a:spcAft>
                 <a:spcPts val="200"/>
               </a:spcAft>
             </a:pPr>
             <a:r>
-              <a:rPr sz="830" b="0">
+              <a:rPr sz="800" b="0">
                 <a:solidFill>
                   <a:srgbClr val="6B7A74"/>
                 </a:solidFill>
                 <a:latin typeface="Microsoft YaHei"/>
               </a:rPr>
-              <a:t>查工作记忆回填真值，按策略适配结构，验完Schema与权限</a:t>
+              <a:t>查记忆回填真值，按策略适配结构，验完Schema与权限</a:t>
             </a:r>
           </a:p>
         </p:txBody>
@@ -4663,7 +4672,7 @@
         </p:nvSpPr>
         <p:spPr>
           <a:xfrm>
-            <a:off x="9358884" y="3383279"/>
+            <a:off x="9358884" y="3081528"/>
             <a:ext cx="201168" cy="237744"/>
           </a:xfrm>
           <a:prstGeom prst="rect">
@@ -4705,7 +4714,7 @@
         </p:nvSpPr>
         <p:spPr>
           <a:xfrm>
-            <a:off x="9564624" y="3035808"/>
+            <a:off x="9564624" y="2779776"/>
             <a:ext cx="2029968" cy="27940"/>
           </a:xfrm>
           <a:prstGeom prst="rect">
@@ -4748,8 +4757,8 @@
         </p:nvSpPr>
         <p:spPr>
           <a:xfrm>
-            <a:off x="9564624" y="3063239"/>
-            <a:ext cx="2029968" cy="932688"/>
+            <a:off x="9564624" y="2807208"/>
+            <a:ext cx="2029968" cy="841248"/>
           </a:xfrm>
           <a:prstGeom prst="rect">
             <a:avLst/>
@@ -4791,8 +4800,8 @@
         </p:nvSpPr>
         <p:spPr>
           <a:xfrm>
-            <a:off x="9656063" y="3127248"/>
-            <a:ext cx="1847088" cy="155448"/>
+            <a:off x="9656063" y="2862072"/>
+            <a:ext cx="1847088" cy="146304"/>
           </a:xfrm>
           <a:prstGeom prst="rect">
             <a:avLst/>
@@ -4814,7 +4823,7 @@
               </a:spcAft>
             </a:pPr>
             <a:r>
-              <a:rPr sz="800" b="1">
+              <a:rPr sz="760" b="1">
                 <a:solidFill>
                   <a:srgbClr val="9AA8A2"/>
                 </a:solidFill>
@@ -4833,8 +4842,8 @@
         </p:nvSpPr>
         <p:spPr>
           <a:xfrm>
-            <a:off x="9656063" y="3291839"/>
-            <a:ext cx="1847088" cy="182880"/>
+            <a:off x="9656063" y="3017520"/>
+            <a:ext cx="1847088" cy="173736"/>
           </a:xfrm>
           <a:prstGeom prst="rect">
             <a:avLst/>
@@ -4856,7 +4865,7 @@
               </a:spcAft>
             </a:pPr>
             <a:r>
-              <a:rPr sz="1050" b="1">
+              <a:rPr sz="1000" b="1">
                 <a:solidFill>
                   <a:srgbClr val="1C2925"/>
                 </a:solidFill>
@@ -4875,8 +4884,8 @@
         </p:nvSpPr>
         <p:spPr>
           <a:xfrm>
-            <a:off x="9656063" y="3493008"/>
-            <a:ext cx="1847088" cy="457200"/>
+            <a:off x="9656063" y="3209544"/>
+            <a:ext cx="1847088" cy="402336"/>
           </a:xfrm>
           <a:prstGeom prst="rect">
             <a:avLst/>
@@ -4891,14 +4900,14 @@
           <a:p>
             <a:pPr algn="l">
               <a:lnSpc>
-                <a:spcPct val="120000"/>
+                <a:spcPct val="118000"/>
               </a:lnSpc>
               <a:spcAft>
                 <a:spcPts val="200"/>
               </a:spcAft>
             </a:pPr>
             <a:r>
-              <a:rPr sz="830" b="0">
+              <a:rPr sz="800" b="0">
                 <a:solidFill>
                   <a:srgbClr val="6B7A74"/>
                 </a:solidFill>
@@ -4917,7 +4926,7 @@
         </p:nvSpPr>
         <p:spPr>
           <a:xfrm>
-            <a:off x="566928" y="4224528"/>
+            <a:off x="566928" y="3767328"/>
             <a:ext cx="502920" cy="219456"/>
           </a:xfrm>
           <a:prstGeom prst="rect">
@@ -4959,7 +4968,7 @@
         </p:nvSpPr>
         <p:spPr>
           <a:xfrm>
-            <a:off x="1042416" y="4210812"/>
+            <a:off x="1042416" y="3753612"/>
             <a:ext cx="3108960" cy="237744"/>
           </a:xfrm>
           <a:prstGeom prst="rect">
@@ -4982,13 +4991,13 @@
               </a:spcAft>
             </a:pPr>
             <a:r>
-              <a:rPr sz="1300" b="1">
+              <a:rPr sz="1250" b="1">
                 <a:solidFill>
                   <a:srgbClr val="1C2925"/>
                 </a:solidFill>
                 <a:latin typeface="Microsoft YaHei"/>
               </a:rPr>
-              <a:t>三个关键问题</a:t>
+              <a:t>两种场景</a:t>
             </a:r>
           </a:p>
         </p:txBody>
@@ -5001,8 +5010,8 @@
         </p:nvSpPr>
         <p:spPr>
           <a:xfrm>
-            <a:off x="566928" y="4498848"/>
-            <a:ext cx="3442106" cy="201168"/>
+            <a:off x="4133087" y="3785615"/>
+            <a:ext cx="7863840" cy="219456"/>
           </a:xfrm>
           <a:prstGeom prst="rect">
             <a:avLst/>
@@ -5024,13 +5033,13 @@
               </a:spcAft>
             </a:pPr>
             <a:r>
-              <a:rPr sz="1150" b="1">
-                <a:solidFill>
-                  <a:srgbClr val="0B544E"/>
-                </a:solidFill>
-                <a:latin typeface="Microsoft YaHei"/>
-              </a:rPr>
-              <a:t>引用怎么写</a:t>
+              <a:rPr sz="850" b="0">
+                <a:solidFill>
+                  <a:srgbClr val="9AA8A2"/>
+                </a:solidFill>
+                <a:latin typeface="Microsoft YaHei"/>
+              </a:rPr>
+              <a:t>按「模型要不要看到这个值」分流，殊途同归于引用</a:t>
             </a:r>
           </a:p>
         </p:txBody>
@@ -5043,8 +5052,8 @@
         </p:nvSpPr>
         <p:spPr>
           <a:xfrm>
-            <a:off x="566928" y="4736592"/>
-            <a:ext cx="3442106" cy="1005840"/>
+            <a:off x="566928" y="4023360"/>
+            <a:ext cx="5300319" cy="164592"/>
           </a:xfrm>
           <a:prstGeom prst="rect">
             <a:avLst/>
@@ -5059,59 +5068,124 @@
           <a:p>
             <a:pPr algn="l">
               <a:lnSpc>
-                <a:spcPct val="125000"/>
+                <a:spcPct val="115000"/>
               </a:lnSpc>
               <a:spcAft>
                 <a:spcPts val="200"/>
               </a:spcAft>
             </a:pPr>
             <a:r>
-              <a:rPr sz="860" b="0">
-                <a:solidFill>
-                  <a:srgbClr val="1C2925"/>
-                </a:solidFill>
-                <a:latin typeface="Microsoft YaHei"/>
-              </a:rPr>
-              <a:t>用 ${resultId.path} 指定「哪条结果的哪个字段」：resultId 是入库时分配的短标识，path 支持点号取嵌套字段，如 ${a1b2c3d4.data.fileUri}。</a:t>
-            </a:r>
-          </a:p>
+              <a:rPr sz="819" b="1">
+                <a:solidFill>
+                  <a:srgbClr val="9AA8A2"/>
+                </a:solidFill>
+                <a:latin typeface="Microsoft YaHei"/>
+              </a:rPr>
+              <a:t>场景一 · 可见但引用</a:t>
+            </a:r>
+          </a:p>
+        </p:txBody>
+      </p:sp>
+      <p:sp>
+        <p:nvSpPr>
+          <p:cNvPr id="48" name="TextBox 47"/>
+          <p:cNvSpPr txBox="1"/>
+          <p:nvPr/>
+        </p:nvSpPr>
+        <p:spPr>
+          <a:xfrm>
+            <a:off x="566928" y="4197096"/>
+            <a:ext cx="5300319" cy="182880"/>
+          </a:xfrm>
+          <a:prstGeom prst="rect">
+            <a:avLst/>
+          </a:prstGeom>
+          <a:noFill/>
+        </p:spPr>
+        <p:txBody>
+          <a:bodyPr wrap="square" lIns="0" rIns="0" tIns="0" bIns="0">
+            <a:spAutoFit/>
+          </a:bodyPr>
+          <a:lstStyle/>
           <a:p>
             <a:pPr algn="l">
               <a:lnSpc>
-                <a:spcPct val="125000"/>
+                <a:spcPct val="115000"/>
               </a:lnSpc>
               <a:spcAft>
                 <a:spcPts val="200"/>
               </a:spcAft>
             </a:pPr>
             <a:r>
-              <a:rPr sz="860" b="0">
-                <a:solidFill>
-                  <a:srgbClr val="6B7A74"/>
-                </a:solidFill>
-                <a:latin typeface="Microsoft YaHei"/>
-              </a:rPr>
-              <a:t>模型不需要看值时，送模前就换成引用，照抄即可；需要看值时内容照常给，参数仍写引用——「看」与「传」分开。</a:t>
-            </a:r>
-          </a:p>
-        </p:txBody>
-      </p:sp>
-      <p:sp>
-        <p:nvSpPr>
-          <p:cNvPr id="48" name="Rectangle 47"/>
+              <a:rPr sz="1050" b="1">
+                <a:solidFill>
+                  <a:srgbClr val="0B544E"/>
+                </a:solidFill>
+                <a:latin typeface="Microsoft YaHei"/>
+              </a:rPr>
+              <a:t>结果全量进上下文，参数仍写引用</a:t>
+            </a:r>
+          </a:p>
+        </p:txBody>
+      </p:sp>
+      <p:sp>
+        <p:nvSpPr>
+          <p:cNvPr id="49" name="TextBox 48"/>
+          <p:cNvSpPr txBox="1"/>
+          <p:nvPr/>
+        </p:nvSpPr>
+        <p:spPr>
+          <a:xfrm>
+            <a:off x="566928" y="4416552"/>
+            <a:ext cx="5300319" cy="512064"/>
+          </a:xfrm>
+          <a:prstGeom prst="rect">
+            <a:avLst/>
+          </a:prstGeom>
+          <a:noFill/>
+        </p:spPr>
+        <p:txBody>
+          <a:bodyPr wrap="square" lIns="0" rIns="0" tIns="0" bIns="0">
+            <a:spAutoFit/>
+          </a:bodyPr>
+          <a:lstStyle/>
+          <a:p>
+            <a:pPr algn="l">
+              <a:lnSpc>
+                <a:spcPct val="122000"/>
+              </a:lnSpc>
+              <a:spcAft>
+                <a:spcPts val="200"/>
+              </a:spcAft>
+            </a:pPr>
+            <a:r>
+              <a:rPr sz="840" b="0">
+                <a:solidFill>
+                  <a:srgbClr val="1C2925"/>
+                </a:solidFill>
+                <a:latin typeface="Microsoft YaHei"/>
+              </a:rPr>
+              <a:t>模型需要读内容才能决策：工具返回原样进入上下文，推理照常。唯一约束是传给下游时参数写 ${resultId.path}，不许把看过的内容再抄一遍——「看」与「传」分开，由 Skill 约定与提示词共同约束。</a:t>
+            </a:r>
+          </a:p>
+        </p:txBody>
+      </p:sp>
+      <p:sp>
+        <p:nvSpPr>
+          <p:cNvPr id="50" name="Rectangle 49"/>
           <p:cNvSpPr/>
           <p:nvPr/>
         </p:nvSpPr>
         <p:spPr>
           <a:xfrm>
-            <a:off x="4173626" y="4526280"/>
-            <a:ext cx="9525" cy="1170432"/>
+            <a:off x="566928" y="4956048"/>
+            <a:ext cx="5300319" cy="384048"/>
           </a:xfrm>
           <a:prstGeom prst="rect">
             <a:avLst/>
           </a:prstGeom>
           <a:solidFill>
-            <a:srgbClr val="DDE5E1"/>
+            <a:srgbClr val="F4F8F6"/>
           </a:solidFill>
           <a:ln>
             <a:noFill/>
@@ -5141,123 +5215,20 @@
       </p:sp>
       <p:sp>
         <p:nvSpPr>
-          <p:cNvPr id="49" name="TextBox 48"/>
-          <p:cNvSpPr txBox="1"/>
-          <p:nvPr/>
-        </p:nvSpPr>
-        <p:spPr>
-          <a:xfrm>
-            <a:off x="4374794" y="4498848"/>
-            <a:ext cx="3442106" cy="201168"/>
-          </a:xfrm>
-          <a:prstGeom prst="rect">
-            <a:avLst/>
-          </a:prstGeom>
-          <a:noFill/>
-        </p:spPr>
-        <p:txBody>
-          <a:bodyPr wrap="square" lIns="0" rIns="0" tIns="0" bIns="0">
-            <a:spAutoFit/>
-          </a:bodyPr>
-          <a:lstStyle/>
-          <a:p>
-            <a:pPr algn="l">
-              <a:lnSpc>
-                <a:spcPct val="115000"/>
-              </a:lnSpc>
-              <a:spcAft>
-                <a:spcPts val="200"/>
-              </a:spcAft>
-            </a:pPr>
-            <a:r>
-              <a:rPr sz="1150" b="1">
-                <a:solidFill>
-                  <a:srgbClr val="0B544E"/>
-                </a:solidFill>
-                <a:latin typeface="Microsoft YaHei"/>
-              </a:rPr>
-              <a:t>真值从哪来</a:t>
-            </a:r>
-          </a:p>
-        </p:txBody>
-      </p:sp>
-      <p:sp>
-        <p:nvSpPr>
-          <p:cNvPr id="50" name="TextBox 49"/>
-          <p:cNvSpPr txBox="1"/>
-          <p:nvPr/>
-        </p:nvSpPr>
-        <p:spPr>
-          <a:xfrm>
-            <a:off x="4374794" y="4736592"/>
-            <a:ext cx="3442106" cy="1005840"/>
-          </a:xfrm>
-          <a:prstGeom prst="rect">
-            <a:avLst/>
-          </a:prstGeom>
-          <a:noFill/>
-        </p:spPr>
-        <p:txBody>
-          <a:bodyPr wrap="square" lIns="0" rIns="0" tIns="0" bIns="0">
-            <a:spAutoFit/>
-          </a:bodyPr>
-          <a:lstStyle/>
-          <a:p>
-            <a:pPr algn="l">
-              <a:lnSpc>
-                <a:spcPct val="125000"/>
-              </a:lnSpc>
-              <a:spcAft>
-                <a:spcPts val="200"/>
-              </a:spcAft>
-            </a:pPr>
-            <a:r>
-              <a:rPr sz="860" b="0">
-                <a:solidFill>
-                  <a:srgbClr val="1C2925"/>
-                </a:solidFill>
-                <a:latin typeface="Microsoft YaHei"/>
-              </a:rPr>
-              <a:t>只从工作记忆取：先查全量结果集，未命中再查工具适配视图。resultId 由 Runtime 统一生成，对内保留与 toolCallId 的映射，可追踪、可对账。</a:t>
-            </a:r>
-          </a:p>
-          <a:p>
-            <a:pPr algn="l">
-              <a:lnSpc>
-                <a:spcPct val="125000"/>
-              </a:lnSpc>
-              <a:spcAft>
-                <a:spcPts val="200"/>
-              </a:spcAft>
-            </a:pPr>
-            <a:r>
-              <a:rPr sz="860" b="0">
-                <a:solidFill>
-                  <a:srgbClr val="6B7A74"/>
-                </a:solidFill>
-                <a:latin typeface="Microsoft YaHei"/>
-              </a:rPr>
-              <a:t>结构不一致时按参数策略转换：[563,728] 自动变成 [{"file_id":"563"},…]，模型和工具都不用动。</a:t>
-            </a:r>
-          </a:p>
-        </p:txBody>
-      </p:sp>
-      <p:sp>
-        <p:nvSpPr>
           <p:cNvPr id="51" name="Rectangle 50"/>
           <p:cNvSpPr/>
           <p:nvPr/>
         </p:nvSpPr>
         <p:spPr>
           <a:xfrm>
-            <a:off x="7981492" y="4526280"/>
-            <a:ext cx="9525" cy="1170432"/>
+            <a:off x="566928" y="4956048"/>
+            <a:ext cx="20320" cy="384048"/>
           </a:xfrm>
           <a:prstGeom prst="rect">
             <a:avLst/>
           </a:prstGeom>
           <a:solidFill>
-            <a:srgbClr val="DDE5E1"/>
+            <a:srgbClr val="0E6F66"/>
           </a:solidFill>
           <a:ln>
             <a:noFill/>
@@ -5293,50 +5264,8 @@
         </p:nvSpPr>
         <p:spPr>
           <a:xfrm>
-            <a:off x="8182660" y="4498848"/>
-            <a:ext cx="3442106" cy="201168"/>
-          </a:xfrm>
-          <a:prstGeom prst="rect">
-            <a:avLst/>
-          </a:prstGeom>
-          <a:noFill/>
-        </p:spPr>
-        <p:txBody>
-          <a:bodyPr wrap="square" lIns="0" rIns="0" tIns="0" bIns="0">
-            <a:spAutoFit/>
-          </a:bodyPr>
-          <a:lstStyle/>
-          <a:p>
-            <a:pPr algn="l">
-              <a:lnSpc>
-                <a:spcPct val="115000"/>
-              </a:lnSpc>
-              <a:spcAft>
-                <a:spcPts val="200"/>
-              </a:spcAft>
-            </a:pPr>
-            <a:r>
-              <a:rPr sz="1150" b="1">
-                <a:solidFill>
-                  <a:srgbClr val="0B544E"/>
-                </a:solidFill>
-                <a:latin typeface="Microsoft YaHei"/>
-              </a:rPr>
-              <a:t>出错怎么办</a:t>
-            </a:r>
-          </a:p>
-        </p:txBody>
-      </p:sp>
-      <p:sp>
-        <p:nvSpPr>
-          <p:cNvPr id="53" name="TextBox 52"/>
-          <p:cNvSpPr txBox="1"/>
-          <p:nvPr/>
-        </p:nvSpPr>
-        <p:spPr>
-          <a:xfrm>
-            <a:off x="8182660" y="4736592"/>
-            <a:ext cx="3442106" cy="1005840"/>
+            <a:off x="676656" y="4992624"/>
+            <a:ext cx="5117439" cy="329184"/>
           </a:xfrm>
           <a:prstGeom prst="rect">
             <a:avLst/>
@@ -5358,13 +5287,22 @@
               </a:spcAft>
             </a:pPr>
             <a:r>
-              <a:rPr sz="860" b="0">
+              <a:rPr sz="780" b="0">
+                <a:solidFill>
+                  <a:srgbClr val="9AA8A2"/>
+                </a:solidFill>
+                <a:latin typeface="Microsoft YaHei"/>
+              </a:rPr>
+              <a:t>上下文：</a:t>
+            </a:r>
+            <a:r>
+              <a:rPr sz="780" b="0">
                 <a:solidFill>
                   <a:srgbClr val="1C2925"/>
                 </a:solidFill>
                 <a:latin typeface="Microsoft YaHei"/>
               </a:rPr>
-              <a:t>引用非法、结果不存在、字段没有、转换失败，一律短路：${…} 原文绝不透传给工具，错误明确回给模型，引导改写后重试。</a:t>
+              <a:t>text = "血糖偏高，建议…"（全量可见）</a:t>
             </a:r>
           </a:p>
           <a:p>
@@ -5377,27 +5315,36 @@
               </a:spcAft>
             </a:pPr>
             <a:r>
-              <a:rPr sz="860" b="0">
-                <a:solidFill>
-                  <a:srgbClr val="6B7A74"/>
-                </a:solidFill>
-                <a:latin typeface="Microsoft YaHei"/>
-              </a:rPr>
-              <a:t>结果带会话作用域和有效期，过期或越权即拒绝；并行链路必须显式写 resultId，不允许含糊的「上一条」。</a:t>
-            </a:r>
-          </a:p>
-        </p:txBody>
-      </p:sp>
-      <p:sp>
-        <p:nvSpPr>
-          <p:cNvPr id="54" name="Rectangle 53"/>
+              <a:rPr sz="780" b="0">
+                <a:solidFill>
+                  <a:srgbClr val="9AA8A2"/>
+                </a:solidFill>
+                <a:latin typeface="Microsoft YaHei"/>
+              </a:rPr>
+              <a:t>模型出参：</a:t>
+            </a:r>
+            <a:r>
+              <a:rPr sz="780" b="1">
+                <a:solidFill>
+                  <a:srgbClr val="0B544E"/>
+                </a:solidFill>
+                <a:latin typeface="Microsoft YaHei"/>
+              </a:rPr>
+              <a:t>report(content = ${e5f6a7b8.text})</a:t>
+            </a:r>
+          </a:p>
+        </p:txBody>
+      </p:sp>
+      <p:sp>
+        <p:nvSpPr>
+          <p:cNvPr id="53" name="Rectangle 52"/>
           <p:cNvSpPr/>
           <p:nvPr/>
         </p:nvSpPr>
         <p:spPr>
           <a:xfrm>
-            <a:off x="566928" y="5870448"/>
-            <a:ext cx="11057839" cy="9525"/>
+            <a:off x="6095847" y="4069080"/>
+            <a:ext cx="9525" cy="1298448"/>
           </a:xfrm>
           <a:prstGeom prst="rect">
             <a:avLst/>
@@ -5433,14 +5380,14 @@
       </p:sp>
       <p:sp>
         <p:nvSpPr>
-          <p:cNvPr id="55" name="TextBox 54"/>
+          <p:cNvPr id="54" name="TextBox 53"/>
           <p:cNvSpPr txBox="1"/>
           <p:nvPr/>
         </p:nvSpPr>
         <p:spPr>
           <a:xfrm>
-            <a:off x="566928" y="5998464"/>
-            <a:ext cx="2581579" cy="201168"/>
+            <a:off x="6324447" y="4023360"/>
+            <a:ext cx="5300319" cy="164592"/>
           </a:xfrm>
           <a:prstGeom prst="rect">
             <a:avLst/>
@@ -5462,27 +5409,27 @@
               </a:spcAft>
             </a:pPr>
             <a:r>
-              <a:rPr sz="1100" b="1">
-                <a:solidFill>
-                  <a:srgbClr val="0B544E"/>
-                </a:solidFill>
-                <a:latin typeface="Microsoft YaHei"/>
-              </a:rPr>
-              <a:t>省 Token</a:t>
-            </a:r>
-          </a:p>
-        </p:txBody>
-      </p:sp>
-      <p:sp>
-        <p:nvSpPr>
-          <p:cNvPr id="56" name="TextBox 55"/>
+              <a:rPr sz="819" b="1">
+                <a:solidFill>
+                  <a:srgbClr val="9AA8A2"/>
+                </a:solidFill>
+                <a:latin typeface="Microsoft YaHei"/>
+              </a:rPr>
+              <a:t>场景二 · Mask 后不可见</a:t>
+            </a:r>
+          </a:p>
+        </p:txBody>
+      </p:sp>
+      <p:sp>
+        <p:nvSpPr>
+          <p:cNvPr id="55" name="TextBox 54"/>
           <p:cNvSpPr txBox="1"/>
           <p:nvPr/>
         </p:nvSpPr>
         <p:spPr>
           <a:xfrm>
-            <a:off x="566928" y="6217920"/>
-            <a:ext cx="2581579" cy="182880"/>
+            <a:off x="6324447" y="4197096"/>
+            <a:ext cx="5300319" cy="182880"/>
           </a:xfrm>
           <a:prstGeom prst="rect">
             <a:avLst/>
@@ -5504,27 +5451,243 @@
               </a:spcAft>
             </a:pPr>
             <a:r>
-              <a:rPr sz="850" b="0">
+              <a:rPr sz="1050" b="1">
+                <a:solidFill>
+                  <a:srgbClr val="0B544E"/>
+                </a:solidFill>
+                <a:latin typeface="Microsoft YaHei"/>
+              </a:rPr>
+              <a:t>Policy 注入掩码，模型全程不接触真值</a:t>
+            </a:r>
+          </a:p>
+        </p:txBody>
+      </p:sp>
+      <p:sp>
+        <p:nvSpPr>
+          <p:cNvPr id="56" name="TextBox 55"/>
+          <p:cNvSpPr txBox="1"/>
+          <p:nvPr/>
+        </p:nvSpPr>
+        <p:spPr>
+          <a:xfrm>
+            <a:off x="6324447" y="4416552"/>
+            <a:ext cx="5300319" cy="512064"/>
+          </a:xfrm>
+          <a:prstGeom prst="rect">
+            <a:avLst/>
+          </a:prstGeom>
+          <a:noFill/>
+        </p:spPr>
+        <p:txBody>
+          <a:bodyPr wrap="square" lIns="0" rIns="0" tIns="0" bIns="0">
+            <a:spAutoFit/>
+          </a:bodyPr>
+          <a:lstStyle/>
+          <a:p>
+            <a:pPr algn="l">
+              <a:lnSpc>
+                <a:spcPct val="122000"/>
+              </a:lnSpc>
+              <a:spcAft>
+                <a:spcPts val="200"/>
+              </a:spcAft>
+            </a:pPr>
+            <a:r>
+              <a:rPr sz="840" b="0">
+                <a:solidFill>
+                  <a:srgbClr val="1C2925"/>
+                </a:solidFill>
+                <a:latin typeface="Microsoft YaHei"/>
+              </a:rPr>
+              <a:t>模型不需要理解的值（文件URI、对象ID等指针字段），送模前就替换成引用。规则由两层 Policy 注入：通用 Policy 按字段名兜底（fileUri、fileId、*Url…），业务 Policy 按工具粒度增删覆盖，业务优先。</a:t>
+            </a:r>
+          </a:p>
+        </p:txBody>
+      </p:sp>
+      <p:sp>
+        <p:nvSpPr>
+          <p:cNvPr id="57" name="Rectangle 56"/>
+          <p:cNvSpPr/>
+          <p:nvPr/>
+        </p:nvSpPr>
+        <p:spPr>
+          <a:xfrm>
+            <a:off x="6324447" y="4956048"/>
+            <a:ext cx="5300319" cy="384048"/>
+          </a:xfrm>
+          <a:prstGeom prst="rect">
+            <a:avLst/>
+          </a:prstGeom>
+          <a:solidFill>
+            <a:srgbClr val="F4F8F6"/>
+          </a:solidFill>
+          <a:ln>
+            <a:noFill/>
+          </a:ln>
+        </p:spPr>
+        <p:style>
+          <a:lnRef idx="1">
+            <a:schemeClr val="accent1"/>
+          </a:lnRef>
+          <a:fillRef idx="3">
+            <a:schemeClr val="accent1"/>
+          </a:fillRef>
+          <a:effectRef idx="2">
+            <a:schemeClr val="accent1"/>
+          </a:effectRef>
+          <a:fontRef idx="minor">
+            <a:schemeClr val="lt1"/>
+          </a:fontRef>
+        </p:style>
+        <p:txBody>
+          <a:bodyPr rtlCol="0" anchor="ctr"/>
+          <a:lstStyle/>
+          <a:p>
+            <a:pPr algn="ctr"/>
+          </a:p>
+        </p:txBody>
+      </p:sp>
+      <p:sp>
+        <p:nvSpPr>
+          <p:cNvPr id="58" name="Rectangle 57"/>
+          <p:cNvSpPr/>
+          <p:nvPr/>
+        </p:nvSpPr>
+        <p:spPr>
+          <a:xfrm>
+            <a:off x="6324447" y="4956048"/>
+            <a:ext cx="20320" cy="384048"/>
+          </a:xfrm>
+          <a:prstGeom prst="rect">
+            <a:avLst/>
+          </a:prstGeom>
+          <a:solidFill>
+            <a:srgbClr val="0E6F66"/>
+          </a:solidFill>
+          <a:ln>
+            <a:noFill/>
+          </a:ln>
+        </p:spPr>
+        <p:style>
+          <a:lnRef idx="1">
+            <a:schemeClr val="accent1"/>
+          </a:lnRef>
+          <a:fillRef idx="3">
+            <a:schemeClr val="accent1"/>
+          </a:fillRef>
+          <a:effectRef idx="2">
+            <a:schemeClr val="accent1"/>
+          </a:effectRef>
+          <a:fontRef idx="minor">
+            <a:schemeClr val="lt1"/>
+          </a:fontRef>
+        </p:style>
+        <p:txBody>
+          <a:bodyPr rtlCol="0" anchor="ctr"/>
+          <a:lstStyle/>
+          <a:p>
+            <a:pPr algn="ctr"/>
+          </a:p>
+        </p:txBody>
+      </p:sp>
+      <p:sp>
+        <p:nvSpPr>
+          <p:cNvPr id="59" name="TextBox 58"/>
+          <p:cNvSpPr txBox="1"/>
+          <p:nvPr/>
+        </p:nvSpPr>
+        <p:spPr>
+          <a:xfrm>
+            <a:off x="6434175" y="4992624"/>
+            <a:ext cx="5117439" cy="329184"/>
+          </a:xfrm>
+          <a:prstGeom prst="rect">
+            <a:avLst/>
+          </a:prstGeom>
+          <a:noFill/>
+        </p:spPr>
+        <p:txBody>
+          <a:bodyPr wrap="square" lIns="0" rIns="0" tIns="0" bIns="0">
+            <a:spAutoFit/>
+          </a:bodyPr>
+          <a:lstStyle/>
+          <a:p>
+            <a:pPr algn="l">
+              <a:lnSpc>
+                <a:spcPct val="125000"/>
+              </a:lnSpc>
+              <a:spcAft>
+                <a:spcPts val="200"/>
+              </a:spcAft>
+            </a:pPr>
+            <a:r>
+              <a:rPr sz="780" b="0">
+                <a:solidFill>
+                  <a:srgbClr val="9AA8A2"/>
+                </a:solidFill>
+                <a:latin typeface="Microsoft YaHei"/>
+              </a:rPr>
+              <a:t>真值：</a:t>
+            </a:r>
+            <a:r>
+              <a:rPr sz="780" b="0">
+                <a:solidFill>
+                  <a:srgbClr val="1C2925"/>
+                </a:solidFill>
+                <a:latin typeface="Microsoft YaHei"/>
+              </a:rPr>
+              <a:t>fileUri = "https://…/very/long/path?token=…"</a:t>
+            </a:r>
+          </a:p>
+          <a:p>
+            <a:pPr algn="l">
+              <a:lnSpc>
+                <a:spcPct val="125000"/>
+              </a:lnSpc>
+              <a:spcAft>
+                <a:spcPts val="200"/>
+              </a:spcAft>
+            </a:pPr>
+            <a:r>
+              <a:rPr sz="780" b="0">
+                <a:solidFill>
+                  <a:srgbClr val="9AA8A2"/>
+                </a:solidFill>
+                <a:latin typeface="Microsoft YaHei"/>
+              </a:rPr>
+              <a:t>送模后：</a:t>
+            </a:r>
+            <a:r>
+              <a:rPr sz="780" b="1">
+                <a:solidFill>
+                  <a:srgbClr val="0B544E"/>
+                </a:solidFill>
+                <a:latin typeface="Microsoft YaHei"/>
+              </a:rPr>
+              <a:t>fileUri = ${a1b2c3d4.fileUri}</a:t>
+            </a:r>
+            <a:r>
+              <a:rPr sz="780" b="0">
                 <a:solidFill>
                   <a:srgbClr val="6B7A74"/>
                 </a:solidFill>
                 <a:latin typeface="Microsoft YaHei"/>
               </a:rPr>
-              <a:t>大结果不再回灌复述，输入与时延同降</a:t>
-            </a:r>
-          </a:p>
-        </p:txBody>
-      </p:sp>
-      <p:sp>
-        <p:nvSpPr>
-          <p:cNvPr id="57" name="TextBox 56"/>
+              <a:t>  ← 所见即所填</a:t>
+            </a:r>
+          </a:p>
+        </p:txBody>
+      </p:sp>
+      <p:sp>
+        <p:nvSpPr>
+          <p:cNvPr id="60" name="TextBox 59"/>
           <p:cNvSpPr txBox="1"/>
           <p:nvPr/>
         </p:nvSpPr>
         <p:spPr>
           <a:xfrm>
-            <a:off x="3331387" y="5998464"/>
-            <a:ext cx="2581579" cy="201168"/>
+            <a:off x="566928" y="5468112"/>
+            <a:ext cx="502920" cy="219456"/>
           </a:xfrm>
           <a:prstGeom prst="rect">
             <a:avLst/>
@@ -5548,25 +5711,25 @@
             <a:r>
               <a:rPr sz="1100" b="1">
                 <a:solidFill>
-                  <a:srgbClr val="0B544E"/>
-                </a:solidFill>
-                <a:latin typeface="Microsoft YaHei"/>
-              </a:rPr>
-              <a:t>抄不错</a:t>
-            </a:r>
-          </a:p>
-        </p:txBody>
-      </p:sp>
-      <p:sp>
-        <p:nvSpPr>
-          <p:cNvPr id="58" name="TextBox 57"/>
+                  <a:srgbClr val="0E6F66"/>
+                </a:solidFill>
+                <a:latin typeface="Microsoft YaHei"/>
+              </a:rPr>
+              <a:t>04</a:t>
+            </a:r>
+          </a:p>
+        </p:txBody>
+      </p:sp>
+      <p:sp>
+        <p:nvSpPr>
+          <p:cNvPr id="61" name="TextBox 60"/>
           <p:cNvSpPr txBox="1"/>
           <p:nvPr/>
         </p:nvSpPr>
         <p:spPr>
           <a:xfrm>
-            <a:off x="3331387" y="6217920"/>
-            <a:ext cx="2581579" cy="182880"/>
+            <a:off x="1042416" y="5454396"/>
+            <a:ext cx="3108960" cy="237744"/>
           </a:xfrm>
           <a:prstGeom prst="rect">
             <a:avLst/>
@@ -5588,27 +5751,27 @@
               </a:spcAft>
             </a:pPr>
             <a:r>
-              <a:rPr sz="850" b="0">
-                <a:solidFill>
-                  <a:srgbClr val="6B7A74"/>
-                </a:solidFill>
-                <a:latin typeface="Microsoft YaHei"/>
-              </a:rPr>
-              <a:t>真值不经模型之手，杜绝截断改写</a:t>
-            </a:r>
-          </a:p>
-        </p:txBody>
-      </p:sp>
-      <p:sp>
-        <p:nvSpPr>
-          <p:cNvPr id="59" name="TextBox 58"/>
+              <a:rPr sz="1250" b="1">
+                <a:solidFill>
+                  <a:srgbClr val="1C2925"/>
+                </a:solidFill>
+                <a:latin typeface="Microsoft YaHei"/>
+              </a:rPr>
+              <a:t>真值与保障</a:t>
+            </a:r>
+          </a:p>
+        </p:txBody>
+      </p:sp>
+      <p:sp>
+        <p:nvSpPr>
+          <p:cNvPr id="62" name="TextBox 61"/>
           <p:cNvSpPr txBox="1"/>
           <p:nvPr/>
         </p:nvSpPr>
         <p:spPr>
           <a:xfrm>
-            <a:off x="6095847" y="5998464"/>
-            <a:ext cx="2581579" cy="201168"/>
+            <a:off x="566928" y="5705856"/>
+            <a:ext cx="5300319" cy="548640"/>
           </a:xfrm>
           <a:prstGeom prst="rect">
             <a:avLst/>
@@ -5623,34 +5786,86 @@
           <a:p>
             <a:pPr algn="l">
               <a:lnSpc>
-                <a:spcPct val="115000"/>
+                <a:spcPct val="125000"/>
               </a:lnSpc>
               <a:spcAft>
                 <a:spcPts val="200"/>
               </a:spcAft>
             </a:pPr>
             <a:r>
-              <a:rPr sz="1100" b="1">
+              <a:rPr sz="900" b="1">
                 <a:solidFill>
                   <a:srgbClr val="0B544E"/>
                 </a:solidFill>
                 <a:latin typeface="Microsoft YaHei"/>
               </a:rPr>
-              <a:t>结构解耦</a:t>
-            </a:r>
-          </a:p>
-        </p:txBody>
-      </p:sp>
-      <p:sp>
-        <p:nvSpPr>
-          <p:cNvPr id="60" name="TextBox 59"/>
+              <a:t>真值从哪来、怎么变  </a:t>
+            </a:r>
+            <a:r>
+              <a:rPr sz="840" b="0">
+                <a:solidFill>
+                  <a:srgbClr val="1C2925"/>
+                </a:solidFill>
+                <a:latin typeface="Microsoft YaHei"/>
+              </a:rPr>
+              <a:t>只从工作记忆取（全量结果集→工具适配视图）；resultId 由 Runtime 生成并映射 toolCallId。结构不一致时按参数策略转换：[563,728] → [{"file_id":"563"},…]。</a:t>
+            </a:r>
+          </a:p>
+        </p:txBody>
+      </p:sp>
+      <p:sp>
+        <p:nvSpPr>
+          <p:cNvPr id="63" name="Rectangle 62"/>
+          <p:cNvSpPr/>
+          <p:nvPr/>
+        </p:nvSpPr>
+        <p:spPr>
+          <a:xfrm>
+            <a:off x="6095847" y="5724144"/>
+            <a:ext cx="9525" cy="475488"/>
+          </a:xfrm>
+          <a:prstGeom prst="rect">
+            <a:avLst/>
+          </a:prstGeom>
+          <a:solidFill>
+            <a:srgbClr val="DDE5E1"/>
+          </a:solidFill>
+          <a:ln>
+            <a:noFill/>
+          </a:ln>
+        </p:spPr>
+        <p:style>
+          <a:lnRef idx="1">
+            <a:schemeClr val="accent1"/>
+          </a:lnRef>
+          <a:fillRef idx="3">
+            <a:schemeClr val="accent1"/>
+          </a:fillRef>
+          <a:effectRef idx="2">
+            <a:schemeClr val="accent1"/>
+          </a:effectRef>
+          <a:fontRef idx="minor">
+            <a:schemeClr val="lt1"/>
+          </a:fontRef>
+        </p:style>
+        <p:txBody>
+          <a:bodyPr rtlCol="0" anchor="ctr"/>
+          <a:lstStyle/>
+          <a:p>
+            <a:pPr algn="ctr"/>
+          </a:p>
+        </p:txBody>
+      </p:sp>
+      <p:sp>
+        <p:nvSpPr>
+          <p:cNvPr id="64" name="TextBox 63"/>
           <p:cNvSpPr txBox="1"/>
           <p:nvPr/>
         </p:nvSpPr>
         <p:spPr>
           <a:xfrm>
-            <a:off x="6095847" y="6217920"/>
-            <a:ext cx="2581579" cy="182880"/>
+            <a:off x="6324447" y="5705856"/>
+            <a:ext cx="5300319" cy="548640"/>
           </a:xfrm>
           <a:prstGeom prst="rect">
             <a:avLst/>
@@ -5665,118 +5880,86 @@
           <a:p>
             <a:pPr algn="l">
               <a:lnSpc>
-                <a:spcPct val="115000"/>
+                <a:spcPct val="125000"/>
               </a:lnSpc>
               <a:spcAft>
                 <a:spcPts val="200"/>
               </a:spcAft>
             </a:pPr>
             <a:r>
-              <a:rPr sz="850" b="0">
-                <a:solidFill>
-                  <a:srgbClr val="6B7A74"/>
-                </a:solidFill>
-                <a:latin typeface="Microsoft YaHei"/>
-              </a:rPr>
-              <a:t>上下游 Schema 差异由策略转换消化</a:t>
-            </a:r>
-          </a:p>
-        </p:txBody>
-      </p:sp>
-      <p:sp>
-        <p:nvSpPr>
-          <p:cNvPr id="61" name="TextBox 60"/>
+              <a:rPr sz="900" b="1">
+                <a:solidFill>
+                  <a:srgbClr val="0B544E"/>
+                </a:solidFill>
+                <a:latin typeface="Microsoft YaHei"/>
+              </a:rPr>
+              <a:t>出错怎么办  </a:t>
+            </a:r>
+            <a:r>
+              <a:rPr sz="840" b="0">
+                <a:solidFill>
+                  <a:srgbClr val="1C2925"/>
+                </a:solidFill>
+                <a:latin typeface="Microsoft YaHei"/>
+              </a:rPr>
+              <a:t>解析失败、字段缺失、转换出错一律短路，${…} 绝不透传，错误回模型改写重试；结果带作用域与有效期，并行链路必须显式写 resultId。</a:t>
+            </a:r>
+          </a:p>
+        </p:txBody>
+      </p:sp>
+      <p:sp>
+        <p:nvSpPr>
+          <p:cNvPr id="65" name="Rectangle 64"/>
+          <p:cNvSpPr/>
+          <p:nvPr/>
+        </p:nvSpPr>
+        <p:spPr>
+          <a:xfrm>
+            <a:off x="566928" y="6309360"/>
+            <a:ext cx="11057839" cy="9525"/>
+          </a:xfrm>
+          <a:prstGeom prst="rect">
+            <a:avLst/>
+          </a:prstGeom>
+          <a:solidFill>
+            <a:srgbClr val="DDE5E1"/>
+          </a:solidFill>
+          <a:ln>
+            <a:noFill/>
+          </a:ln>
+        </p:spPr>
+        <p:style>
+          <a:lnRef idx="1">
+            <a:schemeClr val="accent1"/>
+          </a:lnRef>
+          <a:fillRef idx="3">
+            <a:schemeClr val="accent1"/>
+          </a:fillRef>
+          <a:effectRef idx="2">
+            <a:schemeClr val="accent1"/>
+          </a:effectRef>
+          <a:fontRef idx="minor">
+            <a:schemeClr val="lt1"/>
+          </a:fontRef>
+        </p:style>
+        <p:txBody>
+          <a:bodyPr rtlCol="0" anchor="ctr"/>
+          <a:lstStyle/>
+          <a:p>
+            <a:pPr algn="ctr"/>
+          </a:p>
+        </p:txBody>
+      </p:sp>
+      <p:sp>
+        <p:nvSpPr>
+          <p:cNvPr id="66" name="TextBox 65"/>
           <p:cNvSpPr txBox="1"/>
           <p:nvPr/>
         </p:nvSpPr>
         <p:spPr>
           <a:xfrm>
-            <a:off x="8860307" y="5998464"/>
-            <a:ext cx="2581579" cy="201168"/>
-          </a:xfrm>
-          <a:prstGeom prst="rect">
-            <a:avLst/>
-          </a:prstGeom>
-          <a:noFill/>
-        </p:spPr>
-        <p:txBody>
-          <a:bodyPr wrap="square" lIns="0" rIns="0" tIns="0" bIns="0">
-            <a:spAutoFit/>
-          </a:bodyPr>
-          <a:lstStyle/>
-          <a:p>
-            <a:pPr algn="l">
-              <a:lnSpc>
-                <a:spcPct val="115000"/>
-              </a:lnSpc>
-              <a:spcAft>
-                <a:spcPts val="200"/>
-              </a:spcAft>
-            </a:pPr>
-            <a:r>
-              <a:rPr sz="1100" b="1">
-                <a:solidFill>
-                  <a:srgbClr val="0B544E"/>
-                </a:solidFill>
-                <a:latin typeface="Microsoft YaHei"/>
-              </a:rPr>
-              <a:t>零改动</a:t>
-            </a:r>
-          </a:p>
-        </p:txBody>
-      </p:sp>
-      <p:sp>
-        <p:nvSpPr>
-          <p:cNvPr id="62" name="TextBox 61"/>
-          <p:cNvSpPr txBox="1"/>
-          <p:nvPr/>
-        </p:nvSpPr>
-        <p:spPr>
-          <a:xfrm>
-            <a:off x="8860307" y="6217920"/>
-            <a:ext cx="2581579" cy="182880"/>
-          </a:xfrm>
-          <a:prstGeom prst="rect">
-            <a:avLst/>
-          </a:prstGeom>
-          <a:noFill/>
-        </p:spPr>
-        <p:txBody>
-          <a:bodyPr wrap="square" lIns="0" rIns="0" tIns="0" bIns="0">
-            <a:spAutoFit/>
-          </a:bodyPr>
-          <a:lstStyle/>
-          <a:p>
-            <a:pPr algn="l">
-              <a:lnSpc>
-                <a:spcPct val="115000"/>
-              </a:lnSpc>
-              <a:spcAft>
-                <a:spcPts val="200"/>
-              </a:spcAft>
-            </a:pPr>
-            <a:r>
-              <a:rPr sz="850" b="0">
-                <a:solidFill>
-                  <a:srgbClr val="6B7A74"/>
-                </a:solidFill>
-                <a:latin typeface="Microsoft YaHei"/>
-              </a:rPr>
-              <a:t>能力在框架层，存量工具无感接入</a:t>
-            </a:r>
-          </a:p>
-        </p:txBody>
-      </p:sp>
-      <p:sp>
-        <p:nvSpPr>
-          <p:cNvPr id="63" name="TextBox 62"/>
-          <p:cNvSpPr txBox="1"/>
-          <p:nvPr/>
-        </p:nvSpPr>
-        <p:spPr>
-          <a:xfrm>
-            <a:off x="566928" y="6473952"/>
-            <a:ext cx="11057839" cy="237744"/>
+            <a:off x="566928" y="6419088"/>
+            <a:ext cx="11057839" cy="274320"/>
           </a:xfrm>
           <a:prstGeom prst="rect">
             <a:avLst/>
@@ -5798,13 +5981,76 @@
               </a:spcAft>
             </a:pPr>
             <a:r>
-              <a:rPr sz="1050" b="1">
-                <a:solidFill>
-                  <a:srgbClr val="1C2925"/>
-                </a:solidFill>
-                <a:latin typeface="Microsoft YaHei"/>
-              </a:rPr>
-              <a:t>模型决定「引用哪条结果的哪个字段」，Runtime 保证「真实、适配、合法」，然后才执行。</a:t>
+              <a:rPr sz="950" b="1">
+                <a:solidFill>
+                  <a:srgbClr val="0B544E"/>
+                </a:solidFill>
+                <a:latin typeface="Microsoft YaHei"/>
+              </a:rPr>
+              <a:t>省 Token</a:t>
+            </a:r>
+            <a:r>
+              <a:rPr sz="850" b="0">
+                <a:solidFill>
+                  <a:srgbClr val="6B7A74"/>
+                </a:solidFill>
+                <a:latin typeface="Microsoft YaHei"/>
+              </a:rPr>
+              <a:t>　大结果不再回灌复述　　</a:t>
+            </a:r>
+            <a:r>
+              <a:rPr sz="950" b="1">
+                <a:solidFill>
+                  <a:srgbClr val="0B544E"/>
+                </a:solidFill>
+                <a:latin typeface="Microsoft YaHei"/>
+              </a:rPr>
+              <a:t>抄不错</a:t>
+            </a:r>
+            <a:r>
+              <a:rPr sz="850" b="0">
+                <a:solidFill>
+                  <a:srgbClr val="6B7A74"/>
+                </a:solidFill>
+                <a:latin typeface="Microsoft YaHei"/>
+              </a:rPr>
+              <a:t>　真值不经模型之手　　</a:t>
+            </a:r>
+            <a:r>
+              <a:rPr sz="950" b="1">
+                <a:solidFill>
+                  <a:srgbClr val="0B544E"/>
+                </a:solidFill>
+                <a:latin typeface="Microsoft YaHei"/>
+              </a:rPr>
+              <a:t>结构解耦</a:t>
+            </a:r>
+            <a:r>
+              <a:rPr sz="850" b="0">
+                <a:solidFill>
+                  <a:srgbClr val="6B7A74"/>
+                </a:solidFill>
+                <a:latin typeface="Microsoft YaHei"/>
+              </a:rPr>
+              <a:t>　Schema差异由策略消化　　</a:t>
+            </a:r>
+            <a:r>
+              <a:rPr sz="950" b="1">
+                <a:solidFill>
+                  <a:srgbClr val="0B544E"/>
+                </a:solidFill>
+                <a:latin typeface="Microsoft YaHei"/>
+              </a:rPr>
+              <a:t>零改动</a:t>
+            </a:r>
+            <a:r>
+              <a:rPr sz="850" b="0">
+                <a:solidFill>
+                  <a:srgbClr val="6B7A74"/>
+                </a:solidFill>
+                <a:latin typeface="Microsoft YaHei"/>
+              </a:rPr>
+              <a:t>　存量工具无感接入</a:t>
             </a:r>
           </a:p>
         </p:txBody>

</xml_diff>